<commit_message>
Fold in Sysnet weekly extracts to 20 Sep and confirmed AI capture
Hardware QTD now runs to the real reporting week: $410k (57% of the
$715k OKR2) with a $37.6k gross week, and the member table carries
both extract weeks so the skipped WC 7 Sep deck is closed out. Flags
the $10.2k of hardware discounts this week (vs $2.2k prior), which
net the week to $27.4k.

The Sysnet feed is no longer lagged in the cutover register; the MRR
movement register, ValPay export and invoicing register remain the
outstanding post-cutover refreshes. AI usage drops its 'capture
pending' caveat and notes that Cowork zeros for engineers reflect
surface split, not inactivity.

Co-Authored-By: Claude Opus 5 <noreply@anthropic.com>
Claude-Session: https://claude.ai/code/session_019YTPNjRj34XzLPLC9gKxc4
</commit_message>
<xml_diff>
--- a/exec-deck/output/H&L Weekly Update - WC 14 Sep 2026.pptx
+++ b/exec-deck/output/H&L Weekly Update - WC 14 Sep 2026.pptx
@@ -4686,7 +4686,7 @@
                 <a:ea typeface="Poppins" pitchFamily="34" charset="-122"/>
                 <a:cs typeface="Poppins" pitchFamily="34" charset="-120"/>
               </a:rPr>
-              <a:t>Generated: 19 Sep 2026</a:t>
+              <a:t>Generated: 21 Sep 2026</a:t>
             </a:r>
             <a:endParaRPr lang="en-US" sz="1100" dirty="0"/>
           </a:p>
@@ -22506,7 +22506,7 @@
                 <a:ea typeface="Poppins" pitchFamily="34" charset="-122"/>
                 <a:cs typeface="Poppins" pitchFamily="34" charset="-120"/>
               </a:rPr>
-              <a:t>IT · capture 11 Sep — this week's capture pending</a:t>
+              <a:t>IT · weekly capture</a:t>
             </a:r>
             <a:endParaRPr lang="en-US" sz="1050" dirty="0"/>
           </a:p>
@@ -25692,7 +25692,7 @@
                 <a:ea typeface="Poppins" pitchFamily="34" charset="-122"/>
                 <a:cs typeface="Poppins" pitchFamily="34" charset="-120"/>
               </a:rPr>
-              <a:t>Capture lag: numbers are the 11 Sep Friday capture — the 18 Sep capture wasn't taken during cutover week; deltas resume next drop.</a:t>
+              <a:t>30-day Cowork sessions: engineering shows zeros (Hawraa, Chris, Eric, Tony, Brad, Nidhi, Rahul) — engineers live in Claude Code; Cowork is the ops/leadership surface.</a:t>
             </a:r>
             <a:endParaRPr lang="en-US" sz="900" dirty="0"/>
           </a:p>
@@ -25706,8 +25706,8 @@
         </p:nvSpPr>
         <p:spPr>
           <a:xfrm>
-            <a:off x="9202522" y="6510528"/>
-            <a:ext cx="2574950" cy="256032"/>
+            <a:off x="9326880" y="6510528"/>
+            <a:ext cx="2450592" cy="256032"/>
           </a:xfrm>
           <a:prstGeom prst="roundRect">
             <a:avLst>
@@ -25728,8 +25728,8 @@
         </p:nvSpPr>
         <p:spPr>
           <a:xfrm>
-            <a:off x="9202522" y="6510528"/>
-            <a:ext cx="2574950" cy="256032"/>
+            <a:off x="9326880" y="6510528"/>
+            <a:ext cx="2450592" cy="256032"/>
           </a:xfrm>
           <a:prstGeom prst="rect">
             <a:avLst/>
@@ -25753,7 +25753,7 @@
                 <a:ea typeface="Poppins" pitchFamily="34" charset="-122"/>
                 <a:cs typeface="Poppins" pitchFamily="34" charset="-120"/>
               </a:rPr>
-              <a:t>Source: Claude Admin (capture 11 Sep)</a:t>
+              <a:t>Source: Claude Admin weekly capture</a:t>
             </a:r>
             <a:endParaRPr lang="en-US" sz="700" dirty="0"/>
           </a:p>
@@ -30970,7 +30970,7 @@
             </a:avLst>
           </a:prstGeom>
           <a:solidFill>
-            <a:srgbClr val="C88A2E"/>
+            <a:srgbClr val="8CA0AC"/>
           </a:solidFill>
           <a:ln/>
           <a:effectLst>
@@ -31015,7 +31015,7 @@
                 <a:ea typeface="Poppins" pitchFamily="34" charset="-122"/>
                 <a:cs typeface="Poppins" pitchFamily="34" charset="-120"/>
               </a:rPr>
-              <a:t>LAGGED</a:t>
+              <a:t>AS BEFORE</a:t>
             </a:r>
             <a:endParaRPr lang="en-US" sz="850" dirty="0"/>
           </a:p>
@@ -31054,7 +31054,7 @@
                 <a:ea typeface="Poppins" pitchFamily="34" charset="-122"/>
                 <a:cs typeface="Poppins" pitchFamily="34" charset="-120"/>
               </a:rPr>
-              <a:t>Latest extract covers 7–13 Sep. Movement register (new-MRR line of record) refresh pending post-cutover.</a:t>
+              <a:t>Weekly extracts current to 20 Sep (received 21 Sep). Movement register (new-MRR line of record) refresh still pending.</a:t>
             </a:r>
             <a:endParaRPr lang="en-US" sz="730" dirty="0"/>
           </a:p>
@@ -31273,7 +31273,7 @@
                 <a:ea typeface="Poppins" pitchFamily="34" charset="-122"/>
                 <a:cs typeface="Poppins" pitchFamily="34" charset="-120"/>
               </a:rPr>
-              <a:t>GTM tracker current; Claude admin capture 11 Sep; ValPay export as at 6 Sep — weekly drop pending.</a:t>
+              <a:t>GTM tracker current; Claude admin weekly capture received; ValPay export as at 6 Sep — weekly drop pending.</a:t>
             </a:r>
             <a:endParaRPr lang="en-US" sz="730" dirty="0"/>
           </a:p>
@@ -31729,7 +31729,7 @@
                 <a:ea typeface="Poppins" pitchFamily="34" charset="-122"/>
                 <a:cs typeface="Poppins" pitchFamily="34" charset="-120"/>
               </a:rPr>
-              <a:t>hardware $373k = 52% of $715k vs 89% pace; extract week +$38k; new-MRR register refresh pending</a:t>
+              <a:t>hardware $410k = 57% of $715k vs 89% pace; this week +$38k gross (HW discounts -$10k); new-MRR register refresh pending</a:t>
             </a:r>
             <a:endParaRPr lang="en-US" sz="900" dirty="0"/>
           </a:p>
@@ -33501,7 +33501,7 @@
                 <a:ea typeface="Poppins" pitchFamily="34" charset="-122"/>
                 <a:cs typeface="Poppins" pitchFamily="34" charset="-120"/>
               </a:rPr>
-              <a:t>$373k</a:t>
+              <a:t>$410k</a:t>
             </a:r>
             <a:pPr indent="0" marL="0">
               <a:buNone/>
@@ -33554,7 +33554,7 @@
                 <a:ea typeface="Poppins" pitchFamily="34" charset="-122"/>
                 <a:cs typeface="Poppins" pitchFamily="34" charset="-120"/>
               </a:rPr>
-              <a:t>▲ +$38k extract wk</a:t>
+              <a:t>▲ +$38k this wk</a:t>
             </a:r>
             <a:endParaRPr lang="en-US" sz="950" dirty="0"/>
           </a:p>
@@ -33591,7 +33591,7 @@
         <p:spPr>
           <a:xfrm>
             <a:off x="6428232" y="1901952"/>
-            <a:ext cx="2187245" cy="100584"/>
+            <a:ext cx="2397557" cy="100584"/>
           </a:xfrm>
           <a:prstGeom prst="roundRect">
             <a:avLst>
@@ -33657,7 +33657,7 @@
                 <a:ea typeface="Poppins" pitchFamily="34" charset="-122"/>
                 <a:cs typeface="Poppins" pitchFamily="34" charset="-120"/>
               </a:rPr>
-              <a:t>52%</a:t>
+              <a:t>57%</a:t>
             </a:r>
             <a:pPr algn="r" indent="0" marL="0">
               <a:buNone/>
@@ -33807,7 +33807,7 @@
         <p:spPr>
           <a:xfrm>
             <a:off x="4617720" y="2724912"/>
-            <a:ext cx="3291840" cy="201168"/>
+            <a:ext cx="3383280" cy="201168"/>
           </a:xfrm>
           <a:prstGeom prst="rect">
             <a:avLst/>
@@ -33831,7 +33831,7 @@
                 <a:ea typeface="Poppins" pitchFamily="34" charset="-122"/>
                 <a:cs typeface="Poppins" pitchFamily="34" charset="-120"/>
               </a:rPr>
-              <a:t>HARDWARE ($/qtr) · incl. extract wk 7–13 Sep</a:t>
+              <a:t>HARDWARE ($/qtr) · extracts to 20 Sep · Δ wk = 14–20 Sep</a:t>
             </a:r>
             <a:endParaRPr lang="en-US" sz="800" dirty="0"/>
           </a:p>
@@ -34461,7 +34461,7 @@
                 <a:ea typeface="Poppins" pitchFamily="34" charset="-122"/>
                 <a:cs typeface="Poppins" pitchFamily="34" charset="-120"/>
               </a:rPr>
-              <a:t>$47k</a:t>
+              <a:t>$52k</a:t>
             </a:r>
             <a:endParaRPr lang="en-US" sz="850" dirty="0"/>
           </a:p>
@@ -34498,7 +34498,7 @@
         <p:spPr>
           <a:xfrm>
             <a:off x="6044184" y="3294126"/>
-            <a:ext cx="248717" cy="100584"/>
+            <a:ext cx="270662" cy="100584"/>
           </a:xfrm>
           <a:prstGeom prst="roundRect">
             <a:avLst>
@@ -34564,7 +34564,7 @@
                 <a:ea typeface="Poppins" pitchFamily="34" charset="-122"/>
                 <a:cs typeface="Poppins" pitchFamily="34" charset="-120"/>
               </a:rPr>
-              <a:t>34%</a:t>
+              <a:t>37%</a:t>
             </a:r>
             <a:endParaRPr lang="en-US" sz="800" dirty="0"/>
           </a:p>
@@ -34603,7 +34603,7 @@
                 <a:ea typeface="Poppins" pitchFamily="34" charset="-122"/>
                 <a:cs typeface="Poppins" pitchFamily="34" charset="-120"/>
               </a:rPr>
-              <a:t>+2k</a:t>
+              <a:t>+4k</a:t>
             </a:r>
             <a:endParaRPr lang="en-US" sz="850" dirty="0"/>
           </a:p>
@@ -34921,7 +34921,7 @@
                 <a:ea typeface="Poppins" pitchFamily="34" charset="-122"/>
                 <a:cs typeface="Poppins" pitchFamily="34" charset="-120"/>
               </a:rPr>
-              <a:t>$76k</a:t>
+              <a:t>$78k</a:t>
             </a:r>
             <a:endParaRPr lang="en-US" sz="850" dirty="0"/>
           </a:p>
@@ -34958,7 +34958,7 @@
         <p:spPr>
           <a:xfrm>
             <a:off x="6044184" y="3609594"/>
-            <a:ext cx="387706" cy="100584"/>
+            <a:ext cx="395021" cy="100584"/>
           </a:xfrm>
           <a:prstGeom prst="roundRect">
             <a:avLst>
@@ -35024,7 +35024,7 @@
                 <a:ea typeface="Poppins" pitchFamily="34" charset="-122"/>
                 <a:cs typeface="Poppins" pitchFamily="34" charset="-120"/>
               </a:rPr>
-              <a:t>53%</a:t>
+              <a:t>54%</a:t>
             </a:r>
             <a:endParaRPr lang="en-US" sz="800" dirty="0"/>
           </a:p>
@@ -35063,7 +35063,7 @@
                 <a:ea typeface="Poppins" pitchFamily="34" charset="-122"/>
                 <a:cs typeface="Poppins" pitchFamily="34" charset="-120"/>
               </a:rPr>
-              <a:t>+21k</a:t>
+              <a:t>+2k</a:t>
             </a:r>
             <a:endParaRPr lang="en-US" sz="850" dirty="0"/>
           </a:p>
@@ -35381,7 +35381,7 @@
                 <a:ea typeface="Poppins" pitchFamily="34" charset="-122"/>
                 <a:cs typeface="Poppins" pitchFamily="34" charset="-120"/>
               </a:rPr>
-              <a:t>$46k</a:t>
+              <a:t>$51k</a:t>
             </a:r>
             <a:endParaRPr lang="en-US" sz="850" dirty="0"/>
           </a:p>
@@ -35418,7 +35418,7 @@
         <p:spPr>
           <a:xfrm>
             <a:off x="6044184" y="3925062"/>
-            <a:ext cx="204826" cy="100584"/>
+            <a:ext cx="226771" cy="100584"/>
           </a:xfrm>
           <a:prstGeom prst="roundRect">
             <a:avLst>
@@ -35484,7 +35484,7 @@
                 <a:ea typeface="Poppins" pitchFamily="34" charset="-122"/>
                 <a:cs typeface="Poppins" pitchFamily="34" charset="-120"/>
               </a:rPr>
-              <a:t>28%</a:t>
+              <a:t>31%</a:t>
             </a:r>
             <a:endParaRPr lang="en-US" sz="800" dirty="0"/>
           </a:p>
@@ -35523,7 +35523,7 @@
                 <a:ea typeface="Poppins" pitchFamily="34" charset="-122"/>
                 <a:cs typeface="Poppins" pitchFamily="34" charset="-120"/>
               </a:rPr>
-              <a:t>+2k</a:t>
+              <a:t>+5k</a:t>
             </a:r>
             <a:endParaRPr lang="en-US" sz="850" dirty="0"/>
           </a:p>
@@ -35841,7 +35841,7 @@
                 <a:ea typeface="Poppins" pitchFamily="34" charset="-122"/>
                 <a:cs typeface="Poppins" pitchFamily="34" charset="-120"/>
               </a:rPr>
-              <a:t>$116k</a:t>
+              <a:t>$143k</a:t>
             </a:r>
             <a:endParaRPr lang="en-US" sz="850" dirty="0"/>
           </a:p>
@@ -35878,7 +35878,7 @@
         <p:spPr>
           <a:xfrm>
             <a:off x="6044184" y="4240530"/>
-            <a:ext cx="395021" cy="100584"/>
+            <a:ext cx="490118" cy="100584"/>
           </a:xfrm>
           <a:prstGeom prst="roundRect">
             <a:avLst>
@@ -35944,7 +35944,7 @@
                 <a:ea typeface="Poppins" pitchFamily="34" charset="-122"/>
                 <a:cs typeface="Poppins" pitchFamily="34" charset="-120"/>
               </a:rPr>
-              <a:t>54%</a:t>
+              <a:t>67%</a:t>
             </a:r>
             <a:endParaRPr lang="en-US" sz="800" dirty="0"/>
           </a:p>
@@ -35983,7 +35983,7 @@
                 <a:ea typeface="Poppins" pitchFamily="34" charset="-122"/>
                 <a:cs typeface="Poppins" pitchFamily="34" charset="-120"/>
               </a:rPr>
-              <a:t>+12k</a:t>
+              <a:t>+27k</a:t>
             </a:r>
             <a:endParaRPr lang="en-US" sz="850" dirty="0"/>
           </a:p>
@@ -36437,13 +36437,13 @@
             <a:r>
               <a:rPr lang="en-US" sz="850" b="1" dirty="0">
                 <a:solidFill>
-                  <a:srgbClr val="3D8F5F"/>
-                </a:solidFill>
-                <a:latin typeface="Poppins" pitchFamily="34" charset="0"/>
-                <a:ea typeface="Poppins" pitchFamily="34" charset="-122"/>
-                <a:cs typeface="Poppins" pitchFamily="34" charset="-120"/>
-              </a:rPr>
-              <a:t>+1k</a:t>
+                  <a:srgbClr val="8FA1AC"/>
+                </a:solidFill>
+                <a:latin typeface="Poppins" pitchFamily="34" charset="0"/>
+                <a:ea typeface="Poppins" pitchFamily="34" charset="-122"/>
+                <a:cs typeface="Poppins" pitchFamily="34" charset="-120"/>
+              </a:rPr>
+              <a:t>+0k</a:t>
             </a:r>
             <a:endParaRPr lang="en-US" sz="850" dirty="0"/>
           </a:p>
@@ -37450,7 +37450,7 @@
                 <a:ea typeface="Poppins" pitchFamily="34" charset="-122"/>
                 <a:cs typeface="Poppins" pitchFamily="34" charset="-120"/>
               </a:rPr>
-              <a:t>$373k</a:t>
+              <a:t>$410k</a:t>
             </a:r>
             <a:endParaRPr lang="en-US" sz="850" dirty="0"/>
           </a:p>
@@ -37489,7 +37489,7 @@
                 <a:ea typeface="Poppins" pitchFamily="34" charset="-122"/>
                 <a:cs typeface="Poppins" pitchFamily="34" charset="-120"/>
               </a:rPr>
-              <a:t>49%</a:t>
+              <a:t>54%</a:t>
             </a:r>
             <a:endParaRPr lang="en-US" sz="850" dirty="0"/>
           </a:p>
@@ -37688,7 +37688,7 @@
                 <a:ea typeface="Poppins" pitchFamily="34" charset="-122"/>
                 <a:cs typeface="Poppins" pitchFamily="34" charset="-120"/>
               </a:rPr>
-              <a:t>Hardware is $373k (52%) </a:t>
+              <a:t>Hardware is $410k (57%) </a:t>
             </a:r>
             <a:pPr indent="0" marL="0">
               <a:spcAft>
@@ -37705,7 +37705,7 @@
                 <a:ea typeface="Poppins" pitchFamily="34" charset="-122"/>
                 <a:cs typeface="Poppins" pitchFamily="34" charset="-120"/>
               </a:rPr>
-              <a:t>against an 89% pace mark. The 7–13 Sep extract added $38k — Brett +$21k, Jasmine +$12k.</a:t>
+              <a:t>against an 89% pace mark. This week's extract (14–20 Sep) added $38k gross — Jasmine +$27k, Bradford +$5k, Bjorn +$4k; the prior (7–13 Sep) week's $38k closed the skipped WC 7 Sep deck.</a:t>
             </a:r>
             <a:endParaRPr lang="en-US" sz="900" dirty="0"/>
           </a:p>
@@ -37736,7 +37736,7 @@
                 <a:ea typeface="Poppins" pitchFamily="34" charset="-122"/>
                 <a:cs typeface="Poppins" pitchFamily="34" charset="-120"/>
               </a:rPr>
-              <a:t>New MRR is the gap in this week's picture: </a:t>
+              <a:t>Watch the discounts: </a:t>
             </a:r>
             <a:pPr indent="0" marL="0">
               <a:spcAft>
@@ -37753,7 +37753,7 @@
                 <a:ea typeface="Poppins" pitchFamily="34" charset="-122"/>
                 <a:cs typeface="Poppins" pitchFamily="34" charset="-120"/>
               </a:rPr>
-              <a:t>the movement register (the line of record) hasn't run since 6 Sep. Extract shows $871 of new S/W subscription billing in 7–13 Sep — a different measure, shown for direction only.</a:t>
+              <a:t>hardware discounts ran -$10.2k this week (-$10.0k on Jasmine's deals) vs -$2.2k last week — gross $37.6k nets to $27.4k.</a:t>
             </a:r>
             <a:endParaRPr lang="en-US" sz="900" dirty="0"/>
           </a:p>
@@ -37784,7 +37784,7 @@
                 <a:ea typeface="Poppins" pitchFamily="34" charset="-122"/>
                 <a:cs typeface="Poppins" pitchFamily="34" charset="-120"/>
               </a:rPr>
-              <a:t>No extract yet for 14–20 Sep </a:t>
+              <a:t>New MRR is the remaining gap: </a:t>
             </a:r>
             <a:pPr indent="0" marL="0">
               <a:spcAft>
@@ -37801,7 +37801,7 @@
                 <a:ea typeface="Poppins" pitchFamily="34" charset="-122"/>
                 <a:cs typeface="Poppins" pitchFamily="34" charset="-120"/>
               </a:rPr>
-              <a:t>— Sysnet drop lands next week; this slide bridges the skipped WC 7 Sep deck.</a:t>
+              <a:t>the movement register (the line of record) hasn't rerun since 6 Sep; this week's extract shows a net -$148 S/W subscription movement (credits), a different measure shown for direction only.</a:t>
             </a:r>
             <a:endParaRPr lang="en-US" sz="900" dirty="0"/>
           </a:p>
@@ -37835,7 +37835,7 @@
                 <a:ea typeface="Poppins" pitchFamily="34" charset="-122"/>
                 <a:cs typeface="Poppins" pitchFamily="34" charset="-120"/>
               </a:rPr>
-              <a:t>HW = commissionable only · attainment = invoiced, never closed-won · pace = day 82 of 92 in Q3.</a:t>
+              <a:t>HW = commissionable only, gross of discounts · attainment = invoiced, never closed-won · pace = day 82 of 92 in Q3.</a:t>
             </a:r>
             <a:endParaRPr lang="en-US" sz="900" dirty="0"/>
           </a:p>
@@ -37849,8 +37849,8 @@
         </p:nvSpPr>
         <p:spPr>
           <a:xfrm>
-            <a:off x="6901891" y="6510528"/>
-            <a:ext cx="4875581" cy="256032"/>
+            <a:off x="7026250" y="6510528"/>
+            <a:ext cx="4751222" cy="256032"/>
           </a:xfrm>
           <a:prstGeom prst="roundRect">
             <a:avLst>
@@ -37871,8 +37871,8 @@
         </p:nvSpPr>
         <p:spPr>
           <a:xfrm>
-            <a:off x="6901891" y="6510528"/>
-            <a:ext cx="4875581" cy="256032"/>
+            <a:off x="7026250" y="6510528"/>
+            <a:ext cx="4751222" cy="256032"/>
           </a:xfrm>
           <a:prstGeom prst="rect">
             <a:avLst/>
@@ -37896,7 +37896,7 @@
                 <a:ea typeface="Poppins" pitchFamily="34" charset="-122"/>
                 <a:cs typeface="Poppins" pitchFamily="34" charset="-120"/>
               </a:rPr>
-              <a:t>Source: Sysnet extract 7–13 Sep + sales targets · register refresh pending</a:t>
+              <a:t>Source: Sysnet extracts to 20 Sep + sales targets · MRR register pending</a:t>
             </a:r>
             <a:endParaRPr lang="en-US" sz="700" dirty="0"/>
           </a:p>

</xml_diff>

<commit_message>
Utilisation slide: drop non-PS staff, replace target line with % axis
- Argenis Rafael Guevara and Isaac Mercado carry PS-pipeline tickets but
  are not Professional Services staff. Removed from the capacity base:
  13 people x 38h = 494h available (was 15 / 570h). Billed hours are
  unchanged at 33.01h since both logged nothing, so billable utilisation
  recalculates to 6.7%.
- Replaced the 80% target marker with a 0/20/40/60/80/100% axis along the
  top of the bar column, with light gridlines behind the rows.

Co-Authored-By: Claude Opus 5 <noreply@anthropic.com>
Claude-Session: https://claude.ai/code/session_019YTPNjRj34XzLPLC9gKxc4
</commit_message>
<xml_diff>
--- a/exec-deck/output/H&L Weekly Update - WC 14 Sep 2026.pptx
+++ b/exec-deck/output/H&L Weekly Update - WC 14 Sep 2026.pptx
@@ -46275,7 +46275,7 @@
                 <a:ea typeface="Poppins" pitchFamily="34" charset="-122"/>
                 <a:cs typeface="Poppins" pitchFamily="34" charset="-120"/>
               </a:rPr>
-              <a:t>5.8%</a:t>
+              <a:t>6.7%</a:t>
             </a:r>
             <a:endParaRPr lang="en-US" sz="2600" dirty="0"/>
           </a:p>
@@ -46314,7 +46314,7 @@
                 <a:ea typeface="Poppins" pitchFamily="34" charset="-122"/>
                 <a:cs typeface="Poppins" pitchFamily="34" charset="-120"/>
               </a:rPr>
-              <a:t>33.01h billed of 570h available · target 80%</a:t>
+              <a:t>33.01h billed of 494h available · target 80%</a:t>
             </a:r>
             <a:endParaRPr lang="en-US" sz="780" dirty="0"/>
           </a:p>
@@ -46421,7 +46421,7 @@
                 <a:ea typeface="Poppins" pitchFamily="34" charset="-122"/>
                 <a:cs typeface="Poppins" pitchFamily="34" charset="-120"/>
               </a:rPr>
-              <a:t>570h</a:t>
+              <a:t>494h</a:t>
             </a:r>
             <a:endParaRPr lang="en-US" sz="2600" dirty="0"/>
           </a:p>
@@ -46460,7 +46460,7 @@
                 <a:ea typeface="Poppins" pitchFamily="34" charset="-122"/>
                 <a:cs typeface="Poppins" pitchFamily="34" charset="-120"/>
               </a:rPr>
-              <a:t>15 people assigned to PS-pipeline tickets × 38h standard week</a:t>
+              <a:t>13 people assigned to PS-pipeline tickets × 38h standard week</a:t>
             </a:r>
             <a:endParaRPr lang="en-US" sz="780" dirty="0"/>
           </a:p>
@@ -46741,45 +46741,6 @@
         </p:nvSpPr>
         <p:spPr>
           <a:xfrm>
-            <a:off x="2468880" y="2834640"/>
-            <a:ext cx="2377440" cy="182880"/>
-          </a:xfrm>
-          <a:prstGeom prst="rect">
-            <a:avLst/>
-          </a:prstGeom>
-          <a:noFill/>
-          <a:ln/>
-        </p:spPr>
-        <p:txBody>
-          <a:bodyPr wrap="square" lIns="0" tIns="0" rIns="0" bIns="0" rtlCol="0" anchor="ctr"/>
-          <a:lstStyle/>
-          <a:p>
-            <a:pPr algn="l" indent="0" marL="0">
-              <a:buNone/>
-            </a:pPr>
-            <a:r>
-              <a:rPr lang="en-US" sz="700" b="1" dirty="0">
-                <a:solidFill>
-                  <a:srgbClr val="8FA1AC"/>
-                </a:solidFill>
-                <a:latin typeface="Poppins" pitchFamily="34" charset="0"/>
-                <a:ea typeface="Poppins" pitchFamily="34" charset="-122"/>
-                <a:cs typeface="Poppins" pitchFamily="34" charset="-120"/>
-              </a:rPr>
-              <a:t>UTILISATION OF 38h</a:t>
-            </a:r>
-            <a:endParaRPr lang="en-US" sz="700" dirty="0"/>
-          </a:p>
-        </p:txBody>
-      </p:sp>
-      <p:sp>
-        <p:nvSpPr>
-          <p:cNvPr id="31" name="Text 29"/>
-          <p:cNvSpPr txBox="1"/>
-          <p:nvPr/>
-        </p:nvSpPr>
-        <p:spPr>
-          <a:xfrm>
             <a:off x="5029200" y="2834640"/>
             <a:ext cx="822960" cy="182880"/>
           </a:xfrm>
@@ -46813,7 +46774,7 @@
       </p:sp>
       <p:sp>
         <p:nvSpPr>
-          <p:cNvPr id="32" name="Text 30"/>
+          <p:cNvPr id="31" name="Text 29"/>
           <p:cNvSpPr txBox="1"/>
           <p:nvPr/>
         </p:nvSpPr>
@@ -46852,14 +46813,348 @@
       </p:sp>
       <p:sp>
         <p:nvSpPr>
+          <p:cNvPr id="32" name="Text 30"/>
+          <p:cNvSpPr txBox="1"/>
+          <p:nvPr/>
+        </p:nvSpPr>
+        <p:spPr>
+          <a:xfrm>
+            <a:off x="2468880" y="2816352"/>
+            <a:ext cx="402336" cy="182880"/>
+          </a:xfrm>
+          <a:prstGeom prst="rect">
+            <a:avLst/>
+          </a:prstGeom>
+          <a:noFill/>
+          <a:ln/>
+        </p:spPr>
+        <p:txBody>
+          <a:bodyPr wrap="square" lIns="0" tIns="0" rIns="0" bIns="0" rtlCol="0" anchor="ctr"/>
+          <a:lstStyle/>
+          <a:p>
+            <a:pPr algn="l" indent="0" marL="0">
+              <a:buNone/>
+            </a:pPr>
+            <a:r>
+              <a:rPr lang="en-US" sz="650" b="1" dirty="0">
+                <a:solidFill>
+                  <a:srgbClr val="8FA1AC"/>
+                </a:solidFill>
+                <a:latin typeface="Poppins" pitchFamily="34" charset="0"/>
+                <a:ea typeface="Poppins" pitchFamily="34" charset="-122"/>
+                <a:cs typeface="Poppins" pitchFamily="34" charset="-120"/>
+              </a:rPr>
+              <a:t>0%</a:t>
+            </a:r>
+            <a:endParaRPr lang="en-US" sz="650" dirty="0"/>
+          </a:p>
+        </p:txBody>
+      </p:sp>
+      <p:sp>
+        <p:nvSpPr>
           <p:cNvPr id="33" name="Text 31"/>
           <p:cNvSpPr txBox="1"/>
           <p:nvPr/>
         </p:nvSpPr>
         <p:spPr>
           <a:xfrm>
-            <a:off x="640080" y="3035808"/>
-            <a:ext cx="1783080" cy="169164"/>
+            <a:off x="2743200" y="2816352"/>
+            <a:ext cx="402336" cy="182880"/>
+          </a:xfrm>
+          <a:prstGeom prst="rect">
+            <a:avLst/>
+          </a:prstGeom>
+          <a:noFill/>
+          <a:ln/>
+        </p:spPr>
+        <p:txBody>
+          <a:bodyPr wrap="square" lIns="0" tIns="0" rIns="0" bIns="0" rtlCol="0" anchor="ctr"/>
+          <a:lstStyle/>
+          <a:p>
+            <a:pPr algn="ctr" indent="0" marL="0">
+              <a:buNone/>
+            </a:pPr>
+            <a:r>
+              <a:rPr lang="en-US" sz="650" b="1" dirty="0">
+                <a:solidFill>
+                  <a:srgbClr val="8FA1AC"/>
+                </a:solidFill>
+                <a:latin typeface="Poppins" pitchFamily="34" charset="0"/>
+                <a:ea typeface="Poppins" pitchFamily="34" charset="-122"/>
+                <a:cs typeface="Poppins" pitchFamily="34" charset="-120"/>
+              </a:rPr>
+              <a:t>20%</a:t>
+            </a:r>
+            <a:endParaRPr lang="en-US" sz="650" dirty="0"/>
+          </a:p>
+        </p:txBody>
+      </p:sp>
+      <p:sp>
+        <p:nvSpPr>
+          <p:cNvPr id="34" name="Shape 32"/>
+          <p:cNvSpPr/>
+          <p:nvPr/>
+        </p:nvSpPr>
+        <p:spPr>
+          <a:xfrm>
+            <a:off x="2944368" y="3017520"/>
+            <a:ext cx="5486" cy="2496312"/>
+          </a:xfrm>
+          <a:prstGeom prst="rect">
+            <a:avLst/>
+          </a:prstGeom>
+          <a:solidFill>
+            <a:srgbClr val="E2EAEE"/>
+          </a:solidFill>
+          <a:ln/>
+        </p:spPr>
+      </p:sp>
+      <p:sp>
+        <p:nvSpPr>
+          <p:cNvPr id="35" name="Text 33"/>
+          <p:cNvSpPr txBox="1"/>
+          <p:nvPr/>
+        </p:nvSpPr>
+        <p:spPr>
+          <a:xfrm>
+            <a:off x="3218688" y="2816352"/>
+            <a:ext cx="402336" cy="182880"/>
+          </a:xfrm>
+          <a:prstGeom prst="rect">
+            <a:avLst/>
+          </a:prstGeom>
+          <a:noFill/>
+          <a:ln/>
+        </p:spPr>
+        <p:txBody>
+          <a:bodyPr wrap="square" lIns="0" tIns="0" rIns="0" bIns="0" rtlCol="0" anchor="ctr"/>
+          <a:lstStyle/>
+          <a:p>
+            <a:pPr algn="ctr" indent="0" marL="0">
+              <a:buNone/>
+            </a:pPr>
+            <a:r>
+              <a:rPr lang="en-US" sz="650" b="1" dirty="0">
+                <a:solidFill>
+                  <a:srgbClr val="8FA1AC"/>
+                </a:solidFill>
+                <a:latin typeface="Poppins" pitchFamily="34" charset="0"/>
+                <a:ea typeface="Poppins" pitchFamily="34" charset="-122"/>
+                <a:cs typeface="Poppins" pitchFamily="34" charset="-120"/>
+              </a:rPr>
+              <a:t>40%</a:t>
+            </a:r>
+            <a:endParaRPr lang="en-US" sz="650" dirty="0"/>
+          </a:p>
+        </p:txBody>
+      </p:sp>
+      <p:sp>
+        <p:nvSpPr>
+          <p:cNvPr id="36" name="Shape 34"/>
+          <p:cNvSpPr/>
+          <p:nvPr/>
+        </p:nvSpPr>
+        <p:spPr>
+          <a:xfrm>
+            <a:off x="3419856" y="3017520"/>
+            <a:ext cx="5486" cy="2496312"/>
+          </a:xfrm>
+          <a:prstGeom prst="rect">
+            <a:avLst/>
+          </a:prstGeom>
+          <a:solidFill>
+            <a:srgbClr val="E2EAEE"/>
+          </a:solidFill>
+          <a:ln/>
+        </p:spPr>
+      </p:sp>
+      <p:sp>
+        <p:nvSpPr>
+          <p:cNvPr id="37" name="Text 35"/>
+          <p:cNvSpPr txBox="1"/>
+          <p:nvPr/>
+        </p:nvSpPr>
+        <p:spPr>
+          <a:xfrm>
+            <a:off x="3694176" y="2816352"/>
+            <a:ext cx="402336" cy="182880"/>
+          </a:xfrm>
+          <a:prstGeom prst="rect">
+            <a:avLst/>
+          </a:prstGeom>
+          <a:noFill/>
+          <a:ln/>
+        </p:spPr>
+        <p:txBody>
+          <a:bodyPr wrap="square" lIns="0" tIns="0" rIns="0" bIns="0" rtlCol="0" anchor="ctr"/>
+          <a:lstStyle/>
+          <a:p>
+            <a:pPr algn="ctr" indent="0" marL="0">
+              <a:buNone/>
+            </a:pPr>
+            <a:r>
+              <a:rPr lang="en-US" sz="650" b="1" dirty="0">
+                <a:solidFill>
+                  <a:srgbClr val="8FA1AC"/>
+                </a:solidFill>
+                <a:latin typeface="Poppins" pitchFamily="34" charset="0"/>
+                <a:ea typeface="Poppins" pitchFamily="34" charset="-122"/>
+                <a:cs typeface="Poppins" pitchFamily="34" charset="-120"/>
+              </a:rPr>
+              <a:t>60%</a:t>
+            </a:r>
+            <a:endParaRPr lang="en-US" sz="650" dirty="0"/>
+          </a:p>
+        </p:txBody>
+      </p:sp>
+      <p:sp>
+        <p:nvSpPr>
+          <p:cNvPr id="38" name="Shape 36"/>
+          <p:cNvSpPr/>
+          <p:nvPr/>
+        </p:nvSpPr>
+        <p:spPr>
+          <a:xfrm>
+            <a:off x="3895344" y="3017520"/>
+            <a:ext cx="5486" cy="2496312"/>
+          </a:xfrm>
+          <a:prstGeom prst="rect">
+            <a:avLst/>
+          </a:prstGeom>
+          <a:solidFill>
+            <a:srgbClr val="E2EAEE"/>
+          </a:solidFill>
+          <a:ln/>
+        </p:spPr>
+      </p:sp>
+      <p:sp>
+        <p:nvSpPr>
+          <p:cNvPr id="39" name="Text 37"/>
+          <p:cNvSpPr txBox="1"/>
+          <p:nvPr/>
+        </p:nvSpPr>
+        <p:spPr>
+          <a:xfrm>
+            <a:off x="4169664" y="2816352"/>
+            <a:ext cx="402336" cy="182880"/>
+          </a:xfrm>
+          <a:prstGeom prst="rect">
+            <a:avLst/>
+          </a:prstGeom>
+          <a:noFill/>
+          <a:ln/>
+        </p:spPr>
+        <p:txBody>
+          <a:bodyPr wrap="square" lIns="0" tIns="0" rIns="0" bIns="0" rtlCol="0" anchor="ctr"/>
+          <a:lstStyle/>
+          <a:p>
+            <a:pPr algn="ctr" indent="0" marL="0">
+              <a:buNone/>
+            </a:pPr>
+            <a:r>
+              <a:rPr lang="en-US" sz="650" b="1" dirty="0">
+                <a:solidFill>
+                  <a:srgbClr val="8FA1AC"/>
+                </a:solidFill>
+                <a:latin typeface="Poppins" pitchFamily="34" charset="0"/>
+                <a:ea typeface="Poppins" pitchFamily="34" charset="-122"/>
+                <a:cs typeface="Poppins" pitchFamily="34" charset="-120"/>
+              </a:rPr>
+              <a:t>80%</a:t>
+            </a:r>
+            <a:endParaRPr lang="en-US" sz="650" dirty="0"/>
+          </a:p>
+        </p:txBody>
+      </p:sp>
+      <p:sp>
+        <p:nvSpPr>
+          <p:cNvPr id="40" name="Shape 38"/>
+          <p:cNvSpPr/>
+          <p:nvPr/>
+        </p:nvSpPr>
+        <p:spPr>
+          <a:xfrm>
+            <a:off x="4370832" y="3017520"/>
+            <a:ext cx="5486" cy="2496312"/>
+          </a:xfrm>
+          <a:prstGeom prst="rect">
+            <a:avLst/>
+          </a:prstGeom>
+          <a:solidFill>
+            <a:srgbClr val="E2EAEE"/>
+          </a:solidFill>
+          <a:ln/>
+        </p:spPr>
+      </p:sp>
+      <p:sp>
+        <p:nvSpPr>
+          <p:cNvPr id="41" name="Text 39"/>
+          <p:cNvSpPr txBox="1"/>
+          <p:nvPr/>
+        </p:nvSpPr>
+        <p:spPr>
+          <a:xfrm>
+            <a:off x="4443984" y="2816352"/>
+            <a:ext cx="402336" cy="182880"/>
+          </a:xfrm>
+          <a:prstGeom prst="rect">
+            <a:avLst/>
+          </a:prstGeom>
+          <a:noFill/>
+          <a:ln/>
+        </p:spPr>
+        <p:txBody>
+          <a:bodyPr wrap="square" lIns="0" tIns="0" rIns="0" bIns="0" rtlCol="0" anchor="ctr"/>
+          <a:lstStyle/>
+          <a:p>
+            <a:pPr algn="r" indent="0" marL="0">
+              <a:buNone/>
+            </a:pPr>
+            <a:r>
+              <a:rPr lang="en-US" sz="650" b="1" dirty="0">
+                <a:solidFill>
+                  <a:srgbClr val="8FA1AC"/>
+                </a:solidFill>
+                <a:latin typeface="Poppins" pitchFamily="34" charset="0"/>
+                <a:ea typeface="Poppins" pitchFamily="34" charset="-122"/>
+                <a:cs typeface="Poppins" pitchFamily="34" charset="-120"/>
+              </a:rPr>
+              <a:t>100%</a:t>
+            </a:r>
+            <a:endParaRPr lang="en-US" sz="650" dirty="0"/>
+          </a:p>
+        </p:txBody>
+      </p:sp>
+      <p:sp>
+        <p:nvSpPr>
+          <p:cNvPr id="42" name="Shape 40"/>
+          <p:cNvSpPr/>
+          <p:nvPr/>
+        </p:nvSpPr>
+        <p:spPr>
+          <a:xfrm>
+            <a:off x="4846320" y="3017520"/>
+            <a:ext cx="5486" cy="2496312"/>
+          </a:xfrm>
+          <a:prstGeom prst="rect">
+            <a:avLst/>
+          </a:prstGeom>
+          <a:solidFill>
+            <a:srgbClr val="E2EAEE"/>
+          </a:solidFill>
+          <a:ln/>
+        </p:spPr>
+      </p:sp>
+      <p:sp>
+        <p:nvSpPr>
+          <p:cNvPr id="43" name="Text 41"/>
+          <p:cNvSpPr txBox="1"/>
+          <p:nvPr/>
+        </p:nvSpPr>
+        <p:spPr>
+          <a:xfrm>
+            <a:off x="640080" y="3054096"/>
+            <a:ext cx="1783080" cy="192024"/>
           </a:xfrm>
           <a:prstGeom prst="rect">
             <a:avLst/>
@@ -46891,13 +47186,13 @@
       </p:sp>
       <p:sp>
         <p:nvSpPr>
-          <p:cNvPr id="34" name="Shape 32"/>
-          <p:cNvSpPr/>
-          <p:nvPr/>
-        </p:nvSpPr>
-        <p:spPr>
-          <a:xfrm>
-            <a:off x="2468880" y="3096158"/>
+          <p:cNvPr id="44" name="Shape 42"/>
+          <p:cNvSpPr/>
+          <p:nvPr/>
+        </p:nvSpPr>
+        <p:spPr>
+          <a:xfrm>
+            <a:off x="2468880" y="3120847"/>
             <a:ext cx="2377440" cy="59436"/>
           </a:xfrm>
           <a:prstGeom prst="roundRect">
@@ -46913,13 +47208,13 @@
       </p:sp>
       <p:sp>
         <p:nvSpPr>
-          <p:cNvPr id="35" name="Shape 33"/>
-          <p:cNvSpPr/>
-          <p:nvPr/>
-        </p:nvSpPr>
-        <p:spPr>
-          <a:xfrm>
-            <a:off x="2468880" y="3096158"/>
+          <p:cNvPr id="45" name="Shape 43"/>
+          <p:cNvSpPr/>
+          <p:nvPr/>
+        </p:nvSpPr>
+        <p:spPr>
+          <a:xfrm>
+            <a:off x="2468880" y="3120847"/>
             <a:ext cx="908182" cy="59436"/>
           </a:xfrm>
           <a:prstGeom prst="roundRect">
@@ -46935,14 +47230,14 @@
       </p:sp>
       <p:sp>
         <p:nvSpPr>
-          <p:cNvPr id="36" name="Text 34"/>
-          <p:cNvSpPr txBox="1"/>
-          <p:nvPr/>
-        </p:nvSpPr>
-        <p:spPr>
-          <a:xfrm>
-            <a:off x="5029200" y="3035808"/>
-            <a:ext cx="822960" cy="169164"/>
+          <p:cNvPr id="46" name="Text 44"/>
+          <p:cNvSpPr txBox="1"/>
+          <p:nvPr/>
+        </p:nvSpPr>
+        <p:spPr>
+          <a:xfrm>
+            <a:off x="5029200" y="3054096"/>
+            <a:ext cx="822960" cy="192024"/>
           </a:xfrm>
           <a:prstGeom prst="rect">
             <a:avLst/>
@@ -46974,14 +47269,14 @@
       </p:sp>
       <p:sp>
         <p:nvSpPr>
-          <p:cNvPr id="37" name="Text 35"/>
-          <p:cNvSpPr txBox="1"/>
-          <p:nvPr/>
-        </p:nvSpPr>
-        <p:spPr>
-          <a:xfrm>
-            <a:off x="5943600" y="3035808"/>
-            <a:ext cx="822960" cy="169164"/>
+          <p:cNvPr id="47" name="Text 45"/>
+          <p:cNvSpPr txBox="1"/>
+          <p:nvPr/>
+        </p:nvSpPr>
+        <p:spPr>
+          <a:xfrm>
+            <a:off x="5943600" y="3054096"/>
+            <a:ext cx="822960" cy="192024"/>
           </a:xfrm>
           <a:prstGeom prst="rect">
             <a:avLst/>
@@ -47013,14 +47308,14 @@
       </p:sp>
       <p:sp>
         <p:nvSpPr>
-          <p:cNvPr id="38" name="Text 36"/>
-          <p:cNvSpPr txBox="1"/>
-          <p:nvPr/>
-        </p:nvSpPr>
-        <p:spPr>
-          <a:xfrm>
-            <a:off x="640080" y="3204972"/>
-            <a:ext cx="1783080" cy="169164"/>
+          <p:cNvPr id="48" name="Text 46"/>
+          <p:cNvSpPr txBox="1"/>
+          <p:nvPr/>
+        </p:nvSpPr>
+        <p:spPr>
+          <a:xfrm>
+            <a:off x="640080" y="3246120"/>
+            <a:ext cx="1783080" cy="192024"/>
           </a:xfrm>
           <a:prstGeom prst="rect">
             <a:avLst/>
@@ -47052,13 +47347,13 @@
       </p:sp>
       <p:sp>
         <p:nvSpPr>
-          <p:cNvPr id="39" name="Shape 37"/>
-          <p:cNvSpPr/>
-          <p:nvPr/>
-        </p:nvSpPr>
-        <p:spPr>
-          <a:xfrm>
-            <a:off x="2468880" y="3265322"/>
+          <p:cNvPr id="49" name="Shape 47"/>
+          <p:cNvSpPr/>
+          <p:nvPr/>
+        </p:nvSpPr>
+        <p:spPr>
+          <a:xfrm>
+            <a:off x="2468880" y="3312871"/>
             <a:ext cx="2377440" cy="59436"/>
           </a:xfrm>
           <a:prstGeom prst="roundRect">
@@ -47074,13 +47369,13 @@
       </p:sp>
       <p:sp>
         <p:nvSpPr>
-          <p:cNvPr id="40" name="Shape 38"/>
-          <p:cNvSpPr/>
-          <p:nvPr/>
-        </p:nvSpPr>
-        <p:spPr>
-          <a:xfrm>
-            <a:off x="2468880" y="3265322"/>
+          <p:cNvPr id="50" name="Shape 48"/>
+          <p:cNvSpPr/>
+          <p:nvPr/>
+        </p:nvSpPr>
+        <p:spPr>
+          <a:xfrm>
+            <a:off x="2468880" y="3312871"/>
             <a:ext cx="865388" cy="59436"/>
           </a:xfrm>
           <a:prstGeom prst="roundRect">
@@ -47096,14 +47391,14 @@
       </p:sp>
       <p:sp>
         <p:nvSpPr>
-          <p:cNvPr id="41" name="Text 39"/>
-          <p:cNvSpPr txBox="1"/>
-          <p:nvPr/>
-        </p:nvSpPr>
-        <p:spPr>
-          <a:xfrm>
-            <a:off x="5029200" y="3204972"/>
-            <a:ext cx="822960" cy="169164"/>
+          <p:cNvPr id="51" name="Text 49"/>
+          <p:cNvSpPr txBox="1"/>
+          <p:nvPr/>
+        </p:nvSpPr>
+        <p:spPr>
+          <a:xfrm>
+            <a:off x="5029200" y="3246120"/>
+            <a:ext cx="822960" cy="192024"/>
           </a:xfrm>
           <a:prstGeom prst="rect">
             <a:avLst/>
@@ -47135,14 +47430,14 @@
       </p:sp>
       <p:sp>
         <p:nvSpPr>
-          <p:cNvPr id="42" name="Text 40"/>
-          <p:cNvSpPr txBox="1"/>
-          <p:nvPr/>
-        </p:nvSpPr>
-        <p:spPr>
-          <a:xfrm>
-            <a:off x="5943600" y="3204972"/>
-            <a:ext cx="822960" cy="169164"/>
+          <p:cNvPr id="52" name="Text 50"/>
+          <p:cNvSpPr txBox="1"/>
+          <p:nvPr/>
+        </p:nvSpPr>
+        <p:spPr>
+          <a:xfrm>
+            <a:off x="5943600" y="3246120"/>
+            <a:ext cx="822960" cy="192024"/>
           </a:xfrm>
           <a:prstGeom prst="rect">
             <a:avLst/>
@@ -47174,14 +47469,14 @@
       </p:sp>
       <p:sp>
         <p:nvSpPr>
-          <p:cNvPr id="43" name="Text 41"/>
-          <p:cNvSpPr txBox="1"/>
-          <p:nvPr/>
-        </p:nvSpPr>
-        <p:spPr>
-          <a:xfrm>
-            <a:off x="640080" y="3374136"/>
-            <a:ext cx="1783080" cy="169164"/>
+          <p:cNvPr id="53" name="Text 51"/>
+          <p:cNvSpPr txBox="1"/>
+          <p:nvPr/>
+        </p:nvSpPr>
+        <p:spPr>
+          <a:xfrm>
+            <a:off x="640080" y="3438144"/>
+            <a:ext cx="1783080" cy="192024"/>
           </a:xfrm>
           <a:prstGeom prst="rect">
             <a:avLst/>
@@ -47213,13 +47508,13 @@
       </p:sp>
       <p:sp>
         <p:nvSpPr>
-          <p:cNvPr id="44" name="Shape 42"/>
-          <p:cNvSpPr/>
-          <p:nvPr/>
-        </p:nvSpPr>
-        <p:spPr>
-          <a:xfrm>
-            <a:off x="2468880" y="3434486"/>
+          <p:cNvPr id="54" name="Shape 52"/>
+          <p:cNvSpPr/>
+          <p:nvPr/>
+        </p:nvSpPr>
+        <p:spPr>
+          <a:xfrm>
+            <a:off x="2468880" y="3504895"/>
             <a:ext cx="2377440" cy="59436"/>
           </a:xfrm>
           <a:prstGeom prst="roundRect">
@@ -47235,13 +47530,13 @@
       </p:sp>
       <p:sp>
         <p:nvSpPr>
-          <p:cNvPr id="45" name="Shape 43"/>
-          <p:cNvSpPr/>
-          <p:nvPr/>
-        </p:nvSpPr>
-        <p:spPr>
-          <a:xfrm>
-            <a:off x="2468880" y="3434486"/>
+          <p:cNvPr id="55" name="Shape 53"/>
+          <p:cNvSpPr/>
+          <p:nvPr/>
+        </p:nvSpPr>
+        <p:spPr>
+          <a:xfrm>
+            <a:off x="2468880" y="3504895"/>
             <a:ext cx="152156" cy="59436"/>
           </a:xfrm>
           <a:prstGeom prst="roundRect">
@@ -47257,14 +47552,14 @@
       </p:sp>
       <p:sp>
         <p:nvSpPr>
-          <p:cNvPr id="46" name="Text 44"/>
-          <p:cNvSpPr txBox="1"/>
-          <p:nvPr/>
-        </p:nvSpPr>
-        <p:spPr>
-          <a:xfrm>
-            <a:off x="5029200" y="3374136"/>
-            <a:ext cx="822960" cy="169164"/>
+          <p:cNvPr id="56" name="Text 54"/>
+          <p:cNvSpPr txBox="1"/>
+          <p:nvPr/>
+        </p:nvSpPr>
+        <p:spPr>
+          <a:xfrm>
+            <a:off x="5029200" y="3438144"/>
+            <a:ext cx="822960" cy="192024"/>
           </a:xfrm>
           <a:prstGeom prst="rect">
             <a:avLst/>
@@ -47296,14 +47591,14 @@
       </p:sp>
       <p:sp>
         <p:nvSpPr>
-          <p:cNvPr id="47" name="Text 45"/>
-          <p:cNvSpPr txBox="1"/>
-          <p:nvPr/>
-        </p:nvSpPr>
-        <p:spPr>
-          <a:xfrm>
-            <a:off x="5943600" y="3374136"/>
-            <a:ext cx="822960" cy="169164"/>
+          <p:cNvPr id="57" name="Text 55"/>
+          <p:cNvSpPr txBox="1"/>
+          <p:nvPr/>
+        </p:nvSpPr>
+        <p:spPr>
+          <a:xfrm>
+            <a:off x="5943600" y="3438144"/>
+            <a:ext cx="822960" cy="192024"/>
           </a:xfrm>
           <a:prstGeom prst="rect">
             <a:avLst/>
@@ -47335,14 +47630,14 @@
       </p:sp>
       <p:sp>
         <p:nvSpPr>
-          <p:cNvPr id="48" name="Text 46"/>
-          <p:cNvSpPr txBox="1"/>
-          <p:nvPr/>
-        </p:nvSpPr>
-        <p:spPr>
-          <a:xfrm>
-            <a:off x="640080" y="3543300"/>
-            <a:ext cx="1783080" cy="169164"/>
+          <p:cNvPr id="58" name="Text 56"/>
+          <p:cNvSpPr txBox="1"/>
+          <p:nvPr/>
+        </p:nvSpPr>
+        <p:spPr>
+          <a:xfrm>
+            <a:off x="640080" y="3630168"/>
+            <a:ext cx="1783080" cy="192024"/>
           </a:xfrm>
           <a:prstGeom prst="rect">
             <a:avLst/>
@@ -47374,13 +47669,13 @@
       </p:sp>
       <p:sp>
         <p:nvSpPr>
-          <p:cNvPr id="49" name="Shape 47"/>
-          <p:cNvSpPr/>
-          <p:nvPr/>
-        </p:nvSpPr>
-        <p:spPr>
-          <a:xfrm>
-            <a:off x="2468880" y="3603650"/>
+          <p:cNvPr id="59" name="Shape 57"/>
+          <p:cNvSpPr/>
+          <p:nvPr/>
+        </p:nvSpPr>
+        <p:spPr>
+          <a:xfrm>
+            <a:off x="2468880" y="3696919"/>
             <a:ext cx="2377440" cy="59436"/>
           </a:xfrm>
           <a:prstGeom prst="roundRect">
@@ -47396,13 +47691,13 @@
       </p:sp>
       <p:sp>
         <p:nvSpPr>
-          <p:cNvPr id="50" name="Shape 48"/>
-          <p:cNvSpPr/>
-          <p:nvPr/>
-        </p:nvSpPr>
-        <p:spPr>
-          <a:xfrm>
-            <a:off x="2468880" y="3603650"/>
+          <p:cNvPr id="60" name="Shape 58"/>
+          <p:cNvSpPr/>
+          <p:nvPr/>
+        </p:nvSpPr>
+        <p:spPr>
+          <a:xfrm>
+            <a:off x="2468880" y="3696919"/>
             <a:ext cx="92720" cy="59436"/>
           </a:xfrm>
           <a:prstGeom prst="roundRect">
@@ -47418,14 +47713,14 @@
       </p:sp>
       <p:sp>
         <p:nvSpPr>
-          <p:cNvPr id="51" name="Text 49"/>
-          <p:cNvSpPr txBox="1"/>
-          <p:nvPr/>
-        </p:nvSpPr>
-        <p:spPr>
-          <a:xfrm>
-            <a:off x="5029200" y="3543300"/>
-            <a:ext cx="822960" cy="169164"/>
+          <p:cNvPr id="61" name="Text 59"/>
+          <p:cNvSpPr txBox="1"/>
+          <p:nvPr/>
+        </p:nvSpPr>
+        <p:spPr>
+          <a:xfrm>
+            <a:off x="5029200" y="3630168"/>
+            <a:ext cx="822960" cy="192024"/>
           </a:xfrm>
           <a:prstGeom prst="rect">
             <a:avLst/>
@@ -47457,14 +47752,14 @@
       </p:sp>
       <p:sp>
         <p:nvSpPr>
-          <p:cNvPr id="52" name="Text 50"/>
-          <p:cNvSpPr txBox="1"/>
-          <p:nvPr/>
-        </p:nvSpPr>
-        <p:spPr>
-          <a:xfrm>
-            <a:off x="5943600" y="3543300"/>
-            <a:ext cx="822960" cy="169164"/>
+          <p:cNvPr id="62" name="Text 60"/>
+          <p:cNvSpPr txBox="1"/>
+          <p:nvPr/>
+        </p:nvSpPr>
+        <p:spPr>
+          <a:xfrm>
+            <a:off x="5943600" y="3630168"/>
+            <a:ext cx="822960" cy="192024"/>
           </a:xfrm>
           <a:prstGeom prst="rect">
             <a:avLst/>
@@ -47496,14 +47791,14 @@
       </p:sp>
       <p:sp>
         <p:nvSpPr>
-          <p:cNvPr id="53" name="Text 51"/>
-          <p:cNvSpPr txBox="1"/>
-          <p:nvPr/>
-        </p:nvSpPr>
-        <p:spPr>
-          <a:xfrm>
-            <a:off x="640080" y="3712464"/>
-            <a:ext cx="1783080" cy="169164"/>
+          <p:cNvPr id="63" name="Text 61"/>
+          <p:cNvSpPr txBox="1"/>
+          <p:nvPr/>
+        </p:nvSpPr>
+        <p:spPr>
+          <a:xfrm>
+            <a:off x="640080" y="3822192"/>
+            <a:ext cx="1783080" cy="192024"/>
           </a:xfrm>
           <a:prstGeom prst="rect">
             <a:avLst/>
@@ -47535,13 +47830,13 @@
       </p:sp>
       <p:sp>
         <p:nvSpPr>
-          <p:cNvPr id="54" name="Shape 52"/>
-          <p:cNvSpPr/>
-          <p:nvPr/>
-        </p:nvSpPr>
-        <p:spPr>
-          <a:xfrm>
-            <a:off x="2468880" y="3772814"/>
+          <p:cNvPr id="64" name="Shape 62"/>
+          <p:cNvSpPr/>
+          <p:nvPr/>
+        </p:nvSpPr>
+        <p:spPr>
+          <a:xfrm>
+            <a:off x="2468880" y="3888943"/>
             <a:ext cx="2377440" cy="59436"/>
           </a:xfrm>
           <a:prstGeom prst="roundRect">
@@ -47557,13 +47852,13 @@
       </p:sp>
       <p:sp>
         <p:nvSpPr>
-          <p:cNvPr id="55" name="Shape 53"/>
-          <p:cNvSpPr/>
-          <p:nvPr/>
-        </p:nvSpPr>
-        <p:spPr>
-          <a:xfrm>
-            <a:off x="2468880" y="3772814"/>
+          <p:cNvPr id="65" name="Shape 63"/>
+          <p:cNvSpPr/>
+          <p:nvPr/>
+        </p:nvSpPr>
+        <p:spPr>
+          <a:xfrm>
+            <a:off x="2468880" y="3888943"/>
             <a:ext cx="45720" cy="59436"/>
           </a:xfrm>
           <a:prstGeom prst="roundRect">
@@ -47579,14 +47874,14 @@
       </p:sp>
       <p:sp>
         <p:nvSpPr>
-          <p:cNvPr id="56" name="Text 54"/>
-          <p:cNvSpPr txBox="1"/>
-          <p:nvPr/>
-        </p:nvSpPr>
-        <p:spPr>
-          <a:xfrm>
-            <a:off x="5029200" y="3712464"/>
-            <a:ext cx="822960" cy="169164"/>
+          <p:cNvPr id="66" name="Text 64"/>
+          <p:cNvSpPr txBox="1"/>
+          <p:nvPr/>
+        </p:nvSpPr>
+        <p:spPr>
+          <a:xfrm>
+            <a:off x="5029200" y="3822192"/>
+            <a:ext cx="822960" cy="192024"/>
           </a:xfrm>
           <a:prstGeom prst="rect">
             <a:avLst/>
@@ -47618,14 +47913,14 @@
       </p:sp>
       <p:sp>
         <p:nvSpPr>
-          <p:cNvPr id="57" name="Text 55"/>
-          <p:cNvSpPr txBox="1"/>
-          <p:nvPr/>
-        </p:nvSpPr>
-        <p:spPr>
-          <a:xfrm>
-            <a:off x="5943600" y="3712464"/>
-            <a:ext cx="822960" cy="169164"/>
+          <p:cNvPr id="67" name="Text 65"/>
+          <p:cNvSpPr txBox="1"/>
+          <p:nvPr/>
+        </p:nvSpPr>
+        <p:spPr>
+          <a:xfrm>
+            <a:off x="5943600" y="3822192"/>
+            <a:ext cx="822960" cy="192024"/>
           </a:xfrm>
           <a:prstGeom prst="rect">
             <a:avLst/>
@@ -47657,14 +47952,14 @@
       </p:sp>
       <p:sp>
         <p:nvSpPr>
-          <p:cNvPr id="58" name="Text 56"/>
-          <p:cNvSpPr txBox="1"/>
-          <p:nvPr/>
-        </p:nvSpPr>
-        <p:spPr>
-          <a:xfrm>
-            <a:off x="640080" y="3881628"/>
-            <a:ext cx="1783080" cy="169164"/>
+          <p:cNvPr id="68" name="Text 66"/>
+          <p:cNvSpPr txBox="1"/>
+          <p:nvPr/>
+        </p:nvSpPr>
+        <p:spPr>
+          <a:xfrm>
+            <a:off x="640080" y="4014216"/>
+            <a:ext cx="1783080" cy="192024"/>
           </a:xfrm>
           <a:prstGeom prst="rect">
             <a:avLst/>
@@ -47696,13 +47991,13 @@
       </p:sp>
       <p:sp>
         <p:nvSpPr>
-          <p:cNvPr id="59" name="Shape 57"/>
-          <p:cNvSpPr/>
-          <p:nvPr/>
-        </p:nvSpPr>
-        <p:spPr>
-          <a:xfrm>
-            <a:off x="2468880" y="3941978"/>
+          <p:cNvPr id="69" name="Shape 67"/>
+          <p:cNvSpPr/>
+          <p:nvPr/>
+        </p:nvSpPr>
+        <p:spPr>
+          <a:xfrm>
+            <a:off x="2468880" y="4080967"/>
             <a:ext cx="2377440" cy="59436"/>
           </a:xfrm>
           <a:prstGeom prst="roundRect">
@@ -47718,13 +48013,13 @@
       </p:sp>
       <p:sp>
         <p:nvSpPr>
-          <p:cNvPr id="60" name="Shape 58"/>
-          <p:cNvSpPr/>
-          <p:nvPr/>
-        </p:nvSpPr>
-        <p:spPr>
-          <a:xfrm>
-            <a:off x="2468880" y="3941978"/>
+          <p:cNvPr id="70" name="Shape 68"/>
+          <p:cNvSpPr/>
+          <p:nvPr/>
+        </p:nvSpPr>
+        <p:spPr>
+          <a:xfrm>
+            <a:off x="2468880" y="4080967"/>
             <a:ext cx="45720" cy="59436"/>
           </a:xfrm>
           <a:prstGeom prst="roundRect">
@@ -47740,14 +48035,14 @@
       </p:sp>
       <p:sp>
         <p:nvSpPr>
-          <p:cNvPr id="61" name="Text 59"/>
-          <p:cNvSpPr txBox="1"/>
-          <p:nvPr/>
-        </p:nvSpPr>
-        <p:spPr>
-          <a:xfrm>
-            <a:off x="5029200" y="3881628"/>
-            <a:ext cx="822960" cy="169164"/>
+          <p:cNvPr id="71" name="Text 69"/>
+          <p:cNvSpPr txBox="1"/>
+          <p:nvPr/>
+        </p:nvSpPr>
+        <p:spPr>
+          <a:xfrm>
+            <a:off x="5029200" y="4014216"/>
+            <a:ext cx="822960" cy="192024"/>
           </a:xfrm>
           <a:prstGeom prst="rect">
             <a:avLst/>
@@ -47779,14 +48074,14 @@
       </p:sp>
       <p:sp>
         <p:nvSpPr>
-          <p:cNvPr id="62" name="Text 60"/>
-          <p:cNvSpPr txBox="1"/>
-          <p:nvPr/>
-        </p:nvSpPr>
-        <p:spPr>
-          <a:xfrm>
-            <a:off x="5943600" y="3881628"/>
-            <a:ext cx="822960" cy="169164"/>
+          <p:cNvPr id="72" name="Text 70"/>
+          <p:cNvSpPr txBox="1"/>
+          <p:nvPr/>
+        </p:nvSpPr>
+        <p:spPr>
+          <a:xfrm>
+            <a:off x="5943600" y="4014216"/>
+            <a:ext cx="822960" cy="192024"/>
           </a:xfrm>
           <a:prstGeom prst="rect">
             <a:avLst/>
@@ -47818,14 +48113,14 @@
       </p:sp>
       <p:sp>
         <p:nvSpPr>
-          <p:cNvPr id="63" name="Text 61"/>
-          <p:cNvSpPr txBox="1"/>
-          <p:nvPr/>
-        </p:nvSpPr>
-        <p:spPr>
-          <a:xfrm>
-            <a:off x="640080" y="4050792"/>
-            <a:ext cx="1783080" cy="169164"/>
+          <p:cNvPr id="73" name="Text 71"/>
+          <p:cNvSpPr txBox="1"/>
+          <p:nvPr/>
+        </p:nvSpPr>
+        <p:spPr>
+          <a:xfrm>
+            <a:off x="640080" y="4206240"/>
+            <a:ext cx="1783080" cy="192024"/>
           </a:xfrm>
           <a:prstGeom prst="rect">
             <a:avLst/>
@@ -47857,13 +48152,13 @@
       </p:sp>
       <p:sp>
         <p:nvSpPr>
-          <p:cNvPr id="64" name="Shape 62"/>
-          <p:cNvSpPr/>
-          <p:nvPr/>
-        </p:nvSpPr>
-        <p:spPr>
-          <a:xfrm>
-            <a:off x="2468880" y="4111142"/>
+          <p:cNvPr id="74" name="Shape 72"/>
+          <p:cNvSpPr/>
+          <p:nvPr/>
+        </p:nvSpPr>
+        <p:spPr>
+          <a:xfrm>
+            <a:off x="2468880" y="4272991"/>
             <a:ext cx="2377440" cy="59436"/>
           </a:xfrm>
           <a:prstGeom prst="roundRect">
@@ -47879,14 +48174,14 @@
       </p:sp>
       <p:sp>
         <p:nvSpPr>
-          <p:cNvPr id="65" name="Text 63"/>
-          <p:cNvSpPr txBox="1"/>
-          <p:nvPr/>
-        </p:nvSpPr>
-        <p:spPr>
-          <a:xfrm>
-            <a:off x="5029200" y="4050792"/>
-            <a:ext cx="822960" cy="169164"/>
+          <p:cNvPr id="75" name="Text 73"/>
+          <p:cNvSpPr txBox="1"/>
+          <p:nvPr/>
+        </p:nvSpPr>
+        <p:spPr>
+          <a:xfrm>
+            <a:off x="5029200" y="4206240"/>
+            <a:ext cx="822960" cy="192024"/>
           </a:xfrm>
           <a:prstGeom prst="rect">
             <a:avLst/>
@@ -47918,14 +48213,14 @@
       </p:sp>
       <p:sp>
         <p:nvSpPr>
-          <p:cNvPr id="66" name="Text 64"/>
-          <p:cNvSpPr txBox="1"/>
-          <p:nvPr/>
-        </p:nvSpPr>
-        <p:spPr>
-          <a:xfrm>
-            <a:off x="5943600" y="4050792"/>
-            <a:ext cx="822960" cy="169164"/>
+          <p:cNvPr id="76" name="Text 74"/>
+          <p:cNvSpPr txBox="1"/>
+          <p:nvPr/>
+        </p:nvSpPr>
+        <p:spPr>
+          <a:xfrm>
+            <a:off x="5943600" y="4206240"/>
+            <a:ext cx="822960" cy="192024"/>
           </a:xfrm>
           <a:prstGeom prst="rect">
             <a:avLst/>
@@ -47957,14 +48252,14 @@
       </p:sp>
       <p:sp>
         <p:nvSpPr>
-          <p:cNvPr id="67" name="Text 65"/>
-          <p:cNvSpPr txBox="1"/>
-          <p:nvPr/>
-        </p:nvSpPr>
-        <p:spPr>
-          <a:xfrm>
-            <a:off x="640080" y="4219956"/>
-            <a:ext cx="1783080" cy="169164"/>
+          <p:cNvPr id="77" name="Text 75"/>
+          <p:cNvSpPr txBox="1"/>
+          <p:nvPr/>
+        </p:nvSpPr>
+        <p:spPr>
+          <a:xfrm>
+            <a:off x="640080" y="4398264"/>
+            <a:ext cx="1783080" cy="192024"/>
           </a:xfrm>
           <a:prstGeom prst="rect">
             <a:avLst/>
@@ -47996,13 +48291,13 @@
       </p:sp>
       <p:sp>
         <p:nvSpPr>
-          <p:cNvPr id="68" name="Shape 66"/>
-          <p:cNvSpPr/>
-          <p:nvPr/>
-        </p:nvSpPr>
-        <p:spPr>
-          <a:xfrm>
-            <a:off x="2468880" y="4280306"/>
+          <p:cNvPr id="78" name="Shape 76"/>
+          <p:cNvSpPr/>
+          <p:nvPr/>
+        </p:nvSpPr>
+        <p:spPr>
+          <a:xfrm>
+            <a:off x="2468880" y="4465015"/>
             <a:ext cx="2377440" cy="59436"/>
           </a:xfrm>
           <a:prstGeom prst="roundRect">
@@ -48018,14 +48313,14 @@
       </p:sp>
       <p:sp>
         <p:nvSpPr>
-          <p:cNvPr id="69" name="Text 67"/>
-          <p:cNvSpPr txBox="1"/>
-          <p:nvPr/>
-        </p:nvSpPr>
-        <p:spPr>
-          <a:xfrm>
-            <a:off x="5029200" y="4219956"/>
-            <a:ext cx="822960" cy="169164"/>
+          <p:cNvPr id="79" name="Text 77"/>
+          <p:cNvSpPr txBox="1"/>
+          <p:nvPr/>
+        </p:nvSpPr>
+        <p:spPr>
+          <a:xfrm>
+            <a:off x="5029200" y="4398264"/>
+            <a:ext cx="822960" cy="192024"/>
           </a:xfrm>
           <a:prstGeom prst="rect">
             <a:avLst/>
@@ -48057,14 +48352,14 @@
       </p:sp>
       <p:sp>
         <p:nvSpPr>
-          <p:cNvPr id="70" name="Text 68"/>
-          <p:cNvSpPr txBox="1"/>
-          <p:nvPr/>
-        </p:nvSpPr>
-        <p:spPr>
-          <a:xfrm>
-            <a:off x="5943600" y="4219956"/>
-            <a:ext cx="822960" cy="169164"/>
+          <p:cNvPr id="80" name="Text 78"/>
+          <p:cNvSpPr txBox="1"/>
+          <p:nvPr/>
+        </p:nvSpPr>
+        <p:spPr>
+          <a:xfrm>
+            <a:off x="5943600" y="4398264"/>
+            <a:ext cx="822960" cy="192024"/>
           </a:xfrm>
           <a:prstGeom prst="rect">
             <a:avLst/>
@@ -48096,14 +48391,14 @@
       </p:sp>
       <p:sp>
         <p:nvSpPr>
-          <p:cNvPr id="71" name="Text 69"/>
-          <p:cNvSpPr txBox="1"/>
-          <p:nvPr/>
-        </p:nvSpPr>
-        <p:spPr>
-          <a:xfrm>
-            <a:off x="640080" y="4389120"/>
-            <a:ext cx="1783080" cy="169164"/>
+          <p:cNvPr id="81" name="Text 79"/>
+          <p:cNvSpPr txBox="1"/>
+          <p:nvPr/>
+        </p:nvSpPr>
+        <p:spPr>
+          <a:xfrm>
+            <a:off x="640080" y="4590288"/>
+            <a:ext cx="1783080" cy="192024"/>
           </a:xfrm>
           <a:prstGeom prst="rect">
             <a:avLst/>
@@ -48135,13 +48430,13 @@
       </p:sp>
       <p:sp>
         <p:nvSpPr>
-          <p:cNvPr id="72" name="Shape 70"/>
-          <p:cNvSpPr/>
-          <p:nvPr/>
-        </p:nvSpPr>
-        <p:spPr>
-          <a:xfrm>
-            <a:off x="2468880" y="4449470"/>
+          <p:cNvPr id="82" name="Shape 80"/>
+          <p:cNvSpPr/>
+          <p:nvPr/>
+        </p:nvSpPr>
+        <p:spPr>
+          <a:xfrm>
+            <a:off x="2468880" y="4657039"/>
             <a:ext cx="2377440" cy="59436"/>
           </a:xfrm>
           <a:prstGeom prst="roundRect">
@@ -48157,14 +48452,14 @@
       </p:sp>
       <p:sp>
         <p:nvSpPr>
-          <p:cNvPr id="73" name="Text 71"/>
-          <p:cNvSpPr txBox="1"/>
-          <p:nvPr/>
-        </p:nvSpPr>
-        <p:spPr>
-          <a:xfrm>
-            <a:off x="5029200" y="4389120"/>
-            <a:ext cx="822960" cy="169164"/>
+          <p:cNvPr id="83" name="Text 81"/>
+          <p:cNvSpPr txBox="1"/>
+          <p:nvPr/>
+        </p:nvSpPr>
+        <p:spPr>
+          <a:xfrm>
+            <a:off x="5029200" y="4590288"/>
+            <a:ext cx="822960" cy="192024"/>
           </a:xfrm>
           <a:prstGeom prst="rect">
             <a:avLst/>
@@ -48196,14 +48491,14 @@
       </p:sp>
       <p:sp>
         <p:nvSpPr>
-          <p:cNvPr id="74" name="Text 72"/>
-          <p:cNvSpPr txBox="1"/>
-          <p:nvPr/>
-        </p:nvSpPr>
-        <p:spPr>
-          <a:xfrm>
-            <a:off x="5943600" y="4389120"/>
-            <a:ext cx="822960" cy="169164"/>
+          <p:cNvPr id="84" name="Text 82"/>
+          <p:cNvSpPr txBox="1"/>
+          <p:nvPr/>
+        </p:nvSpPr>
+        <p:spPr>
+          <a:xfrm>
+            <a:off x="5943600" y="4590288"/>
+            <a:ext cx="822960" cy="192024"/>
           </a:xfrm>
           <a:prstGeom prst="rect">
             <a:avLst/>
@@ -48235,14 +48530,14 @@
       </p:sp>
       <p:sp>
         <p:nvSpPr>
-          <p:cNvPr id="75" name="Text 73"/>
-          <p:cNvSpPr txBox="1"/>
-          <p:nvPr/>
-        </p:nvSpPr>
-        <p:spPr>
-          <a:xfrm>
-            <a:off x="640080" y="4558284"/>
-            <a:ext cx="1783080" cy="169164"/>
+          <p:cNvPr id="85" name="Text 83"/>
+          <p:cNvSpPr txBox="1"/>
+          <p:nvPr/>
+        </p:nvSpPr>
+        <p:spPr>
+          <a:xfrm>
+            <a:off x="640080" y="4782312"/>
+            <a:ext cx="1783080" cy="192024"/>
           </a:xfrm>
           <a:prstGeom prst="rect">
             <a:avLst/>
@@ -48274,13 +48569,13 @@
       </p:sp>
       <p:sp>
         <p:nvSpPr>
-          <p:cNvPr id="76" name="Shape 74"/>
-          <p:cNvSpPr/>
-          <p:nvPr/>
-        </p:nvSpPr>
-        <p:spPr>
-          <a:xfrm>
-            <a:off x="2468880" y="4618634"/>
+          <p:cNvPr id="86" name="Shape 84"/>
+          <p:cNvSpPr/>
+          <p:nvPr/>
+        </p:nvSpPr>
+        <p:spPr>
+          <a:xfrm>
+            <a:off x="2468880" y="4849063"/>
             <a:ext cx="2377440" cy="59436"/>
           </a:xfrm>
           <a:prstGeom prst="roundRect">
@@ -48296,14 +48591,14 @@
       </p:sp>
       <p:sp>
         <p:nvSpPr>
-          <p:cNvPr id="77" name="Text 75"/>
-          <p:cNvSpPr txBox="1"/>
-          <p:nvPr/>
-        </p:nvSpPr>
-        <p:spPr>
-          <a:xfrm>
-            <a:off x="5029200" y="4558284"/>
-            <a:ext cx="822960" cy="169164"/>
+          <p:cNvPr id="87" name="Text 85"/>
+          <p:cNvSpPr txBox="1"/>
+          <p:nvPr/>
+        </p:nvSpPr>
+        <p:spPr>
+          <a:xfrm>
+            <a:off x="5029200" y="4782312"/>
+            <a:ext cx="822960" cy="192024"/>
           </a:xfrm>
           <a:prstGeom prst="rect">
             <a:avLst/>
@@ -48335,14 +48630,14 @@
       </p:sp>
       <p:sp>
         <p:nvSpPr>
-          <p:cNvPr id="78" name="Text 76"/>
-          <p:cNvSpPr txBox="1"/>
-          <p:nvPr/>
-        </p:nvSpPr>
-        <p:spPr>
-          <a:xfrm>
-            <a:off x="5943600" y="4558284"/>
-            <a:ext cx="822960" cy="169164"/>
+          <p:cNvPr id="88" name="Text 86"/>
+          <p:cNvSpPr txBox="1"/>
+          <p:nvPr/>
+        </p:nvSpPr>
+        <p:spPr>
+          <a:xfrm>
+            <a:off x="5943600" y="4782312"/>
+            <a:ext cx="822960" cy="192024"/>
           </a:xfrm>
           <a:prstGeom prst="rect">
             <a:avLst/>
@@ -48374,14 +48669,14 @@
       </p:sp>
       <p:sp>
         <p:nvSpPr>
-          <p:cNvPr id="79" name="Text 77"/>
-          <p:cNvSpPr txBox="1"/>
-          <p:nvPr/>
-        </p:nvSpPr>
-        <p:spPr>
-          <a:xfrm>
-            <a:off x="640080" y="4727448"/>
-            <a:ext cx="1783080" cy="169164"/>
+          <p:cNvPr id="89" name="Text 87"/>
+          <p:cNvSpPr txBox="1"/>
+          <p:nvPr/>
+        </p:nvSpPr>
+        <p:spPr>
+          <a:xfrm>
+            <a:off x="640080" y="4974336"/>
+            <a:ext cx="1783080" cy="192024"/>
           </a:xfrm>
           <a:prstGeom prst="rect">
             <a:avLst/>
@@ -48405,7 +48700,7 @@
                 <a:ea typeface="Poppins" pitchFamily="34" charset="-122"/>
                 <a:cs typeface="Poppins" pitchFamily="34" charset="-120"/>
               </a:rPr>
-              <a:t>Argenis Rafael Guevara</a:t>
+              <a:t>Jasmine Hikuroa</a:t>
             </a:r>
             <a:endParaRPr lang="en-US" sz="800" dirty="0"/>
           </a:p>
@@ -48413,13 +48708,13 @@
       </p:sp>
       <p:sp>
         <p:nvSpPr>
-          <p:cNvPr id="80" name="Shape 78"/>
-          <p:cNvSpPr/>
-          <p:nvPr/>
-        </p:nvSpPr>
-        <p:spPr>
-          <a:xfrm>
-            <a:off x="2468880" y="4787798"/>
+          <p:cNvPr id="90" name="Shape 88"/>
+          <p:cNvSpPr/>
+          <p:nvPr/>
+        </p:nvSpPr>
+        <p:spPr>
+          <a:xfrm>
+            <a:off x="2468880" y="5041087"/>
             <a:ext cx="2377440" cy="59436"/>
           </a:xfrm>
           <a:prstGeom prst="roundRect">
@@ -48435,14 +48730,14 @@
       </p:sp>
       <p:sp>
         <p:nvSpPr>
-          <p:cNvPr id="81" name="Text 79"/>
-          <p:cNvSpPr txBox="1"/>
-          <p:nvPr/>
-        </p:nvSpPr>
-        <p:spPr>
-          <a:xfrm>
-            <a:off x="5029200" y="4727448"/>
-            <a:ext cx="822960" cy="169164"/>
+          <p:cNvPr id="91" name="Text 89"/>
+          <p:cNvSpPr txBox="1"/>
+          <p:nvPr/>
+        </p:nvSpPr>
+        <p:spPr>
+          <a:xfrm>
+            <a:off x="5029200" y="4974336"/>
+            <a:ext cx="822960" cy="192024"/>
           </a:xfrm>
           <a:prstGeom prst="rect">
             <a:avLst/>
@@ -48474,14 +48769,14 @@
       </p:sp>
       <p:sp>
         <p:nvSpPr>
-          <p:cNvPr id="82" name="Text 80"/>
-          <p:cNvSpPr txBox="1"/>
-          <p:nvPr/>
-        </p:nvSpPr>
-        <p:spPr>
-          <a:xfrm>
-            <a:off x="5943600" y="4727448"/>
-            <a:ext cx="822960" cy="169164"/>
+          <p:cNvPr id="92" name="Text 90"/>
+          <p:cNvSpPr txBox="1"/>
+          <p:nvPr/>
+        </p:nvSpPr>
+        <p:spPr>
+          <a:xfrm>
+            <a:off x="5943600" y="4974336"/>
+            <a:ext cx="822960" cy="192024"/>
           </a:xfrm>
           <a:prstGeom prst="rect">
             <a:avLst/>
@@ -48513,14 +48808,14 @@
       </p:sp>
       <p:sp>
         <p:nvSpPr>
-          <p:cNvPr id="83" name="Text 81"/>
-          <p:cNvSpPr txBox="1"/>
-          <p:nvPr/>
-        </p:nvSpPr>
-        <p:spPr>
-          <a:xfrm>
-            <a:off x="640080" y="4896612"/>
-            <a:ext cx="1783080" cy="169164"/>
+          <p:cNvPr id="93" name="Text 91"/>
+          <p:cNvSpPr txBox="1"/>
+          <p:nvPr/>
+        </p:nvSpPr>
+        <p:spPr>
+          <a:xfrm>
+            <a:off x="640080" y="5166360"/>
+            <a:ext cx="1783080" cy="192024"/>
           </a:xfrm>
           <a:prstGeom prst="rect">
             <a:avLst/>
@@ -48544,7 +48839,7 @@
                 <a:ea typeface="Poppins" pitchFamily="34" charset="-122"/>
                 <a:cs typeface="Poppins" pitchFamily="34" charset="-120"/>
               </a:rPr>
-              <a:t>Isaac Mercado</a:t>
+              <a:t>Bjorn Magabo</a:t>
             </a:r>
             <a:endParaRPr lang="en-US" sz="800" dirty="0"/>
           </a:p>
@@ -48552,13 +48847,13 @@
       </p:sp>
       <p:sp>
         <p:nvSpPr>
-          <p:cNvPr id="84" name="Shape 82"/>
-          <p:cNvSpPr/>
-          <p:nvPr/>
-        </p:nvSpPr>
-        <p:spPr>
-          <a:xfrm>
-            <a:off x="2468880" y="4956962"/>
+          <p:cNvPr id="94" name="Shape 92"/>
+          <p:cNvSpPr/>
+          <p:nvPr/>
+        </p:nvSpPr>
+        <p:spPr>
+          <a:xfrm>
+            <a:off x="2468880" y="5233111"/>
             <a:ext cx="2377440" cy="59436"/>
           </a:xfrm>
           <a:prstGeom prst="roundRect">
@@ -48574,14 +48869,14 @@
       </p:sp>
       <p:sp>
         <p:nvSpPr>
-          <p:cNvPr id="85" name="Text 83"/>
-          <p:cNvSpPr txBox="1"/>
-          <p:nvPr/>
-        </p:nvSpPr>
-        <p:spPr>
-          <a:xfrm>
-            <a:off x="5029200" y="4896612"/>
-            <a:ext cx="822960" cy="169164"/>
+          <p:cNvPr id="95" name="Text 93"/>
+          <p:cNvSpPr txBox="1"/>
+          <p:nvPr/>
+        </p:nvSpPr>
+        <p:spPr>
+          <a:xfrm>
+            <a:off x="5029200" y="5166360"/>
+            <a:ext cx="822960" cy="192024"/>
           </a:xfrm>
           <a:prstGeom prst="rect">
             <a:avLst/>
@@ -48613,14 +48908,14 @@
       </p:sp>
       <p:sp>
         <p:nvSpPr>
-          <p:cNvPr id="86" name="Text 84"/>
-          <p:cNvSpPr txBox="1"/>
-          <p:nvPr/>
-        </p:nvSpPr>
-        <p:spPr>
-          <a:xfrm>
-            <a:off x="5943600" y="4896612"/>
-            <a:ext cx="822960" cy="169164"/>
+          <p:cNvPr id="96" name="Text 94"/>
+          <p:cNvSpPr txBox="1"/>
+          <p:nvPr/>
+        </p:nvSpPr>
+        <p:spPr>
+          <a:xfrm>
+            <a:off x="5943600" y="5166360"/>
+            <a:ext cx="822960" cy="192024"/>
           </a:xfrm>
           <a:prstGeom prst="rect">
             <a:avLst/>
@@ -48652,14 +48947,14 @@
       </p:sp>
       <p:sp>
         <p:nvSpPr>
-          <p:cNvPr id="87" name="Text 85"/>
-          <p:cNvSpPr txBox="1"/>
-          <p:nvPr/>
-        </p:nvSpPr>
-        <p:spPr>
-          <a:xfrm>
-            <a:off x="640080" y="5065776"/>
-            <a:ext cx="1783080" cy="169164"/>
+          <p:cNvPr id="97" name="Text 95"/>
+          <p:cNvSpPr txBox="1"/>
+          <p:nvPr/>
+        </p:nvSpPr>
+        <p:spPr>
+          <a:xfrm>
+            <a:off x="640080" y="5358384"/>
+            <a:ext cx="1783080" cy="192024"/>
           </a:xfrm>
           <a:prstGeom prst="rect">
             <a:avLst/>
@@ -48683,7 +48978,7 @@
                 <a:ea typeface="Poppins" pitchFamily="34" charset="-122"/>
                 <a:cs typeface="Poppins" pitchFamily="34" charset="-120"/>
               </a:rPr>
-              <a:t>Jasmine Hikuroa</a:t>
+              <a:t>Phuong Ho</a:t>
             </a:r>
             <a:endParaRPr lang="en-US" sz="800" dirty="0"/>
           </a:p>
@@ -48691,13 +48986,13 @@
       </p:sp>
       <p:sp>
         <p:nvSpPr>
-          <p:cNvPr id="88" name="Shape 86"/>
-          <p:cNvSpPr/>
-          <p:nvPr/>
-        </p:nvSpPr>
-        <p:spPr>
-          <a:xfrm>
-            <a:off x="2468880" y="5126126"/>
+          <p:cNvPr id="98" name="Shape 96"/>
+          <p:cNvSpPr/>
+          <p:nvPr/>
+        </p:nvSpPr>
+        <p:spPr>
+          <a:xfrm>
+            <a:off x="2468880" y="5425135"/>
             <a:ext cx="2377440" cy="59436"/>
           </a:xfrm>
           <a:prstGeom prst="roundRect">
@@ -48713,14 +49008,14 @@
       </p:sp>
       <p:sp>
         <p:nvSpPr>
-          <p:cNvPr id="89" name="Text 87"/>
-          <p:cNvSpPr txBox="1"/>
-          <p:nvPr/>
-        </p:nvSpPr>
-        <p:spPr>
-          <a:xfrm>
-            <a:off x="5029200" y="5065776"/>
-            <a:ext cx="822960" cy="169164"/>
+          <p:cNvPr id="99" name="Text 97"/>
+          <p:cNvSpPr txBox="1"/>
+          <p:nvPr/>
+        </p:nvSpPr>
+        <p:spPr>
+          <a:xfrm>
+            <a:off x="5029200" y="5358384"/>
+            <a:ext cx="822960" cy="192024"/>
           </a:xfrm>
           <a:prstGeom prst="rect">
             <a:avLst/>
@@ -48752,14 +49047,14 @@
       </p:sp>
       <p:sp>
         <p:nvSpPr>
-          <p:cNvPr id="90" name="Text 88"/>
-          <p:cNvSpPr txBox="1"/>
-          <p:nvPr/>
-        </p:nvSpPr>
-        <p:spPr>
-          <a:xfrm>
-            <a:off x="5943600" y="5065776"/>
-            <a:ext cx="822960" cy="169164"/>
+          <p:cNvPr id="100" name="Text 98"/>
+          <p:cNvSpPr txBox="1"/>
+          <p:nvPr/>
+        </p:nvSpPr>
+        <p:spPr>
+          <a:xfrm>
+            <a:off x="5943600" y="5358384"/>
+            <a:ext cx="822960" cy="192024"/>
           </a:xfrm>
           <a:prstGeom prst="rect">
             <a:avLst/>
@@ -48791,91 +49086,30 @@
       </p:sp>
       <p:sp>
         <p:nvSpPr>
-          <p:cNvPr id="91" name="Text 89"/>
-          <p:cNvSpPr txBox="1"/>
-          <p:nvPr/>
-        </p:nvSpPr>
-        <p:spPr>
-          <a:xfrm>
-            <a:off x="640080" y="5234940"/>
-            <a:ext cx="1783080" cy="169164"/>
-          </a:xfrm>
-          <a:prstGeom prst="rect">
-            <a:avLst/>
-          </a:prstGeom>
-          <a:noFill/>
-          <a:ln/>
-        </p:spPr>
-        <p:txBody>
-          <a:bodyPr wrap="square" lIns="0" tIns="0" rIns="0" bIns="0" rtlCol="0" anchor="ctr"/>
+          <p:cNvPr id="101" name="Text 99"/>
+          <p:cNvSpPr txBox="1"/>
+          <p:nvPr/>
+        </p:nvSpPr>
+        <p:spPr>
+          <a:xfrm>
+            <a:off x="640080" y="5614416"/>
+            <a:ext cx="6126480" cy="292608"/>
+          </a:xfrm>
+          <a:prstGeom prst="rect">
+            <a:avLst/>
+          </a:prstGeom>
+          <a:noFill/>
+          <a:ln/>
+        </p:spPr>
+        <p:txBody>
+          <a:bodyPr wrap="square" lIns="0" tIns="0" rIns="0" bIns="0" rtlCol="0" anchor="t"/>
           <a:lstStyle/>
           <a:p>
             <a:pPr indent="0" marL="0">
               <a:buNone/>
             </a:pPr>
             <a:r>
-              <a:rPr lang="en-US" sz="800" dirty="0">
-                <a:solidFill>
-                  <a:srgbClr val="5E7280"/>
-                </a:solidFill>
-                <a:latin typeface="Poppins" pitchFamily="34" charset="0"/>
-                <a:ea typeface="Poppins" pitchFamily="34" charset="-122"/>
-                <a:cs typeface="Poppins" pitchFamily="34" charset="-120"/>
-              </a:rPr>
-              <a:t>Bjorn Magabo</a:t>
-            </a:r>
-            <a:endParaRPr lang="en-US" sz="800" dirty="0"/>
-          </a:p>
-        </p:txBody>
-      </p:sp>
-      <p:sp>
-        <p:nvSpPr>
-          <p:cNvPr id="92" name="Shape 90"/>
-          <p:cNvSpPr/>
-          <p:nvPr/>
-        </p:nvSpPr>
-        <p:spPr>
-          <a:xfrm>
-            <a:off x="2468880" y="5295290"/>
-            <a:ext cx="2377440" cy="59436"/>
-          </a:xfrm>
-          <a:prstGeom prst="roundRect">
-            <a:avLst>
-              <a:gd name="adj" fmla="val 49231"/>
-            </a:avLst>
-          </a:prstGeom>
-          <a:solidFill>
-            <a:srgbClr val="E2EAEE"/>
-          </a:solidFill>
-          <a:ln/>
-        </p:spPr>
-      </p:sp>
-      <p:sp>
-        <p:nvSpPr>
-          <p:cNvPr id="93" name="Text 91"/>
-          <p:cNvSpPr txBox="1"/>
-          <p:nvPr/>
-        </p:nvSpPr>
-        <p:spPr>
-          <a:xfrm>
-            <a:off x="5029200" y="5234940"/>
-            <a:ext cx="822960" cy="169164"/>
-          </a:xfrm>
-          <a:prstGeom prst="rect">
-            <a:avLst/>
-          </a:prstGeom>
-          <a:noFill/>
-          <a:ln/>
-        </p:spPr>
-        <p:txBody>
-          <a:bodyPr wrap="square" lIns="0" tIns="0" rIns="0" bIns="0" rtlCol="0" anchor="ctr"/>
-          <a:lstStyle/>
-          <a:p>
-            <a:pPr algn="r" indent="0" marL="0">
-              <a:buNone/>
-            </a:pPr>
-            <a:r>
-              <a:rPr lang="en-US" sz="800" dirty="0">
+              <a:rPr lang="en-US" sz="580" dirty="0">
                 <a:solidFill>
                   <a:srgbClr val="8FA1AC"/>
                 </a:solidFill>
@@ -48883,283 +49117,7 @@
                 <a:ea typeface="Poppins" pitchFamily="34" charset="-122"/>
                 <a:cs typeface="Poppins" pitchFamily="34" charset="-120"/>
               </a:rPr>
-              <a:t>—</a:t>
-            </a:r>
-            <a:endParaRPr lang="en-US" sz="800" dirty="0"/>
-          </a:p>
-        </p:txBody>
-      </p:sp>
-      <p:sp>
-        <p:nvSpPr>
-          <p:cNvPr id="94" name="Text 92"/>
-          <p:cNvSpPr txBox="1"/>
-          <p:nvPr/>
-        </p:nvSpPr>
-        <p:spPr>
-          <a:xfrm>
-            <a:off x="5943600" y="5234940"/>
-            <a:ext cx="822960" cy="169164"/>
-          </a:xfrm>
-          <a:prstGeom prst="rect">
-            <a:avLst/>
-          </a:prstGeom>
-          <a:noFill/>
-          <a:ln/>
-        </p:spPr>
-        <p:txBody>
-          <a:bodyPr wrap="square" lIns="0" tIns="0" rIns="0" bIns="0" rtlCol="0" anchor="ctr"/>
-          <a:lstStyle/>
-          <a:p>
-            <a:pPr algn="r" indent="0" marL="0">
-              <a:buNone/>
-            </a:pPr>
-            <a:r>
-              <a:rPr lang="en-US" sz="600" dirty="0">
-                <a:solidFill>
-                  <a:srgbClr val="8FA1AC"/>
-                </a:solidFill>
-                <a:latin typeface="Poppins" pitchFamily="34" charset="0"/>
-                <a:ea typeface="Poppins" pitchFamily="34" charset="-122"/>
-                <a:cs typeface="Poppins" pitchFamily="34" charset="-120"/>
-              </a:rPr>
-              <a:t>no time logged</a:t>
-            </a:r>
-            <a:endParaRPr lang="en-US" sz="600" dirty="0"/>
-          </a:p>
-        </p:txBody>
-      </p:sp>
-      <p:sp>
-        <p:nvSpPr>
-          <p:cNvPr id="95" name="Text 93"/>
-          <p:cNvSpPr txBox="1"/>
-          <p:nvPr/>
-        </p:nvSpPr>
-        <p:spPr>
-          <a:xfrm>
-            <a:off x="640080" y="5404104"/>
-            <a:ext cx="1783080" cy="169164"/>
-          </a:xfrm>
-          <a:prstGeom prst="rect">
-            <a:avLst/>
-          </a:prstGeom>
-          <a:noFill/>
-          <a:ln/>
-        </p:spPr>
-        <p:txBody>
-          <a:bodyPr wrap="square" lIns="0" tIns="0" rIns="0" bIns="0" rtlCol="0" anchor="ctr"/>
-          <a:lstStyle/>
-          <a:p>
-            <a:pPr indent="0" marL="0">
-              <a:buNone/>
-            </a:pPr>
-            <a:r>
-              <a:rPr lang="en-US" sz="800" dirty="0">
-                <a:solidFill>
-                  <a:srgbClr val="5E7280"/>
-                </a:solidFill>
-                <a:latin typeface="Poppins" pitchFamily="34" charset="0"/>
-                <a:ea typeface="Poppins" pitchFamily="34" charset="-122"/>
-                <a:cs typeface="Poppins" pitchFamily="34" charset="-120"/>
-              </a:rPr>
-              <a:t>Phuong Ho</a:t>
-            </a:r>
-            <a:endParaRPr lang="en-US" sz="800" dirty="0"/>
-          </a:p>
-        </p:txBody>
-      </p:sp>
-      <p:sp>
-        <p:nvSpPr>
-          <p:cNvPr id="96" name="Shape 94"/>
-          <p:cNvSpPr/>
-          <p:nvPr/>
-        </p:nvSpPr>
-        <p:spPr>
-          <a:xfrm>
-            <a:off x="2468880" y="5464454"/>
-            <a:ext cx="2377440" cy="59436"/>
-          </a:xfrm>
-          <a:prstGeom prst="roundRect">
-            <a:avLst>
-              <a:gd name="adj" fmla="val 49231"/>
-            </a:avLst>
-          </a:prstGeom>
-          <a:solidFill>
-            <a:srgbClr val="E2EAEE"/>
-          </a:solidFill>
-          <a:ln/>
-        </p:spPr>
-      </p:sp>
-      <p:sp>
-        <p:nvSpPr>
-          <p:cNvPr id="97" name="Text 95"/>
-          <p:cNvSpPr txBox="1"/>
-          <p:nvPr/>
-        </p:nvSpPr>
-        <p:spPr>
-          <a:xfrm>
-            <a:off x="5029200" y="5404104"/>
-            <a:ext cx="822960" cy="169164"/>
-          </a:xfrm>
-          <a:prstGeom prst="rect">
-            <a:avLst/>
-          </a:prstGeom>
-          <a:noFill/>
-          <a:ln/>
-        </p:spPr>
-        <p:txBody>
-          <a:bodyPr wrap="square" lIns="0" tIns="0" rIns="0" bIns="0" rtlCol="0" anchor="ctr"/>
-          <a:lstStyle/>
-          <a:p>
-            <a:pPr algn="r" indent="0" marL="0">
-              <a:buNone/>
-            </a:pPr>
-            <a:r>
-              <a:rPr lang="en-US" sz="800" dirty="0">
-                <a:solidFill>
-                  <a:srgbClr val="8FA1AC"/>
-                </a:solidFill>
-                <a:latin typeface="Poppins" pitchFamily="34" charset="0"/>
-                <a:ea typeface="Poppins" pitchFamily="34" charset="-122"/>
-                <a:cs typeface="Poppins" pitchFamily="34" charset="-120"/>
-              </a:rPr>
-              <a:t>—</a:t>
-            </a:r>
-            <a:endParaRPr lang="en-US" sz="800" dirty="0"/>
-          </a:p>
-        </p:txBody>
-      </p:sp>
-      <p:sp>
-        <p:nvSpPr>
-          <p:cNvPr id="98" name="Text 96"/>
-          <p:cNvSpPr txBox="1"/>
-          <p:nvPr/>
-        </p:nvSpPr>
-        <p:spPr>
-          <a:xfrm>
-            <a:off x="5943600" y="5404104"/>
-            <a:ext cx="822960" cy="169164"/>
-          </a:xfrm>
-          <a:prstGeom prst="rect">
-            <a:avLst/>
-          </a:prstGeom>
-          <a:noFill/>
-          <a:ln/>
-        </p:spPr>
-        <p:txBody>
-          <a:bodyPr wrap="square" lIns="0" tIns="0" rIns="0" bIns="0" rtlCol="0" anchor="ctr"/>
-          <a:lstStyle/>
-          <a:p>
-            <a:pPr algn="r" indent="0" marL="0">
-              <a:buNone/>
-            </a:pPr>
-            <a:r>
-              <a:rPr lang="en-US" sz="600" dirty="0">
-                <a:solidFill>
-                  <a:srgbClr val="8FA1AC"/>
-                </a:solidFill>
-                <a:latin typeface="Poppins" pitchFamily="34" charset="0"/>
-                <a:ea typeface="Poppins" pitchFamily="34" charset="-122"/>
-                <a:cs typeface="Poppins" pitchFamily="34" charset="-120"/>
-              </a:rPr>
-              <a:t>no time logged</a:t>
-            </a:r>
-            <a:endParaRPr lang="en-US" sz="600" dirty="0"/>
-          </a:p>
-        </p:txBody>
-      </p:sp>
-      <p:sp>
-        <p:nvSpPr>
-          <p:cNvPr id="99" name="Shape 97"/>
-          <p:cNvSpPr/>
-          <p:nvPr/>
-        </p:nvSpPr>
-        <p:spPr>
-          <a:xfrm>
-            <a:off x="4370832" y="2999232"/>
-            <a:ext cx="7315" cy="2537460"/>
-          </a:xfrm>
-          <a:prstGeom prst="rect">
-            <a:avLst/>
-          </a:prstGeom>
-          <a:solidFill>
-            <a:srgbClr val="B4552D"/>
-          </a:solidFill>
-          <a:ln/>
-        </p:spPr>
-      </p:sp>
-      <p:sp>
-        <p:nvSpPr>
-          <p:cNvPr id="100" name="Text 98"/>
-          <p:cNvSpPr txBox="1"/>
-          <p:nvPr/>
-        </p:nvSpPr>
-        <p:spPr>
-          <a:xfrm>
-            <a:off x="3931920" y="2816352"/>
-            <a:ext cx="877824" cy="164592"/>
-          </a:xfrm>
-          <a:prstGeom prst="rect">
-            <a:avLst/>
-          </a:prstGeom>
-          <a:noFill/>
-          <a:ln/>
-        </p:spPr>
-        <p:txBody>
-          <a:bodyPr wrap="square" lIns="0" tIns="0" rIns="0" bIns="0" rtlCol="0" anchor="ctr"/>
-          <a:lstStyle/>
-          <a:p>
-            <a:pPr algn="ctr" indent="0" marL="0">
-              <a:buNone/>
-            </a:pPr>
-            <a:r>
-              <a:rPr lang="en-US" sz="600" b="1" dirty="0">
-                <a:solidFill>
-                  <a:srgbClr val="B4552D"/>
-                </a:solidFill>
-                <a:latin typeface="Poppins" pitchFamily="34" charset="0"/>
-                <a:ea typeface="Poppins" pitchFamily="34" charset="-122"/>
-                <a:cs typeface="Poppins" pitchFamily="34" charset="-120"/>
-              </a:rPr>
-              <a:t>80% target</a:t>
-            </a:r>
-            <a:endParaRPr lang="en-US" sz="600" dirty="0"/>
-          </a:p>
-        </p:txBody>
-      </p:sp>
-      <p:sp>
-        <p:nvSpPr>
-          <p:cNvPr id="101" name="Text 99"/>
-          <p:cNvSpPr txBox="1"/>
-          <p:nvPr/>
-        </p:nvSpPr>
-        <p:spPr>
-          <a:xfrm>
-            <a:off x="640080" y="5650992"/>
-            <a:ext cx="6126480" cy="256032"/>
-          </a:xfrm>
-          <a:prstGeom prst="rect">
-            <a:avLst/>
-          </a:prstGeom>
-          <a:noFill/>
-          <a:ln/>
-        </p:spPr>
-        <p:txBody>
-          <a:bodyPr wrap="square" lIns="0" tIns="0" rIns="0" bIns="0" rtlCol="0" anchor="t"/>
-          <a:lstStyle/>
-          <a:p>
-            <a:pPr indent="0" marL="0">
-              <a:buNone/>
-            </a:pPr>
-            <a:r>
-              <a:rPr lang="en-US" sz="580" dirty="0">
-                <a:solidFill>
-                  <a:srgbClr val="8FA1AC"/>
-                </a:solidFill>
-                <a:latin typeface="Poppins" pitchFamily="34" charset="0"/>
-                <a:ea typeface="Poppins" pitchFamily="34" charset="-122"/>
-                <a:cs typeface="Poppins" pitchFamily="34" charset="-120"/>
-              </a:rPr>
-              <a:t>Available staff = the 15 people assigned to PS-pipeline tickets open now or closed this week (Tech, Onboarding, Integrations, Training, Warranty), at a 38h standard week.</a:t>
+              <a:t>Available staff = the 13 Professional Services people assigned to PS-pipeline tickets open now or closed this week, at a 38h standard week. Argenis Rafael Guevara and Isaac Mercado carry PS-pipeline tickets but are not Professional Services staff — excluded from the capacity base.</a:t>
             </a:r>
             <a:endParaRPr lang="en-US" sz="580" dirty="0"/>
           </a:p>
@@ -50218,7 +50176,7 @@
                 <a:ea typeface="Poppins" pitchFamily="34" charset="-122"/>
                 <a:cs typeface="Poppins" pitchFamily="34" charset="-120"/>
               </a:rPr>
-              <a:t>5.8% billable utilisation is a logging number, not a delivery number. </a:t>
+              <a:t>6.7% billable utilisation is a logging number, not a delivery number. </a:t>
             </a:r>
             <a:pPr indent="0" marL="0">
               <a:spcAft>
@@ -50235,7 +50193,7 @@
                 <a:ea typeface="Poppins" pitchFamily="34" charset="-122"/>
                 <a:cs typeface="Poppins" pitchFamily="34" charset="-120"/>
               </a:rPr>
-              <a:t>33.01h landed against 570h of capacity, but only 13% of the week's 132 PS items carry hours.</a:t>
+              <a:t>33.01h landed against 494h of capacity, but only 13% of the week's 132 PS items carry hours.</a:t>
             </a:r>
             <a:endParaRPr lang="en-US" sz="900" dirty="0"/>
           </a:p>
@@ -50283,7 +50241,7 @@
                 <a:ea typeface="Poppins" pitchFamily="34" charset="-122"/>
                 <a:cs typeface="Poppins" pitchFamily="34" charset="-120"/>
               </a:rPr>
-              <a:t>Katherine Fenwick 38.2% and Rhys Woolcock 36.4%; the other 9 PS members logged nothing at all.</a:t>
+              <a:t>Katherine Fenwick 38.2% and Rhys Woolcock 36.4%; the other 7 PS members logged nothing at all.</a:t>
             </a:r>
             <a:endParaRPr lang="en-US" sz="900" dirty="0"/>
           </a:p>

</xml_diff>

<commit_message>
Utilisation: correct the non-PS exclusions to Lopez, Hikuroa, Magabo, Ho
Argenis Rafael Guevara and Isaac Mercado were excluded in error and are
restored. The four who are not Professional Services staff are Anton Lopez,
Jasmine Hikuroa, Bjorn Magabo and Phuong Ho; they come out of the capacity
base. 11 people x 38h = 418h available, billed hours unchanged at 33.01h
(all four logged nothing), so billable utilisation is 7.9%.

Employee row pitch now scales to the roster size so the panel stays filled.

Co-Authored-By: Claude Opus 5 <noreply@anthropic.com>
Claude-Session: https://claude.ai/code/session_019YTPNjRj34XzLPLC9gKxc4
</commit_message>
<xml_diff>
--- a/exec-deck/output/H&L Weekly Update - WC 14 Sep 2026.pptx
+++ b/exec-deck/output/H&L Weekly Update - WC 14 Sep 2026.pptx
@@ -46275,7 +46275,7 @@
                 <a:ea typeface="Poppins" pitchFamily="34" charset="-122"/>
                 <a:cs typeface="Poppins" pitchFamily="34" charset="-120"/>
               </a:rPr>
-              <a:t>6.7%</a:t>
+              <a:t>7.9%</a:t>
             </a:r>
             <a:endParaRPr lang="en-US" sz="2600" dirty="0"/>
           </a:p>
@@ -46314,7 +46314,7 @@
                 <a:ea typeface="Poppins" pitchFamily="34" charset="-122"/>
                 <a:cs typeface="Poppins" pitchFamily="34" charset="-120"/>
               </a:rPr>
-              <a:t>33.01h billed of 494h available · target 80%</a:t>
+              <a:t>33.01h billed of 418h available · target 80%</a:t>
             </a:r>
             <a:endParaRPr lang="en-US" sz="780" dirty="0"/>
           </a:p>
@@ -46421,7 +46421,7 @@
                 <a:ea typeface="Poppins" pitchFamily="34" charset="-122"/>
                 <a:cs typeface="Poppins" pitchFamily="34" charset="-120"/>
               </a:rPr>
-              <a:t>494h</a:t>
+              <a:t>418h</a:t>
             </a:r>
             <a:endParaRPr lang="en-US" sz="2600" dirty="0"/>
           </a:p>
@@ -46460,7 +46460,7 @@
                 <a:ea typeface="Poppins" pitchFamily="34" charset="-122"/>
                 <a:cs typeface="Poppins" pitchFamily="34" charset="-120"/>
               </a:rPr>
-              <a:t>13 people assigned to PS-pipeline tickets × 38h standard week</a:t>
+              <a:t>11 people assigned to PS-pipeline tickets × 38h standard week</a:t>
             </a:r>
             <a:endParaRPr lang="en-US" sz="780" dirty="0"/>
           </a:p>
@@ -46898,7 +46898,7 @@
         <p:spPr>
           <a:xfrm>
             <a:off x="2944368" y="3017520"/>
-            <a:ext cx="5486" cy="2496312"/>
+            <a:ext cx="5486" cy="2487168"/>
           </a:xfrm>
           <a:prstGeom prst="rect">
             <a:avLst/>
@@ -46957,7 +46957,7 @@
         <p:spPr>
           <a:xfrm>
             <a:off x="3419856" y="3017520"/>
-            <a:ext cx="5486" cy="2496312"/>
+            <a:ext cx="5486" cy="2487168"/>
           </a:xfrm>
           <a:prstGeom prst="rect">
             <a:avLst/>
@@ -47016,7 +47016,7 @@
         <p:spPr>
           <a:xfrm>
             <a:off x="3895344" y="3017520"/>
-            <a:ext cx="5486" cy="2496312"/>
+            <a:ext cx="5486" cy="2487168"/>
           </a:xfrm>
           <a:prstGeom prst="rect">
             <a:avLst/>
@@ -47075,7 +47075,7 @@
         <p:spPr>
           <a:xfrm>
             <a:off x="4370832" y="3017520"/>
-            <a:ext cx="5486" cy="2496312"/>
+            <a:ext cx="5486" cy="2487168"/>
           </a:xfrm>
           <a:prstGeom prst="rect">
             <a:avLst/>
@@ -47134,7 +47134,7 @@
         <p:spPr>
           <a:xfrm>
             <a:off x="4846320" y="3017520"/>
-            <a:ext cx="5486" cy="2496312"/>
+            <a:ext cx="5486" cy="2487168"/>
           </a:xfrm>
           <a:prstGeom prst="rect">
             <a:avLst/>
@@ -47154,7 +47154,7 @@
         <p:spPr>
           <a:xfrm>
             <a:off x="640080" y="3054096"/>
-            <a:ext cx="1783080" cy="192024"/>
+            <a:ext cx="1783080" cy="226106"/>
           </a:xfrm>
           <a:prstGeom prst="rect">
             <a:avLst/>
@@ -47192,7 +47192,7 @@
         </p:nvSpPr>
         <p:spPr>
           <a:xfrm>
-            <a:off x="2468880" y="3120847"/>
+            <a:off x="2468880" y="3137431"/>
             <a:ext cx="2377440" cy="59436"/>
           </a:xfrm>
           <a:prstGeom prst="roundRect">
@@ -47214,7 +47214,7 @@
         </p:nvSpPr>
         <p:spPr>
           <a:xfrm>
-            <a:off x="2468880" y="3120847"/>
+            <a:off x="2468880" y="3137431"/>
             <a:ext cx="908182" cy="59436"/>
           </a:xfrm>
           <a:prstGeom prst="roundRect">
@@ -47237,7 +47237,7 @@
         <p:spPr>
           <a:xfrm>
             <a:off x="5029200" y="3054096"/>
-            <a:ext cx="822960" cy="192024"/>
+            <a:ext cx="822960" cy="226106"/>
           </a:xfrm>
           <a:prstGeom prst="rect">
             <a:avLst/>
@@ -47276,7 +47276,7 @@
         <p:spPr>
           <a:xfrm>
             <a:off x="5943600" y="3054096"/>
-            <a:ext cx="822960" cy="192024"/>
+            <a:ext cx="822960" cy="226106"/>
           </a:xfrm>
           <a:prstGeom prst="rect">
             <a:avLst/>
@@ -47314,8 +47314,8 @@
         </p:nvSpPr>
         <p:spPr>
           <a:xfrm>
-            <a:off x="640080" y="3246120"/>
-            <a:ext cx="1783080" cy="192024"/>
+            <a:off x="640080" y="3280202"/>
+            <a:ext cx="1783080" cy="226106"/>
           </a:xfrm>
           <a:prstGeom prst="rect">
             <a:avLst/>
@@ -47353,7 +47353,7 @@
         </p:nvSpPr>
         <p:spPr>
           <a:xfrm>
-            <a:off x="2468880" y="3312871"/>
+            <a:off x="2468880" y="3363537"/>
             <a:ext cx="2377440" cy="59436"/>
           </a:xfrm>
           <a:prstGeom prst="roundRect">
@@ -47375,7 +47375,7 @@
         </p:nvSpPr>
         <p:spPr>
           <a:xfrm>
-            <a:off x="2468880" y="3312871"/>
+            <a:off x="2468880" y="3363537"/>
             <a:ext cx="865388" cy="59436"/>
           </a:xfrm>
           <a:prstGeom prst="roundRect">
@@ -47397,8 +47397,8 @@
         </p:nvSpPr>
         <p:spPr>
           <a:xfrm>
-            <a:off x="5029200" y="3246120"/>
-            <a:ext cx="822960" cy="192024"/>
+            <a:off x="5029200" y="3280202"/>
+            <a:ext cx="822960" cy="226106"/>
           </a:xfrm>
           <a:prstGeom prst="rect">
             <a:avLst/>
@@ -47436,8 +47436,8 @@
         </p:nvSpPr>
         <p:spPr>
           <a:xfrm>
-            <a:off x="5943600" y="3246120"/>
-            <a:ext cx="822960" cy="192024"/>
+            <a:off x="5943600" y="3280202"/>
+            <a:ext cx="822960" cy="226106"/>
           </a:xfrm>
           <a:prstGeom prst="rect">
             <a:avLst/>
@@ -47475,8 +47475,8 @@
         </p:nvSpPr>
         <p:spPr>
           <a:xfrm>
-            <a:off x="640080" y="3438144"/>
-            <a:ext cx="1783080" cy="192024"/>
+            <a:off x="640080" y="3506308"/>
+            <a:ext cx="1783080" cy="226106"/>
           </a:xfrm>
           <a:prstGeom prst="rect">
             <a:avLst/>
@@ -47514,7 +47514,7 @@
         </p:nvSpPr>
         <p:spPr>
           <a:xfrm>
-            <a:off x="2468880" y="3504895"/>
+            <a:off x="2468880" y="3589643"/>
             <a:ext cx="2377440" cy="59436"/>
           </a:xfrm>
           <a:prstGeom prst="roundRect">
@@ -47536,7 +47536,7 @@
         </p:nvSpPr>
         <p:spPr>
           <a:xfrm>
-            <a:off x="2468880" y="3504895"/>
+            <a:off x="2468880" y="3589643"/>
             <a:ext cx="152156" cy="59436"/>
           </a:xfrm>
           <a:prstGeom prst="roundRect">
@@ -47558,8 +47558,8 @@
         </p:nvSpPr>
         <p:spPr>
           <a:xfrm>
-            <a:off x="5029200" y="3438144"/>
-            <a:ext cx="822960" cy="192024"/>
+            <a:off x="5029200" y="3506308"/>
+            <a:ext cx="822960" cy="226106"/>
           </a:xfrm>
           <a:prstGeom prst="rect">
             <a:avLst/>
@@ -47597,8 +47597,8 @@
         </p:nvSpPr>
         <p:spPr>
           <a:xfrm>
-            <a:off x="5943600" y="3438144"/>
-            <a:ext cx="822960" cy="192024"/>
+            <a:off x="5943600" y="3506308"/>
+            <a:ext cx="822960" cy="226106"/>
           </a:xfrm>
           <a:prstGeom prst="rect">
             <a:avLst/>
@@ -47636,8 +47636,8 @@
         </p:nvSpPr>
         <p:spPr>
           <a:xfrm>
-            <a:off x="640080" y="3630168"/>
-            <a:ext cx="1783080" cy="192024"/>
+            <a:off x="640080" y="3732415"/>
+            <a:ext cx="1783080" cy="226106"/>
           </a:xfrm>
           <a:prstGeom prst="rect">
             <a:avLst/>
@@ -47675,7 +47675,7 @@
         </p:nvSpPr>
         <p:spPr>
           <a:xfrm>
-            <a:off x="2468880" y="3696919"/>
+            <a:off x="2468880" y="3815750"/>
             <a:ext cx="2377440" cy="59436"/>
           </a:xfrm>
           <a:prstGeom prst="roundRect">
@@ -47697,7 +47697,7 @@
         </p:nvSpPr>
         <p:spPr>
           <a:xfrm>
-            <a:off x="2468880" y="3696919"/>
+            <a:off x="2468880" y="3815750"/>
             <a:ext cx="92720" cy="59436"/>
           </a:xfrm>
           <a:prstGeom prst="roundRect">
@@ -47719,8 +47719,8 @@
         </p:nvSpPr>
         <p:spPr>
           <a:xfrm>
-            <a:off x="5029200" y="3630168"/>
-            <a:ext cx="822960" cy="192024"/>
+            <a:off x="5029200" y="3732415"/>
+            <a:ext cx="822960" cy="226106"/>
           </a:xfrm>
           <a:prstGeom prst="rect">
             <a:avLst/>
@@ -47758,8 +47758,8 @@
         </p:nvSpPr>
         <p:spPr>
           <a:xfrm>
-            <a:off x="5943600" y="3630168"/>
-            <a:ext cx="822960" cy="192024"/>
+            <a:off x="5943600" y="3732415"/>
+            <a:ext cx="822960" cy="226106"/>
           </a:xfrm>
           <a:prstGeom prst="rect">
             <a:avLst/>
@@ -47797,8 +47797,8 @@
         </p:nvSpPr>
         <p:spPr>
           <a:xfrm>
-            <a:off x="640080" y="3822192"/>
-            <a:ext cx="1783080" cy="192024"/>
+            <a:off x="640080" y="3958521"/>
+            <a:ext cx="1783080" cy="226106"/>
           </a:xfrm>
           <a:prstGeom prst="rect">
             <a:avLst/>
@@ -47836,7 +47836,7 @@
         </p:nvSpPr>
         <p:spPr>
           <a:xfrm>
-            <a:off x="2468880" y="3888943"/>
+            <a:off x="2468880" y="4041856"/>
             <a:ext cx="2377440" cy="59436"/>
           </a:xfrm>
           <a:prstGeom prst="roundRect">
@@ -47858,7 +47858,7 @@
         </p:nvSpPr>
         <p:spPr>
           <a:xfrm>
-            <a:off x="2468880" y="3888943"/>
+            <a:off x="2468880" y="4041856"/>
             <a:ext cx="45720" cy="59436"/>
           </a:xfrm>
           <a:prstGeom prst="roundRect">
@@ -47880,8 +47880,8 @@
         </p:nvSpPr>
         <p:spPr>
           <a:xfrm>
-            <a:off x="5029200" y="3822192"/>
-            <a:ext cx="822960" cy="192024"/>
+            <a:off x="5029200" y="3958521"/>
+            <a:ext cx="822960" cy="226106"/>
           </a:xfrm>
           <a:prstGeom prst="rect">
             <a:avLst/>
@@ -47919,8 +47919,8 @@
         </p:nvSpPr>
         <p:spPr>
           <a:xfrm>
-            <a:off x="5943600" y="3822192"/>
-            <a:ext cx="822960" cy="192024"/>
+            <a:off x="5943600" y="3958521"/>
+            <a:ext cx="822960" cy="226106"/>
           </a:xfrm>
           <a:prstGeom prst="rect">
             <a:avLst/>
@@ -47958,8 +47958,8 @@
         </p:nvSpPr>
         <p:spPr>
           <a:xfrm>
-            <a:off x="640080" y="4014216"/>
-            <a:ext cx="1783080" cy="192024"/>
+            <a:off x="640080" y="4184627"/>
+            <a:ext cx="1783080" cy="226106"/>
           </a:xfrm>
           <a:prstGeom prst="rect">
             <a:avLst/>
@@ -47997,7 +47997,7 @@
         </p:nvSpPr>
         <p:spPr>
           <a:xfrm>
-            <a:off x="2468880" y="4080967"/>
+            <a:off x="2468880" y="4267962"/>
             <a:ext cx="2377440" cy="59436"/>
           </a:xfrm>
           <a:prstGeom prst="roundRect">
@@ -48019,7 +48019,7 @@
         </p:nvSpPr>
         <p:spPr>
           <a:xfrm>
-            <a:off x="2468880" y="4080967"/>
+            <a:off x="2468880" y="4267962"/>
             <a:ext cx="45720" cy="59436"/>
           </a:xfrm>
           <a:prstGeom prst="roundRect">
@@ -48041,8 +48041,8 @@
         </p:nvSpPr>
         <p:spPr>
           <a:xfrm>
-            <a:off x="5029200" y="4014216"/>
-            <a:ext cx="822960" cy="192024"/>
+            <a:off x="5029200" y="4184627"/>
+            <a:ext cx="822960" cy="226106"/>
           </a:xfrm>
           <a:prstGeom prst="rect">
             <a:avLst/>
@@ -48080,8 +48080,8 @@
         </p:nvSpPr>
         <p:spPr>
           <a:xfrm>
-            <a:off x="5943600" y="4014216"/>
-            <a:ext cx="822960" cy="192024"/>
+            <a:off x="5943600" y="4184627"/>
+            <a:ext cx="822960" cy="226106"/>
           </a:xfrm>
           <a:prstGeom prst="rect">
             <a:avLst/>
@@ -48119,8 +48119,8 @@
         </p:nvSpPr>
         <p:spPr>
           <a:xfrm>
-            <a:off x="640080" y="4206240"/>
-            <a:ext cx="1783080" cy="192024"/>
+            <a:off x="640080" y="4410733"/>
+            <a:ext cx="1783080" cy="226106"/>
           </a:xfrm>
           <a:prstGeom prst="rect">
             <a:avLst/>
@@ -48158,7 +48158,7 @@
         </p:nvSpPr>
         <p:spPr>
           <a:xfrm>
-            <a:off x="2468880" y="4272991"/>
+            <a:off x="2468880" y="4494068"/>
             <a:ext cx="2377440" cy="59436"/>
           </a:xfrm>
           <a:prstGeom prst="roundRect">
@@ -48180,8 +48180,8 @@
         </p:nvSpPr>
         <p:spPr>
           <a:xfrm>
-            <a:off x="5029200" y="4206240"/>
-            <a:ext cx="822960" cy="192024"/>
+            <a:off x="5029200" y="4410733"/>
+            <a:ext cx="822960" cy="226106"/>
           </a:xfrm>
           <a:prstGeom prst="rect">
             <a:avLst/>
@@ -48219,8 +48219,8 @@
         </p:nvSpPr>
         <p:spPr>
           <a:xfrm>
-            <a:off x="5943600" y="4206240"/>
-            <a:ext cx="822960" cy="192024"/>
+            <a:off x="5943600" y="4410733"/>
+            <a:ext cx="822960" cy="226106"/>
           </a:xfrm>
           <a:prstGeom prst="rect">
             <a:avLst/>
@@ -48258,8 +48258,8 @@
         </p:nvSpPr>
         <p:spPr>
           <a:xfrm>
-            <a:off x="640080" y="4398264"/>
-            <a:ext cx="1783080" cy="192024"/>
+            <a:off x="640080" y="4636839"/>
+            <a:ext cx="1783080" cy="226106"/>
           </a:xfrm>
           <a:prstGeom prst="rect">
             <a:avLst/>
@@ -48297,7 +48297,7 @@
         </p:nvSpPr>
         <p:spPr>
           <a:xfrm>
-            <a:off x="2468880" y="4465015"/>
+            <a:off x="2468880" y="4720174"/>
             <a:ext cx="2377440" cy="59436"/>
           </a:xfrm>
           <a:prstGeom prst="roundRect">
@@ -48319,8 +48319,8 @@
         </p:nvSpPr>
         <p:spPr>
           <a:xfrm>
-            <a:off x="5029200" y="4398264"/>
-            <a:ext cx="822960" cy="192024"/>
+            <a:off x="5029200" y="4636839"/>
+            <a:ext cx="822960" cy="226106"/>
           </a:xfrm>
           <a:prstGeom prst="rect">
             <a:avLst/>
@@ -48358,8 +48358,8 @@
         </p:nvSpPr>
         <p:spPr>
           <a:xfrm>
-            <a:off x="5943600" y="4398264"/>
-            <a:ext cx="822960" cy="192024"/>
+            <a:off x="5943600" y="4636839"/>
+            <a:ext cx="822960" cy="226106"/>
           </a:xfrm>
           <a:prstGeom prst="rect">
             <a:avLst/>
@@ -48397,8 +48397,8 @@
         </p:nvSpPr>
         <p:spPr>
           <a:xfrm>
-            <a:off x="640080" y="4590288"/>
-            <a:ext cx="1783080" cy="192024"/>
+            <a:off x="640080" y="4862945"/>
+            <a:ext cx="1783080" cy="226106"/>
           </a:xfrm>
           <a:prstGeom prst="rect">
             <a:avLst/>
@@ -48436,7 +48436,7 @@
         </p:nvSpPr>
         <p:spPr>
           <a:xfrm>
-            <a:off x="2468880" y="4657039"/>
+            <a:off x="2468880" y="4946281"/>
             <a:ext cx="2377440" cy="59436"/>
           </a:xfrm>
           <a:prstGeom prst="roundRect">
@@ -48458,8 +48458,8 @@
         </p:nvSpPr>
         <p:spPr>
           <a:xfrm>
-            <a:off x="5029200" y="4590288"/>
-            <a:ext cx="822960" cy="192024"/>
+            <a:off x="5029200" y="4862945"/>
+            <a:ext cx="822960" cy="226106"/>
           </a:xfrm>
           <a:prstGeom prst="rect">
             <a:avLst/>
@@ -48497,8 +48497,8 @@
         </p:nvSpPr>
         <p:spPr>
           <a:xfrm>
-            <a:off x="5943600" y="4590288"/>
-            <a:ext cx="822960" cy="192024"/>
+            <a:off x="5943600" y="4862945"/>
+            <a:ext cx="822960" cy="226106"/>
           </a:xfrm>
           <a:prstGeom prst="rect">
             <a:avLst/>
@@ -48536,8 +48536,8 @@
         </p:nvSpPr>
         <p:spPr>
           <a:xfrm>
-            <a:off x="640080" y="4782312"/>
-            <a:ext cx="1783080" cy="192024"/>
+            <a:off x="640080" y="5089052"/>
+            <a:ext cx="1783080" cy="226106"/>
           </a:xfrm>
           <a:prstGeom prst="rect">
             <a:avLst/>
@@ -48561,7 +48561,7 @@
                 <a:ea typeface="Poppins" pitchFamily="34" charset="-122"/>
                 <a:cs typeface="Poppins" pitchFamily="34" charset="-120"/>
               </a:rPr>
-              <a:t>Anton Lopez</a:t>
+              <a:t>Argenis Rafael Guevara</a:t>
             </a:r>
             <a:endParaRPr lang="en-US" sz="800" dirty="0"/>
           </a:p>
@@ -48575,7 +48575,7 @@
         </p:nvSpPr>
         <p:spPr>
           <a:xfrm>
-            <a:off x="2468880" y="4849063"/>
+            <a:off x="2468880" y="5172387"/>
             <a:ext cx="2377440" cy="59436"/>
           </a:xfrm>
           <a:prstGeom prst="roundRect">
@@ -48597,8 +48597,8 @@
         </p:nvSpPr>
         <p:spPr>
           <a:xfrm>
-            <a:off x="5029200" y="4782312"/>
-            <a:ext cx="822960" cy="192024"/>
+            <a:off x="5029200" y="5089052"/>
+            <a:ext cx="822960" cy="226106"/>
           </a:xfrm>
           <a:prstGeom prst="rect">
             <a:avLst/>
@@ -48636,8 +48636,8 @@
         </p:nvSpPr>
         <p:spPr>
           <a:xfrm>
-            <a:off x="5943600" y="4782312"/>
-            <a:ext cx="822960" cy="192024"/>
+            <a:off x="5943600" y="5089052"/>
+            <a:ext cx="822960" cy="226106"/>
           </a:xfrm>
           <a:prstGeom prst="rect">
             <a:avLst/>
@@ -48675,8 +48675,8 @@
         </p:nvSpPr>
         <p:spPr>
           <a:xfrm>
-            <a:off x="640080" y="4974336"/>
-            <a:ext cx="1783080" cy="192024"/>
+            <a:off x="640080" y="5315158"/>
+            <a:ext cx="1783080" cy="226106"/>
           </a:xfrm>
           <a:prstGeom prst="rect">
             <a:avLst/>
@@ -48700,7 +48700,7 @@
                 <a:ea typeface="Poppins" pitchFamily="34" charset="-122"/>
                 <a:cs typeface="Poppins" pitchFamily="34" charset="-120"/>
               </a:rPr>
-              <a:t>Jasmine Hikuroa</a:t>
+              <a:t>Isaac Mercado</a:t>
             </a:r>
             <a:endParaRPr lang="en-US" sz="800" dirty="0"/>
           </a:p>
@@ -48714,7 +48714,7 @@
         </p:nvSpPr>
         <p:spPr>
           <a:xfrm>
-            <a:off x="2468880" y="5041087"/>
+            <a:off x="2468880" y="5398493"/>
             <a:ext cx="2377440" cy="59436"/>
           </a:xfrm>
           <a:prstGeom prst="roundRect">
@@ -48736,8 +48736,8 @@
         </p:nvSpPr>
         <p:spPr>
           <a:xfrm>
-            <a:off x="5029200" y="4974336"/>
-            <a:ext cx="822960" cy="192024"/>
+            <a:off x="5029200" y="5315158"/>
+            <a:ext cx="822960" cy="226106"/>
           </a:xfrm>
           <a:prstGeom prst="rect">
             <a:avLst/>
@@ -48775,8 +48775,8 @@
         </p:nvSpPr>
         <p:spPr>
           <a:xfrm>
-            <a:off x="5943600" y="4974336"/>
-            <a:ext cx="822960" cy="192024"/>
+            <a:off x="5943600" y="5315158"/>
+            <a:ext cx="822960" cy="226106"/>
           </a:xfrm>
           <a:prstGeom prst="rect">
             <a:avLst/>
@@ -48809,284 +48809,6 @@
       <p:sp>
         <p:nvSpPr>
           <p:cNvPr id="93" name="Text 91"/>
-          <p:cNvSpPr txBox="1"/>
-          <p:nvPr/>
-        </p:nvSpPr>
-        <p:spPr>
-          <a:xfrm>
-            <a:off x="640080" y="5166360"/>
-            <a:ext cx="1783080" cy="192024"/>
-          </a:xfrm>
-          <a:prstGeom prst="rect">
-            <a:avLst/>
-          </a:prstGeom>
-          <a:noFill/>
-          <a:ln/>
-        </p:spPr>
-        <p:txBody>
-          <a:bodyPr wrap="square" lIns="0" tIns="0" rIns="0" bIns="0" rtlCol="0" anchor="ctr"/>
-          <a:lstStyle/>
-          <a:p>
-            <a:pPr indent="0" marL="0">
-              <a:buNone/>
-            </a:pPr>
-            <a:r>
-              <a:rPr lang="en-US" sz="800" dirty="0">
-                <a:solidFill>
-                  <a:srgbClr val="5E7280"/>
-                </a:solidFill>
-                <a:latin typeface="Poppins" pitchFamily="34" charset="0"/>
-                <a:ea typeface="Poppins" pitchFamily="34" charset="-122"/>
-                <a:cs typeface="Poppins" pitchFamily="34" charset="-120"/>
-              </a:rPr>
-              <a:t>Bjorn Magabo</a:t>
-            </a:r>
-            <a:endParaRPr lang="en-US" sz="800" dirty="0"/>
-          </a:p>
-        </p:txBody>
-      </p:sp>
-      <p:sp>
-        <p:nvSpPr>
-          <p:cNvPr id="94" name="Shape 92"/>
-          <p:cNvSpPr/>
-          <p:nvPr/>
-        </p:nvSpPr>
-        <p:spPr>
-          <a:xfrm>
-            <a:off x="2468880" y="5233111"/>
-            <a:ext cx="2377440" cy="59436"/>
-          </a:xfrm>
-          <a:prstGeom prst="roundRect">
-            <a:avLst>
-              <a:gd name="adj" fmla="val 49231"/>
-            </a:avLst>
-          </a:prstGeom>
-          <a:solidFill>
-            <a:srgbClr val="E2EAEE"/>
-          </a:solidFill>
-          <a:ln/>
-        </p:spPr>
-      </p:sp>
-      <p:sp>
-        <p:nvSpPr>
-          <p:cNvPr id="95" name="Text 93"/>
-          <p:cNvSpPr txBox="1"/>
-          <p:nvPr/>
-        </p:nvSpPr>
-        <p:spPr>
-          <a:xfrm>
-            <a:off x="5029200" y="5166360"/>
-            <a:ext cx="822960" cy="192024"/>
-          </a:xfrm>
-          <a:prstGeom prst="rect">
-            <a:avLst/>
-          </a:prstGeom>
-          <a:noFill/>
-          <a:ln/>
-        </p:spPr>
-        <p:txBody>
-          <a:bodyPr wrap="square" lIns="0" tIns="0" rIns="0" bIns="0" rtlCol="0" anchor="ctr"/>
-          <a:lstStyle/>
-          <a:p>
-            <a:pPr algn="r" indent="0" marL="0">
-              <a:buNone/>
-            </a:pPr>
-            <a:r>
-              <a:rPr lang="en-US" sz="800" dirty="0">
-                <a:solidFill>
-                  <a:srgbClr val="8FA1AC"/>
-                </a:solidFill>
-                <a:latin typeface="Poppins" pitchFamily="34" charset="0"/>
-                <a:ea typeface="Poppins" pitchFamily="34" charset="-122"/>
-                <a:cs typeface="Poppins" pitchFamily="34" charset="-120"/>
-              </a:rPr>
-              <a:t>—</a:t>
-            </a:r>
-            <a:endParaRPr lang="en-US" sz="800" dirty="0"/>
-          </a:p>
-        </p:txBody>
-      </p:sp>
-      <p:sp>
-        <p:nvSpPr>
-          <p:cNvPr id="96" name="Text 94"/>
-          <p:cNvSpPr txBox="1"/>
-          <p:nvPr/>
-        </p:nvSpPr>
-        <p:spPr>
-          <a:xfrm>
-            <a:off x="5943600" y="5166360"/>
-            <a:ext cx="822960" cy="192024"/>
-          </a:xfrm>
-          <a:prstGeom prst="rect">
-            <a:avLst/>
-          </a:prstGeom>
-          <a:noFill/>
-          <a:ln/>
-        </p:spPr>
-        <p:txBody>
-          <a:bodyPr wrap="square" lIns="0" tIns="0" rIns="0" bIns="0" rtlCol="0" anchor="ctr"/>
-          <a:lstStyle/>
-          <a:p>
-            <a:pPr algn="r" indent="0" marL="0">
-              <a:buNone/>
-            </a:pPr>
-            <a:r>
-              <a:rPr lang="en-US" sz="600" dirty="0">
-                <a:solidFill>
-                  <a:srgbClr val="8FA1AC"/>
-                </a:solidFill>
-                <a:latin typeface="Poppins" pitchFamily="34" charset="0"/>
-                <a:ea typeface="Poppins" pitchFamily="34" charset="-122"/>
-                <a:cs typeface="Poppins" pitchFamily="34" charset="-120"/>
-              </a:rPr>
-              <a:t>no time logged</a:t>
-            </a:r>
-            <a:endParaRPr lang="en-US" sz="600" dirty="0"/>
-          </a:p>
-        </p:txBody>
-      </p:sp>
-      <p:sp>
-        <p:nvSpPr>
-          <p:cNvPr id="97" name="Text 95"/>
-          <p:cNvSpPr txBox="1"/>
-          <p:nvPr/>
-        </p:nvSpPr>
-        <p:spPr>
-          <a:xfrm>
-            <a:off x="640080" y="5358384"/>
-            <a:ext cx="1783080" cy="192024"/>
-          </a:xfrm>
-          <a:prstGeom prst="rect">
-            <a:avLst/>
-          </a:prstGeom>
-          <a:noFill/>
-          <a:ln/>
-        </p:spPr>
-        <p:txBody>
-          <a:bodyPr wrap="square" lIns="0" tIns="0" rIns="0" bIns="0" rtlCol="0" anchor="ctr"/>
-          <a:lstStyle/>
-          <a:p>
-            <a:pPr indent="0" marL="0">
-              <a:buNone/>
-            </a:pPr>
-            <a:r>
-              <a:rPr lang="en-US" sz="800" dirty="0">
-                <a:solidFill>
-                  <a:srgbClr val="5E7280"/>
-                </a:solidFill>
-                <a:latin typeface="Poppins" pitchFamily="34" charset="0"/>
-                <a:ea typeface="Poppins" pitchFamily="34" charset="-122"/>
-                <a:cs typeface="Poppins" pitchFamily="34" charset="-120"/>
-              </a:rPr>
-              <a:t>Phuong Ho</a:t>
-            </a:r>
-            <a:endParaRPr lang="en-US" sz="800" dirty="0"/>
-          </a:p>
-        </p:txBody>
-      </p:sp>
-      <p:sp>
-        <p:nvSpPr>
-          <p:cNvPr id="98" name="Shape 96"/>
-          <p:cNvSpPr/>
-          <p:nvPr/>
-        </p:nvSpPr>
-        <p:spPr>
-          <a:xfrm>
-            <a:off x="2468880" y="5425135"/>
-            <a:ext cx="2377440" cy="59436"/>
-          </a:xfrm>
-          <a:prstGeom prst="roundRect">
-            <a:avLst>
-              <a:gd name="adj" fmla="val 49231"/>
-            </a:avLst>
-          </a:prstGeom>
-          <a:solidFill>
-            <a:srgbClr val="E2EAEE"/>
-          </a:solidFill>
-          <a:ln/>
-        </p:spPr>
-      </p:sp>
-      <p:sp>
-        <p:nvSpPr>
-          <p:cNvPr id="99" name="Text 97"/>
-          <p:cNvSpPr txBox="1"/>
-          <p:nvPr/>
-        </p:nvSpPr>
-        <p:spPr>
-          <a:xfrm>
-            <a:off x="5029200" y="5358384"/>
-            <a:ext cx="822960" cy="192024"/>
-          </a:xfrm>
-          <a:prstGeom prst="rect">
-            <a:avLst/>
-          </a:prstGeom>
-          <a:noFill/>
-          <a:ln/>
-        </p:spPr>
-        <p:txBody>
-          <a:bodyPr wrap="square" lIns="0" tIns="0" rIns="0" bIns="0" rtlCol="0" anchor="ctr"/>
-          <a:lstStyle/>
-          <a:p>
-            <a:pPr algn="r" indent="0" marL="0">
-              <a:buNone/>
-            </a:pPr>
-            <a:r>
-              <a:rPr lang="en-US" sz="800" dirty="0">
-                <a:solidFill>
-                  <a:srgbClr val="8FA1AC"/>
-                </a:solidFill>
-                <a:latin typeface="Poppins" pitchFamily="34" charset="0"/>
-                <a:ea typeface="Poppins" pitchFamily="34" charset="-122"/>
-                <a:cs typeface="Poppins" pitchFamily="34" charset="-120"/>
-              </a:rPr>
-              <a:t>—</a:t>
-            </a:r>
-            <a:endParaRPr lang="en-US" sz="800" dirty="0"/>
-          </a:p>
-        </p:txBody>
-      </p:sp>
-      <p:sp>
-        <p:nvSpPr>
-          <p:cNvPr id="100" name="Text 98"/>
-          <p:cNvSpPr txBox="1"/>
-          <p:nvPr/>
-        </p:nvSpPr>
-        <p:spPr>
-          <a:xfrm>
-            <a:off x="5943600" y="5358384"/>
-            <a:ext cx="822960" cy="192024"/>
-          </a:xfrm>
-          <a:prstGeom prst="rect">
-            <a:avLst/>
-          </a:prstGeom>
-          <a:noFill/>
-          <a:ln/>
-        </p:spPr>
-        <p:txBody>
-          <a:bodyPr wrap="square" lIns="0" tIns="0" rIns="0" bIns="0" rtlCol="0" anchor="ctr"/>
-          <a:lstStyle/>
-          <a:p>
-            <a:pPr algn="r" indent="0" marL="0">
-              <a:buNone/>
-            </a:pPr>
-            <a:r>
-              <a:rPr lang="en-US" sz="600" dirty="0">
-                <a:solidFill>
-                  <a:srgbClr val="8FA1AC"/>
-                </a:solidFill>
-                <a:latin typeface="Poppins" pitchFamily="34" charset="0"/>
-                <a:ea typeface="Poppins" pitchFamily="34" charset="-122"/>
-                <a:cs typeface="Poppins" pitchFamily="34" charset="-120"/>
-              </a:rPr>
-              <a:t>no time logged</a:t>
-            </a:r>
-            <a:endParaRPr lang="en-US" sz="600" dirty="0"/>
-          </a:p>
-        </p:txBody>
-      </p:sp>
-      <p:sp>
-        <p:nvSpPr>
-          <p:cNvPr id="101" name="Text 99"/>
           <p:cNvSpPr txBox="1"/>
           <p:nvPr/>
         </p:nvSpPr>
@@ -49117,7 +48839,7 @@
                 <a:ea typeface="Poppins" pitchFamily="34" charset="-122"/>
                 <a:cs typeface="Poppins" pitchFamily="34" charset="-120"/>
               </a:rPr>
-              <a:t>Available staff = the 13 Professional Services people assigned to PS-pipeline tickets open now or closed this week, at a 38h standard week. Argenis Rafael Guevara and Isaac Mercado carry PS-pipeline tickets but are not Professional Services staff — excluded from the capacity base.</a:t>
+              <a:t>Available staff = the 11 Professional Services people assigned to PS-pipeline tickets open now or closed this week, at a 38h standard week. Anton Lopez, Jasmine Hikuroa, Bjorn Magabo and Phuong Ho carry PS-pipeline tickets but are not Professional Services staff — excluded from the capacity base.</a:t>
             </a:r>
             <a:endParaRPr lang="en-US" sz="580" dirty="0"/>
           </a:p>
@@ -49125,7 +48847,7 @@
       </p:sp>
       <p:sp>
         <p:nvSpPr>
-          <p:cNvPr id="102" name="Shape 100"/>
+          <p:cNvPr id="94" name="Shape 92"/>
           <p:cNvSpPr/>
           <p:nvPr/>
         </p:nvSpPr>
@@ -49154,7 +48876,7 @@
       </p:sp>
       <p:sp>
         <p:nvSpPr>
-          <p:cNvPr id="103" name="Text 101"/>
+          <p:cNvPr id="95" name="Text 93"/>
           <p:cNvSpPr txBox="1"/>
           <p:nvPr/>
         </p:nvSpPr>
@@ -49207,7 +48929,7 @@
       </p:sp>
       <p:sp>
         <p:nvSpPr>
-          <p:cNvPr id="104" name="Text 102"/>
+          <p:cNvPr id="96" name="Text 94"/>
           <p:cNvSpPr txBox="1"/>
           <p:nvPr/>
         </p:nvSpPr>
@@ -49246,7 +48968,7 @@
       </p:sp>
       <p:sp>
         <p:nvSpPr>
-          <p:cNvPr id="105" name="Text 103"/>
+          <p:cNvPr id="97" name="Text 95"/>
           <p:cNvSpPr txBox="1"/>
           <p:nvPr/>
         </p:nvSpPr>
@@ -49285,7 +49007,7 @@
       </p:sp>
       <p:sp>
         <p:nvSpPr>
-          <p:cNvPr id="106" name="Text 104"/>
+          <p:cNvPr id="98" name="Text 96"/>
           <p:cNvSpPr txBox="1"/>
           <p:nvPr/>
         </p:nvSpPr>
@@ -49324,7 +49046,7 @@
       </p:sp>
       <p:sp>
         <p:nvSpPr>
-          <p:cNvPr id="107" name="Text 105"/>
+          <p:cNvPr id="99" name="Text 97"/>
           <p:cNvSpPr txBox="1"/>
           <p:nvPr/>
         </p:nvSpPr>
@@ -49363,7 +49085,7 @@
       </p:sp>
       <p:sp>
         <p:nvSpPr>
-          <p:cNvPr id="108" name="Shape 106"/>
+          <p:cNvPr id="100" name="Shape 98"/>
           <p:cNvSpPr/>
           <p:nvPr/>
         </p:nvSpPr>
@@ -49385,7 +49107,7 @@
       </p:sp>
       <p:sp>
         <p:nvSpPr>
-          <p:cNvPr id="109" name="Shape 107"/>
+          <p:cNvPr id="101" name="Shape 99"/>
           <p:cNvSpPr/>
           <p:nvPr/>
         </p:nvSpPr>
@@ -49407,7 +49129,7 @@
       </p:sp>
       <p:sp>
         <p:nvSpPr>
-          <p:cNvPr id="110" name="Text 108"/>
+          <p:cNvPr id="102" name="Text 100"/>
           <p:cNvSpPr txBox="1"/>
           <p:nvPr/>
         </p:nvSpPr>
@@ -49446,7 +49168,7 @@
       </p:sp>
       <p:sp>
         <p:nvSpPr>
-          <p:cNvPr id="111" name="Text 109"/>
+          <p:cNvPr id="103" name="Text 101"/>
           <p:cNvSpPr txBox="1"/>
           <p:nvPr/>
         </p:nvSpPr>
@@ -49485,7 +49207,7 @@
       </p:sp>
       <p:sp>
         <p:nvSpPr>
-          <p:cNvPr id="112" name="Text 110"/>
+          <p:cNvPr id="104" name="Text 102"/>
           <p:cNvSpPr txBox="1"/>
           <p:nvPr/>
         </p:nvSpPr>
@@ -49524,7 +49246,7 @@
       </p:sp>
       <p:sp>
         <p:nvSpPr>
-          <p:cNvPr id="113" name="Shape 111"/>
+          <p:cNvPr id="105" name="Shape 103"/>
           <p:cNvSpPr/>
           <p:nvPr/>
         </p:nvSpPr>
@@ -49546,7 +49268,7 @@
       </p:sp>
       <p:sp>
         <p:nvSpPr>
-          <p:cNvPr id="114" name="Shape 112"/>
+          <p:cNvPr id="106" name="Shape 104"/>
           <p:cNvSpPr/>
           <p:nvPr/>
         </p:nvSpPr>
@@ -49568,7 +49290,7 @@
       </p:sp>
       <p:sp>
         <p:nvSpPr>
-          <p:cNvPr id="115" name="Text 113"/>
+          <p:cNvPr id="107" name="Text 105"/>
           <p:cNvSpPr txBox="1"/>
           <p:nvPr/>
         </p:nvSpPr>
@@ -49607,7 +49329,7 @@
       </p:sp>
       <p:sp>
         <p:nvSpPr>
-          <p:cNvPr id="116" name="Text 114"/>
+          <p:cNvPr id="108" name="Text 106"/>
           <p:cNvSpPr txBox="1"/>
           <p:nvPr/>
         </p:nvSpPr>
@@ -49646,7 +49368,7 @@
       </p:sp>
       <p:sp>
         <p:nvSpPr>
-          <p:cNvPr id="117" name="Text 115"/>
+          <p:cNvPr id="109" name="Text 107"/>
           <p:cNvSpPr txBox="1"/>
           <p:nvPr/>
         </p:nvSpPr>
@@ -49685,7 +49407,7 @@
       </p:sp>
       <p:sp>
         <p:nvSpPr>
-          <p:cNvPr id="118" name="Shape 116"/>
+          <p:cNvPr id="110" name="Shape 108"/>
           <p:cNvSpPr/>
           <p:nvPr/>
         </p:nvSpPr>
@@ -49707,7 +49429,7 @@
       </p:sp>
       <p:sp>
         <p:nvSpPr>
-          <p:cNvPr id="119" name="Text 117"/>
+          <p:cNvPr id="111" name="Text 109"/>
           <p:cNvSpPr txBox="1"/>
           <p:nvPr/>
         </p:nvSpPr>
@@ -49746,7 +49468,7 @@
       </p:sp>
       <p:sp>
         <p:nvSpPr>
-          <p:cNvPr id="120" name="Text 118"/>
+          <p:cNvPr id="112" name="Text 110"/>
           <p:cNvSpPr txBox="1"/>
           <p:nvPr/>
         </p:nvSpPr>
@@ -49785,7 +49507,7 @@
       </p:sp>
       <p:sp>
         <p:nvSpPr>
-          <p:cNvPr id="121" name="Text 119"/>
+          <p:cNvPr id="113" name="Text 111"/>
           <p:cNvSpPr txBox="1"/>
           <p:nvPr/>
         </p:nvSpPr>
@@ -49824,7 +49546,7 @@
       </p:sp>
       <p:sp>
         <p:nvSpPr>
-          <p:cNvPr id="122" name="Shape 120"/>
+          <p:cNvPr id="114" name="Shape 112"/>
           <p:cNvSpPr/>
           <p:nvPr/>
         </p:nvSpPr>
@@ -49846,7 +49568,7 @@
       </p:sp>
       <p:sp>
         <p:nvSpPr>
-          <p:cNvPr id="123" name="Text 121"/>
+          <p:cNvPr id="115" name="Text 113"/>
           <p:cNvSpPr txBox="1"/>
           <p:nvPr/>
         </p:nvSpPr>
@@ -49885,7 +49607,7 @@
       </p:sp>
       <p:sp>
         <p:nvSpPr>
-          <p:cNvPr id="124" name="Text 122"/>
+          <p:cNvPr id="116" name="Text 114"/>
           <p:cNvSpPr txBox="1"/>
           <p:nvPr/>
         </p:nvSpPr>
@@ -49924,7 +49646,7 @@
       </p:sp>
       <p:sp>
         <p:nvSpPr>
-          <p:cNvPr id="125" name="Text 123"/>
+          <p:cNvPr id="117" name="Text 115"/>
           <p:cNvSpPr txBox="1"/>
           <p:nvPr/>
         </p:nvSpPr>
@@ -49963,7 +49685,7 @@
       </p:sp>
       <p:sp>
         <p:nvSpPr>
-          <p:cNvPr id="126" name="Shape 124"/>
+          <p:cNvPr id="118" name="Shape 116"/>
           <p:cNvSpPr/>
           <p:nvPr/>
         </p:nvSpPr>
@@ -49985,7 +49707,7 @@
       </p:sp>
       <p:sp>
         <p:nvSpPr>
-          <p:cNvPr id="127" name="Text 125"/>
+          <p:cNvPr id="119" name="Text 117"/>
           <p:cNvSpPr txBox="1"/>
           <p:nvPr/>
         </p:nvSpPr>
@@ -50024,7 +49746,7 @@
       </p:sp>
       <p:sp>
         <p:nvSpPr>
-          <p:cNvPr id="128" name="Text 126"/>
+          <p:cNvPr id="120" name="Text 118"/>
           <p:cNvSpPr txBox="1"/>
           <p:nvPr/>
         </p:nvSpPr>
@@ -50063,7 +49785,7 @@
       </p:sp>
       <p:sp>
         <p:nvSpPr>
-          <p:cNvPr id="129" name="Shape 127"/>
+          <p:cNvPr id="121" name="Shape 119"/>
           <p:cNvSpPr/>
           <p:nvPr/>
         </p:nvSpPr>
@@ -50092,7 +49814,7 @@
       </p:sp>
       <p:sp>
         <p:nvSpPr>
-          <p:cNvPr id="130" name="Text 128"/>
+          <p:cNvPr id="122" name="Text 120"/>
           <p:cNvSpPr txBox="1"/>
           <p:nvPr/>
         </p:nvSpPr>
@@ -50131,7 +49853,7 @@
       </p:sp>
       <p:sp>
         <p:nvSpPr>
-          <p:cNvPr id="131" name="Text 129"/>
+          <p:cNvPr id="123" name="Text 121"/>
           <p:cNvSpPr txBox="1"/>
           <p:nvPr/>
         </p:nvSpPr>
@@ -50176,7 +49898,7 @@
                 <a:ea typeface="Poppins" pitchFamily="34" charset="-122"/>
                 <a:cs typeface="Poppins" pitchFamily="34" charset="-120"/>
               </a:rPr>
-              <a:t>6.7% billable utilisation is a logging number, not a delivery number. </a:t>
+              <a:t>7.9% billable utilisation is a logging number, not a delivery number. </a:t>
             </a:r>
             <a:pPr indent="0" marL="0">
               <a:spcAft>
@@ -50193,7 +49915,7 @@
                 <a:ea typeface="Poppins" pitchFamily="34" charset="-122"/>
                 <a:cs typeface="Poppins" pitchFamily="34" charset="-120"/>
               </a:rPr>
-              <a:t>33.01h landed against 494h of capacity, but only 13% of the week's 132 PS items carry hours.</a:t>
+              <a:t>33.01h landed against 418h of capacity, but only 13% of the week's 132 PS items carry hours.</a:t>
             </a:r>
             <a:endParaRPr lang="en-US" sz="900" dirty="0"/>
           </a:p>
@@ -50241,7 +49963,7 @@
                 <a:ea typeface="Poppins" pitchFamily="34" charset="-122"/>
                 <a:cs typeface="Poppins" pitchFamily="34" charset="-120"/>
               </a:rPr>
-              <a:t>Katherine Fenwick 38.2% and Rhys Woolcock 36.4%; the other 7 PS members logged nothing at all.</a:t>
+              <a:t>Katherine Fenwick 38.2% and Rhys Woolcock 36.4%; the other 5 PS members logged nothing at all.</a:t>
             </a:r>
             <a:endParaRPr lang="en-US" sz="900" dirty="0"/>
           </a:p>
@@ -50297,7 +50019,7 @@
       </p:sp>
       <p:sp>
         <p:nvSpPr>
-          <p:cNvPr id="132" name="Text 130"/>
+          <p:cNvPr id="124" name="Text 122"/>
           <p:cNvSpPr txBox="1"/>
           <p:nvPr/>
         </p:nvSpPr>
@@ -50336,7 +50058,7 @@
       </p:sp>
       <p:sp>
         <p:nvSpPr>
-          <p:cNvPr id="133" name="Shape 131"/>
+          <p:cNvPr id="125" name="Shape 123"/>
           <p:cNvSpPr/>
           <p:nvPr/>
         </p:nvSpPr>
@@ -50358,7 +50080,7 @@
       </p:sp>
       <p:sp>
         <p:nvSpPr>
-          <p:cNvPr id="134" name="Text 132"/>
+          <p:cNvPr id="126" name="Text 124"/>
           <p:cNvSpPr txBox="1"/>
           <p:nvPr/>
         </p:nvSpPr>

</xml_diff>

<commit_message>
Utilisation: exclude Fenwick and Hettiarachchy, add TOTAL rows
Katherine Fenwick and Yeran Hettiarachchy are not Professional Services
staff, so both they and their hours come out. Unlike the earlier
exclusions they had logged time, so every figure moves:

  staff        11 -> 9      available   418h -> 342h
  billed    33.01h -> 16.07h  utilisation 7.9% -> 4.7%
  items         17 -> 13      coverage     13% -> 10%
  Tech       31.44h -> 16.00h (99.6%)  Integration 1.57h -> 0.07h

Both tables now close with a TOTAL row: billable-by-employee totals the
hours and the overall utilisation against the capacity line, billable-by-
PS-work totals the hours and the item count carrying time.

The 'Warranty Test' hygiene note is dropped — that record was Yeran's and
is no longer in the totals.

Co-Authored-By: Claude Opus 5 <noreply@anthropic.com>
Claude-Session: https://claude.ai/code/session_019YTPNjRj34XzLPLC9gKxc4
</commit_message>
<xml_diff>
--- a/exec-deck/output/H&L Weekly Update - WC 14 Sep 2026.pptx
+++ b/exec-deck/output/H&L Weekly Update - WC 14 Sep 2026.pptx
@@ -46275,7 +46275,7 @@
                 <a:ea typeface="Poppins" pitchFamily="34" charset="-122"/>
                 <a:cs typeface="Poppins" pitchFamily="34" charset="-120"/>
               </a:rPr>
-              <a:t>7.9%</a:t>
+              <a:t>4.7%</a:t>
             </a:r>
             <a:endParaRPr lang="en-US" sz="2600" dirty="0"/>
           </a:p>
@@ -46314,7 +46314,7 @@
                 <a:ea typeface="Poppins" pitchFamily="34" charset="-122"/>
                 <a:cs typeface="Poppins" pitchFamily="34" charset="-120"/>
               </a:rPr>
-              <a:t>33.01h billed of 418h available · target 80%</a:t>
+              <a:t>16.07h billed of 342h available · target 80%</a:t>
             </a:r>
             <a:endParaRPr lang="en-US" sz="780" dirty="0"/>
           </a:p>
@@ -46421,7 +46421,7 @@
                 <a:ea typeface="Poppins" pitchFamily="34" charset="-122"/>
                 <a:cs typeface="Poppins" pitchFamily="34" charset="-120"/>
               </a:rPr>
-              <a:t>418h</a:t>
+              <a:t>342h</a:t>
             </a:r>
             <a:endParaRPr lang="en-US" sz="2600" dirty="0"/>
           </a:p>
@@ -46460,7 +46460,7 @@
                 <a:ea typeface="Poppins" pitchFamily="34" charset="-122"/>
                 <a:cs typeface="Poppins" pitchFamily="34" charset="-120"/>
               </a:rPr>
-              <a:t>11 people assigned to PS-pipeline tickets × 38h standard week</a:t>
+              <a:t>9 people assigned to PS-pipeline tickets × 38h standard week</a:t>
             </a:r>
             <a:endParaRPr lang="en-US" sz="780" dirty="0"/>
           </a:p>
@@ -46567,7 +46567,7 @@
                 <a:ea typeface="Poppins" pitchFamily="34" charset="-122"/>
                 <a:cs typeface="Poppins" pitchFamily="34" charset="-120"/>
               </a:rPr>
-              <a:t>13%</a:t>
+              <a:t>10%</a:t>
             </a:r>
             <a:endParaRPr lang="en-US" sz="2600" dirty="0"/>
           </a:p>
@@ -46606,7 +46606,7 @@
                 <a:ea typeface="Poppins" pitchFamily="34" charset="-122"/>
                 <a:cs typeface="Poppins" pitchFamily="34" charset="-120"/>
               </a:rPr>
-              <a:t>17 of 132 PS items raised this week carry hours — utilisation reads low because logging is ramping, not because delivery stopped</a:t>
+              <a:t>13 of 132 PS items raised this week carry hours — utilisation reads low because logging is ramping, not because delivery stopped</a:t>
             </a:r>
             <a:endParaRPr lang="en-US" sz="780" dirty="0"/>
           </a:p>
@@ -46898,7 +46898,7 @@
         <p:spPr>
           <a:xfrm>
             <a:off x="2944368" y="3017520"/>
-            <a:ext cx="5486" cy="2487168"/>
+            <a:ext cx="5486" cy="2139696"/>
           </a:xfrm>
           <a:prstGeom prst="rect">
             <a:avLst/>
@@ -46957,7 +46957,7 @@
         <p:spPr>
           <a:xfrm>
             <a:off x="3419856" y="3017520"/>
-            <a:ext cx="5486" cy="2487168"/>
+            <a:ext cx="5486" cy="2139696"/>
           </a:xfrm>
           <a:prstGeom prst="rect">
             <a:avLst/>
@@ -47016,7 +47016,7 @@
         <p:spPr>
           <a:xfrm>
             <a:off x="3895344" y="3017520"/>
-            <a:ext cx="5486" cy="2487168"/>
+            <a:ext cx="5486" cy="2139696"/>
           </a:xfrm>
           <a:prstGeom prst="rect">
             <a:avLst/>
@@ -47075,7 +47075,7 @@
         <p:spPr>
           <a:xfrm>
             <a:off x="4370832" y="3017520"/>
-            <a:ext cx="5486" cy="2487168"/>
+            <a:ext cx="5486" cy="2139696"/>
           </a:xfrm>
           <a:prstGeom prst="rect">
             <a:avLst/>
@@ -47134,7 +47134,7 @@
         <p:spPr>
           <a:xfrm>
             <a:off x="4846320" y="3017520"/>
-            <a:ext cx="5486" cy="2487168"/>
+            <a:ext cx="5486" cy="2139696"/>
           </a:xfrm>
           <a:prstGeom prst="rect">
             <a:avLst/>
@@ -47154,7 +47154,7 @@
         <p:spPr>
           <a:xfrm>
             <a:off x="640080" y="3054096"/>
-            <a:ext cx="1783080" cy="226106"/>
+            <a:ext cx="1783080" cy="237744"/>
           </a:xfrm>
           <a:prstGeom prst="rect">
             <a:avLst/>
@@ -47178,7 +47178,7 @@
                 <a:ea typeface="Poppins" pitchFamily="34" charset="-122"/>
                 <a:cs typeface="Poppins" pitchFamily="34" charset="-120"/>
               </a:rPr>
-              <a:t>Katherine Fenwick</a:t>
+              <a:t>Rhys Woolcock</a:t>
             </a:r>
             <a:endParaRPr lang="en-US" sz="800" dirty="0"/>
           </a:p>
@@ -47192,7 +47192,7 @@
         </p:nvSpPr>
         <p:spPr>
           <a:xfrm>
-            <a:off x="2468880" y="3137431"/>
+            <a:off x="2468880" y="3143250"/>
             <a:ext cx="2377440" cy="59436"/>
           </a:xfrm>
           <a:prstGeom prst="roundRect">
@@ -47214,8 +47214,8 @@
         </p:nvSpPr>
         <p:spPr>
           <a:xfrm>
-            <a:off x="2468880" y="3137431"/>
-            <a:ext cx="908182" cy="59436"/>
+            <a:off x="2468880" y="3143250"/>
+            <a:ext cx="865388" cy="59436"/>
           </a:xfrm>
           <a:prstGeom prst="roundRect">
             <a:avLst>
@@ -47237,7 +47237,7 @@
         <p:spPr>
           <a:xfrm>
             <a:off x="5029200" y="3054096"/>
-            <a:ext cx="822960" cy="226106"/>
+            <a:ext cx="822960" cy="237744"/>
           </a:xfrm>
           <a:prstGeom prst="rect">
             <a:avLst/>
@@ -47261,7 +47261,7 @@
                 <a:ea typeface="Poppins" pitchFamily="34" charset="-122"/>
                 <a:cs typeface="Poppins" pitchFamily="34" charset="-120"/>
               </a:rPr>
-              <a:t>14.50h</a:t>
+              <a:t>13.82h</a:t>
             </a:r>
             <a:endParaRPr lang="en-US" sz="800" dirty="0"/>
           </a:p>
@@ -47276,7 +47276,7 @@
         <p:spPr>
           <a:xfrm>
             <a:off x="5943600" y="3054096"/>
-            <a:ext cx="822960" cy="226106"/>
+            <a:ext cx="822960" cy="237744"/>
           </a:xfrm>
           <a:prstGeom prst="rect">
             <a:avLst/>
@@ -47300,7 +47300,7 @@
                 <a:ea typeface="Poppins" pitchFamily="34" charset="-122"/>
                 <a:cs typeface="Poppins" pitchFamily="34" charset="-120"/>
               </a:rPr>
-              <a:t>38.2%</a:t>
+              <a:t>36.4%</a:t>
             </a:r>
             <a:endParaRPr lang="en-US" sz="800" dirty="0"/>
           </a:p>
@@ -47314,8 +47314,8 @@
         </p:nvSpPr>
         <p:spPr>
           <a:xfrm>
-            <a:off x="640080" y="3280202"/>
-            <a:ext cx="1783080" cy="226106"/>
+            <a:off x="640080" y="3291840"/>
+            <a:ext cx="1783080" cy="237744"/>
           </a:xfrm>
           <a:prstGeom prst="rect">
             <a:avLst/>
@@ -47339,7 +47339,7 @@
                 <a:ea typeface="Poppins" pitchFamily="34" charset="-122"/>
                 <a:cs typeface="Poppins" pitchFamily="34" charset="-120"/>
               </a:rPr>
-              <a:t>Rhys Woolcock</a:t>
+              <a:t>Gregory St Clare-Hobbs</a:t>
             </a:r>
             <a:endParaRPr lang="en-US" sz="800" dirty="0"/>
           </a:p>
@@ -47353,7 +47353,7 @@
         </p:nvSpPr>
         <p:spPr>
           <a:xfrm>
-            <a:off x="2468880" y="3363537"/>
+            <a:off x="2468880" y="3380994"/>
             <a:ext cx="2377440" cy="59436"/>
           </a:xfrm>
           <a:prstGeom prst="roundRect">
@@ -47375,8 +47375,8 @@
         </p:nvSpPr>
         <p:spPr>
           <a:xfrm>
-            <a:off x="2468880" y="3363537"/>
-            <a:ext cx="865388" cy="59436"/>
+            <a:off x="2468880" y="3380994"/>
+            <a:ext cx="92720" cy="59436"/>
           </a:xfrm>
           <a:prstGeom prst="roundRect">
             <a:avLst>
@@ -47397,8 +47397,8 @@
         </p:nvSpPr>
         <p:spPr>
           <a:xfrm>
-            <a:off x="5029200" y="3280202"/>
-            <a:ext cx="822960" cy="226106"/>
+            <a:off x="5029200" y="3291840"/>
+            <a:ext cx="822960" cy="237744"/>
           </a:xfrm>
           <a:prstGeom prst="rect">
             <a:avLst/>
@@ -47422,7 +47422,7 @@
                 <a:ea typeface="Poppins" pitchFamily="34" charset="-122"/>
                 <a:cs typeface="Poppins" pitchFamily="34" charset="-120"/>
               </a:rPr>
-              <a:t>13.82h</a:t>
+              <a:t>1.50h</a:t>
             </a:r>
             <a:endParaRPr lang="en-US" sz="800" dirty="0"/>
           </a:p>
@@ -47436,8 +47436,8 @@
         </p:nvSpPr>
         <p:spPr>
           <a:xfrm>
-            <a:off x="5943600" y="3280202"/>
-            <a:ext cx="822960" cy="226106"/>
+            <a:off x="5943600" y="3291840"/>
+            <a:ext cx="822960" cy="237744"/>
           </a:xfrm>
           <a:prstGeom prst="rect">
             <a:avLst/>
@@ -47461,7 +47461,7 @@
                 <a:ea typeface="Poppins" pitchFamily="34" charset="-122"/>
                 <a:cs typeface="Poppins" pitchFamily="34" charset="-120"/>
               </a:rPr>
-              <a:t>36.4%</a:t>
+              <a:t>3.9%</a:t>
             </a:r>
             <a:endParaRPr lang="en-US" sz="800" dirty="0"/>
           </a:p>
@@ -47475,8 +47475,8 @@
         </p:nvSpPr>
         <p:spPr>
           <a:xfrm>
-            <a:off x="640080" y="3506308"/>
-            <a:ext cx="1783080" cy="226106"/>
+            <a:off x="640080" y="3529584"/>
+            <a:ext cx="1783080" cy="237744"/>
           </a:xfrm>
           <a:prstGeom prst="rect">
             <a:avLst/>
@@ -47500,7 +47500,7 @@
                 <a:ea typeface="Poppins" pitchFamily="34" charset="-122"/>
                 <a:cs typeface="Poppins" pitchFamily="34" charset="-120"/>
               </a:rPr>
-              <a:t>Yeran Hettiarachchy</a:t>
+              <a:t>Isayah Kuhlmann</a:t>
             </a:r>
             <a:endParaRPr lang="en-US" sz="800" dirty="0"/>
           </a:p>
@@ -47514,7 +47514,7 @@
         </p:nvSpPr>
         <p:spPr>
           <a:xfrm>
-            <a:off x="2468880" y="3589643"/>
+            <a:off x="2468880" y="3618738"/>
             <a:ext cx="2377440" cy="59436"/>
           </a:xfrm>
           <a:prstGeom prst="roundRect">
@@ -47536,8 +47536,147 @@
         </p:nvSpPr>
         <p:spPr>
           <a:xfrm>
-            <a:off x="2468880" y="3589643"/>
-            <a:ext cx="152156" cy="59436"/>
+            <a:off x="2468880" y="3618738"/>
+            <a:ext cx="45720" cy="59436"/>
+          </a:xfrm>
+          <a:prstGeom prst="roundRect">
+            <a:avLst>
+              <a:gd name="adj" fmla="val 64000"/>
+            </a:avLst>
+          </a:prstGeom>
+          <a:solidFill>
+            <a:srgbClr val="2C8394"/>
+          </a:solidFill>
+          <a:ln/>
+        </p:spPr>
+      </p:sp>
+      <p:sp>
+        <p:nvSpPr>
+          <p:cNvPr id="56" name="Text 54"/>
+          <p:cNvSpPr txBox="1"/>
+          <p:nvPr/>
+        </p:nvSpPr>
+        <p:spPr>
+          <a:xfrm>
+            <a:off x="5029200" y="3529584"/>
+            <a:ext cx="822960" cy="237744"/>
+          </a:xfrm>
+          <a:prstGeom prst="rect">
+            <a:avLst/>
+          </a:prstGeom>
+          <a:noFill/>
+          <a:ln/>
+        </p:spPr>
+        <p:txBody>
+          <a:bodyPr wrap="square" lIns="0" tIns="0" rIns="0" bIns="0" rtlCol="0" anchor="ctr"/>
+          <a:lstStyle/>
+          <a:p>
+            <a:pPr algn="r" indent="0" marL="0">
+              <a:buNone/>
+            </a:pPr>
+            <a:r>
+              <a:rPr lang="en-US" sz="800" b="1" dirty="0">
+                <a:solidFill>
+                  <a:srgbClr val="2C8394"/>
+                </a:solidFill>
+                <a:latin typeface="Poppins" pitchFamily="34" charset="0"/>
+                <a:ea typeface="Poppins" pitchFamily="34" charset="-122"/>
+                <a:cs typeface="Poppins" pitchFamily="34" charset="-120"/>
+              </a:rPr>
+              <a:t>0.50h</a:t>
+            </a:r>
+            <a:endParaRPr lang="en-US" sz="800" dirty="0"/>
+          </a:p>
+        </p:txBody>
+      </p:sp>
+      <p:sp>
+        <p:nvSpPr>
+          <p:cNvPr id="57" name="Text 55"/>
+          <p:cNvSpPr txBox="1"/>
+          <p:nvPr/>
+        </p:nvSpPr>
+        <p:spPr>
+          <a:xfrm>
+            <a:off x="5943600" y="3529584"/>
+            <a:ext cx="822960" cy="237744"/>
+          </a:xfrm>
+          <a:prstGeom prst="rect">
+            <a:avLst/>
+          </a:prstGeom>
+          <a:noFill/>
+          <a:ln/>
+        </p:spPr>
+        <p:txBody>
+          <a:bodyPr wrap="square" lIns="0" tIns="0" rIns="0" bIns="0" rtlCol="0" anchor="ctr"/>
+          <a:lstStyle/>
+          <a:p>
+            <a:pPr algn="r" indent="0" marL="0">
+              <a:buNone/>
+            </a:pPr>
+            <a:r>
+              <a:rPr lang="en-US" sz="800" b="1" dirty="0">
+                <a:solidFill>
+                  <a:srgbClr val="12293A"/>
+                </a:solidFill>
+                <a:latin typeface="Poppins" pitchFamily="34" charset="0"/>
+                <a:ea typeface="Poppins" pitchFamily="34" charset="-122"/>
+                <a:cs typeface="Poppins" pitchFamily="34" charset="-120"/>
+              </a:rPr>
+              <a:t>1.3%</a:t>
+            </a:r>
+            <a:endParaRPr lang="en-US" sz="800" dirty="0"/>
+          </a:p>
+        </p:txBody>
+      </p:sp>
+      <p:sp>
+        <p:nvSpPr>
+          <p:cNvPr id="58" name="Text 56"/>
+          <p:cNvSpPr txBox="1"/>
+          <p:nvPr/>
+        </p:nvSpPr>
+        <p:spPr>
+          <a:xfrm>
+            <a:off x="640080" y="3767328"/>
+            <a:ext cx="1783080" cy="237744"/>
+          </a:xfrm>
+          <a:prstGeom prst="rect">
+            <a:avLst/>
+          </a:prstGeom>
+          <a:noFill/>
+          <a:ln/>
+        </p:spPr>
+        <p:txBody>
+          <a:bodyPr wrap="square" lIns="0" tIns="0" rIns="0" bIns="0" rtlCol="0" anchor="ctr"/>
+          <a:lstStyle/>
+          <a:p>
+            <a:pPr indent="0" marL="0">
+              <a:buNone/>
+            </a:pPr>
+            <a:r>
+              <a:rPr lang="en-US" sz="800" b="1" dirty="0">
+                <a:solidFill>
+                  <a:srgbClr val="12293A"/>
+                </a:solidFill>
+                <a:latin typeface="Poppins" pitchFamily="34" charset="0"/>
+                <a:ea typeface="Poppins" pitchFamily="34" charset="-122"/>
+                <a:cs typeface="Poppins" pitchFamily="34" charset="-120"/>
+              </a:rPr>
+              <a:t>Joshua Casey</a:t>
+            </a:r>
+            <a:endParaRPr lang="en-US" sz="800" dirty="0"/>
+          </a:p>
+        </p:txBody>
+      </p:sp>
+      <p:sp>
+        <p:nvSpPr>
+          <p:cNvPr id="59" name="Shape 57"/>
+          <p:cNvSpPr/>
+          <p:nvPr/>
+        </p:nvSpPr>
+        <p:spPr>
+          <a:xfrm>
+            <a:off x="2468880" y="3856482"/>
+            <a:ext cx="2377440" cy="59436"/>
           </a:xfrm>
           <a:prstGeom prst="roundRect">
             <a:avLst>
@@ -47545,6 +47684,28 @@
             </a:avLst>
           </a:prstGeom>
           <a:solidFill>
+            <a:srgbClr val="E2EAEE"/>
+          </a:solidFill>
+          <a:ln/>
+        </p:spPr>
+      </p:sp>
+      <p:sp>
+        <p:nvSpPr>
+          <p:cNvPr id="60" name="Shape 58"/>
+          <p:cNvSpPr/>
+          <p:nvPr/>
+        </p:nvSpPr>
+        <p:spPr>
+          <a:xfrm>
+            <a:off x="2468880" y="3856482"/>
+            <a:ext cx="45720" cy="59436"/>
+          </a:xfrm>
+          <a:prstGeom prst="roundRect">
+            <a:avLst>
+              <a:gd name="adj" fmla="val 64000"/>
+            </a:avLst>
+          </a:prstGeom>
+          <a:solidFill>
             <a:srgbClr val="2C8394"/>
           </a:solidFill>
           <a:ln/>
@@ -47552,14 +47713,14 @@
       </p:sp>
       <p:sp>
         <p:nvSpPr>
-          <p:cNvPr id="56" name="Text 54"/>
-          <p:cNvSpPr txBox="1"/>
-          <p:nvPr/>
-        </p:nvSpPr>
-        <p:spPr>
-          <a:xfrm>
-            <a:off x="5029200" y="3506308"/>
-            <a:ext cx="822960" cy="226106"/>
+          <p:cNvPr id="61" name="Text 59"/>
+          <p:cNvSpPr txBox="1"/>
+          <p:nvPr/>
+        </p:nvSpPr>
+        <p:spPr>
+          <a:xfrm>
+            <a:off x="5029200" y="3767328"/>
+            <a:ext cx="822960" cy="237744"/>
           </a:xfrm>
           <a:prstGeom prst="rect">
             <a:avLst/>
@@ -47583,7 +47744,7 @@
                 <a:ea typeface="Poppins" pitchFamily="34" charset="-122"/>
                 <a:cs typeface="Poppins" pitchFamily="34" charset="-120"/>
               </a:rPr>
-              <a:t>2.44h</a:t>
+              <a:t>0.25h</a:t>
             </a:r>
             <a:endParaRPr lang="en-US" sz="800" dirty="0"/>
           </a:p>
@@ -47591,14 +47752,14 @@
       </p:sp>
       <p:sp>
         <p:nvSpPr>
-          <p:cNvPr id="57" name="Text 55"/>
-          <p:cNvSpPr txBox="1"/>
-          <p:nvPr/>
-        </p:nvSpPr>
-        <p:spPr>
-          <a:xfrm>
-            <a:off x="5943600" y="3506308"/>
-            <a:ext cx="822960" cy="226106"/>
+          <p:cNvPr id="62" name="Text 60"/>
+          <p:cNvSpPr txBox="1"/>
+          <p:nvPr/>
+        </p:nvSpPr>
+        <p:spPr>
+          <a:xfrm>
+            <a:off x="5943600" y="3767328"/>
+            <a:ext cx="822960" cy="237744"/>
           </a:xfrm>
           <a:prstGeom prst="rect">
             <a:avLst/>
@@ -47622,7 +47783,7 @@
                 <a:ea typeface="Poppins" pitchFamily="34" charset="-122"/>
                 <a:cs typeface="Poppins" pitchFamily="34" charset="-120"/>
               </a:rPr>
-              <a:t>6.4%</a:t>
+              <a:t>0.7%</a:t>
             </a:r>
             <a:endParaRPr lang="en-US" sz="800" dirty="0"/>
           </a:p>
@@ -47630,38 +47791,38 @@
       </p:sp>
       <p:sp>
         <p:nvSpPr>
-          <p:cNvPr id="58" name="Text 56"/>
-          <p:cNvSpPr txBox="1"/>
-          <p:nvPr/>
-        </p:nvSpPr>
-        <p:spPr>
-          <a:xfrm>
-            <a:off x="640080" y="3732415"/>
-            <a:ext cx="1783080" cy="226106"/>
-          </a:xfrm>
-          <a:prstGeom prst="rect">
-            <a:avLst/>
-          </a:prstGeom>
-          <a:noFill/>
-          <a:ln/>
-        </p:spPr>
-        <p:txBody>
-          <a:bodyPr wrap="square" lIns="0" tIns="0" rIns="0" bIns="0" rtlCol="0" anchor="ctr"/>
-          <a:lstStyle/>
-          <a:p>
-            <a:pPr indent="0" marL="0">
-              <a:buNone/>
-            </a:pPr>
-            <a:r>
-              <a:rPr lang="en-US" sz="800" b="1" dirty="0">
-                <a:solidFill>
-                  <a:srgbClr val="12293A"/>
-                </a:solidFill>
-                <a:latin typeface="Poppins" pitchFamily="34" charset="0"/>
-                <a:ea typeface="Poppins" pitchFamily="34" charset="-122"/>
-                <a:cs typeface="Poppins" pitchFamily="34" charset="-120"/>
-              </a:rPr>
-              <a:t>Gregory St Clare-Hobbs</a:t>
+          <p:cNvPr id="63" name="Text 61"/>
+          <p:cNvSpPr txBox="1"/>
+          <p:nvPr/>
+        </p:nvSpPr>
+        <p:spPr>
+          <a:xfrm>
+            <a:off x="640080" y="4005072"/>
+            <a:ext cx="1783080" cy="237744"/>
+          </a:xfrm>
+          <a:prstGeom prst="rect">
+            <a:avLst/>
+          </a:prstGeom>
+          <a:noFill/>
+          <a:ln/>
+        </p:spPr>
+        <p:txBody>
+          <a:bodyPr wrap="square" lIns="0" tIns="0" rIns="0" bIns="0" rtlCol="0" anchor="ctr"/>
+          <a:lstStyle/>
+          <a:p>
+            <a:pPr indent="0" marL="0">
+              <a:buNone/>
+            </a:pPr>
+            <a:r>
+              <a:rPr lang="en-US" sz="800" dirty="0">
+                <a:solidFill>
+                  <a:srgbClr val="5E7280"/>
+                </a:solidFill>
+                <a:latin typeface="Poppins" pitchFamily="34" charset="0"/>
+                <a:ea typeface="Poppins" pitchFamily="34" charset="-122"/>
+                <a:cs typeface="Poppins" pitchFamily="34" charset="-120"/>
+              </a:rPr>
+              <a:t>Rodney Nolan</a:t>
             </a:r>
             <a:endParaRPr lang="en-US" sz="800" dirty="0"/>
           </a:p>
@@ -47669,13 +47830,13 @@
       </p:sp>
       <p:sp>
         <p:nvSpPr>
-          <p:cNvPr id="59" name="Shape 57"/>
-          <p:cNvSpPr/>
-          <p:nvPr/>
-        </p:nvSpPr>
-        <p:spPr>
-          <a:xfrm>
-            <a:off x="2468880" y="3815750"/>
+          <p:cNvPr id="64" name="Shape 62"/>
+          <p:cNvSpPr/>
+          <p:nvPr/>
+        </p:nvSpPr>
+        <p:spPr>
+          <a:xfrm>
+            <a:off x="2468880" y="4094226"/>
             <a:ext cx="2377440" cy="59436"/>
           </a:xfrm>
           <a:prstGeom prst="roundRect">
@@ -47691,14 +47852,131 @@
       </p:sp>
       <p:sp>
         <p:nvSpPr>
-          <p:cNvPr id="60" name="Shape 58"/>
-          <p:cNvSpPr/>
-          <p:nvPr/>
-        </p:nvSpPr>
-        <p:spPr>
-          <a:xfrm>
-            <a:off x="2468880" y="3815750"/>
-            <a:ext cx="92720" cy="59436"/>
+          <p:cNvPr id="65" name="Text 63"/>
+          <p:cNvSpPr txBox="1"/>
+          <p:nvPr/>
+        </p:nvSpPr>
+        <p:spPr>
+          <a:xfrm>
+            <a:off x="5029200" y="4005072"/>
+            <a:ext cx="822960" cy="237744"/>
+          </a:xfrm>
+          <a:prstGeom prst="rect">
+            <a:avLst/>
+          </a:prstGeom>
+          <a:noFill/>
+          <a:ln/>
+        </p:spPr>
+        <p:txBody>
+          <a:bodyPr wrap="square" lIns="0" tIns="0" rIns="0" bIns="0" rtlCol="0" anchor="ctr"/>
+          <a:lstStyle/>
+          <a:p>
+            <a:pPr algn="r" indent="0" marL="0">
+              <a:buNone/>
+            </a:pPr>
+            <a:r>
+              <a:rPr lang="en-US" sz="800" dirty="0">
+                <a:solidFill>
+                  <a:srgbClr val="8FA1AC"/>
+                </a:solidFill>
+                <a:latin typeface="Poppins" pitchFamily="34" charset="0"/>
+                <a:ea typeface="Poppins" pitchFamily="34" charset="-122"/>
+                <a:cs typeface="Poppins" pitchFamily="34" charset="-120"/>
+              </a:rPr>
+              <a:t>—</a:t>
+            </a:r>
+            <a:endParaRPr lang="en-US" sz="800" dirty="0"/>
+          </a:p>
+        </p:txBody>
+      </p:sp>
+      <p:sp>
+        <p:nvSpPr>
+          <p:cNvPr id="66" name="Text 64"/>
+          <p:cNvSpPr txBox="1"/>
+          <p:nvPr/>
+        </p:nvSpPr>
+        <p:spPr>
+          <a:xfrm>
+            <a:off x="5943600" y="4005072"/>
+            <a:ext cx="822960" cy="237744"/>
+          </a:xfrm>
+          <a:prstGeom prst="rect">
+            <a:avLst/>
+          </a:prstGeom>
+          <a:noFill/>
+          <a:ln/>
+        </p:spPr>
+        <p:txBody>
+          <a:bodyPr wrap="square" lIns="0" tIns="0" rIns="0" bIns="0" rtlCol="0" anchor="ctr"/>
+          <a:lstStyle/>
+          <a:p>
+            <a:pPr algn="r" indent="0" marL="0">
+              <a:buNone/>
+            </a:pPr>
+            <a:r>
+              <a:rPr lang="en-US" sz="600" dirty="0">
+                <a:solidFill>
+                  <a:srgbClr val="8FA1AC"/>
+                </a:solidFill>
+                <a:latin typeface="Poppins" pitchFamily="34" charset="0"/>
+                <a:ea typeface="Poppins" pitchFamily="34" charset="-122"/>
+                <a:cs typeface="Poppins" pitchFamily="34" charset="-120"/>
+              </a:rPr>
+              <a:t>no time logged</a:t>
+            </a:r>
+            <a:endParaRPr lang="en-US" sz="600" dirty="0"/>
+          </a:p>
+        </p:txBody>
+      </p:sp>
+      <p:sp>
+        <p:nvSpPr>
+          <p:cNvPr id="67" name="Text 65"/>
+          <p:cNvSpPr txBox="1"/>
+          <p:nvPr/>
+        </p:nvSpPr>
+        <p:spPr>
+          <a:xfrm>
+            <a:off x="640080" y="4242816"/>
+            <a:ext cx="1783080" cy="237744"/>
+          </a:xfrm>
+          <a:prstGeom prst="rect">
+            <a:avLst/>
+          </a:prstGeom>
+          <a:noFill/>
+          <a:ln/>
+        </p:spPr>
+        <p:txBody>
+          <a:bodyPr wrap="square" lIns="0" tIns="0" rIns="0" bIns="0" rtlCol="0" anchor="ctr"/>
+          <a:lstStyle/>
+          <a:p>
+            <a:pPr indent="0" marL="0">
+              <a:buNone/>
+            </a:pPr>
+            <a:r>
+              <a:rPr lang="en-US" sz="800" dirty="0">
+                <a:solidFill>
+                  <a:srgbClr val="5E7280"/>
+                </a:solidFill>
+                <a:latin typeface="Poppins" pitchFamily="34" charset="0"/>
+                <a:ea typeface="Poppins" pitchFamily="34" charset="-122"/>
+                <a:cs typeface="Poppins" pitchFamily="34" charset="-120"/>
+              </a:rPr>
+              <a:t>Karim AlRifaii</a:t>
+            </a:r>
+            <a:endParaRPr lang="en-US" sz="800" dirty="0"/>
+          </a:p>
+        </p:txBody>
+      </p:sp>
+      <p:sp>
+        <p:nvSpPr>
+          <p:cNvPr id="68" name="Shape 66"/>
+          <p:cNvSpPr/>
+          <p:nvPr/>
+        </p:nvSpPr>
+        <p:spPr>
+          <a:xfrm>
+            <a:off x="2468880" y="4331970"/>
+            <a:ext cx="2377440" cy="59436"/>
           </a:xfrm>
           <a:prstGeom prst="roundRect">
             <a:avLst>
@@ -47706,21 +47984,21 @@
             </a:avLst>
           </a:prstGeom>
           <a:solidFill>
-            <a:srgbClr val="2C8394"/>
-          </a:solidFill>
-          <a:ln/>
-        </p:spPr>
-      </p:sp>
-      <p:sp>
-        <p:nvSpPr>
-          <p:cNvPr id="61" name="Text 59"/>
-          <p:cNvSpPr txBox="1"/>
-          <p:nvPr/>
-        </p:nvSpPr>
-        <p:spPr>
-          <a:xfrm>
-            <a:off x="5029200" y="3732415"/>
-            <a:ext cx="822960" cy="226106"/>
+            <a:srgbClr val="E2EAEE"/>
+          </a:solidFill>
+          <a:ln/>
+        </p:spPr>
+      </p:sp>
+      <p:sp>
+        <p:nvSpPr>
+          <p:cNvPr id="69" name="Text 67"/>
+          <p:cNvSpPr txBox="1"/>
+          <p:nvPr/>
+        </p:nvSpPr>
+        <p:spPr>
+          <a:xfrm>
+            <a:off x="5029200" y="4242816"/>
+            <a:ext cx="822960" cy="237744"/>
           </a:xfrm>
           <a:prstGeom prst="rect">
             <a:avLst/>
@@ -47736,15 +48014,15 @@
               <a:buNone/>
             </a:pPr>
             <a:r>
-              <a:rPr lang="en-US" sz="800" b="1" dirty="0">
-                <a:solidFill>
-                  <a:srgbClr val="2C8394"/>
-                </a:solidFill>
-                <a:latin typeface="Poppins" pitchFamily="34" charset="0"/>
-                <a:ea typeface="Poppins" pitchFamily="34" charset="-122"/>
-                <a:cs typeface="Poppins" pitchFamily="34" charset="-120"/>
-              </a:rPr>
-              <a:t>1.50h</a:t>
+              <a:rPr lang="en-US" sz="800" dirty="0">
+                <a:solidFill>
+                  <a:srgbClr val="8FA1AC"/>
+                </a:solidFill>
+                <a:latin typeface="Poppins" pitchFamily="34" charset="0"/>
+                <a:ea typeface="Poppins" pitchFamily="34" charset="-122"/>
+                <a:cs typeface="Poppins" pitchFamily="34" charset="-120"/>
+              </a:rPr>
+              <a:t>—</a:t>
             </a:r>
             <a:endParaRPr lang="en-US" sz="800" dirty="0"/>
           </a:p>
@@ -47752,14 +48030,14 @@
       </p:sp>
       <p:sp>
         <p:nvSpPr>
-          <p:cNvPr id="62" name="Text 60"/>
-          <p:cNvSpPr txBox="1"/>
-          <p:nvPr/>
-        </p:nvSpPr>
-        <p:spPr>
-          <a:xfrm>
-            <a:off x="5943600" y="3732415"/>
-            <a:ext cx="822960" cy="226106"/>
+          <p:cNvPr id="70" name="Text 68"/>
+          <p:cNvSpPr txBox="1"/>
+          <p:nvPr/>
+        </p:nvSpPr>
+        <p:spPr>
+          <a:xfrm>
+            <a:off x="5943600" y="4242816"/>
+            <a:ext cx="822960" cy="237744"/>
           </a:xfrm>
           <a:prstGeom prst="rect">
             <a:avLst/>
@@ -47775,15 +48053,54 @@
               <a:buNone/>
             </a:pPr>
             <a:r>
-              <a:rPr lang="en-US" sz="800" b="1" dirty="0">
-                <a:solidFill>
-                  <a:srgbClr val="12293A"/>
-                </a:solidFill>
-                <a:latin typeface="Poppins" pitchFamily="34" charset="0"/>
-                <a:ea typeface="Poppins" pitchFamily="34" charset="-122"/>
-                <a:cs typeface="Poppins" pitchFamily="34" charset="-120"/>
-              </a:rPr>
-              <a:t>3.9%</a:t>
+              <a:rPr lang="en-US" sz="600" dirty="0">
+                <a:solidFill>
+                  <a:srgbClr val="8FA1AC"/>
+                </a:solidFill>
+                <a:latin typeface="Poppins" pitchFamily="34" charset="0"/>
+                <a:ea typeface="Poppins" pitchFamily="34" charset="-122"/>
+                <a:cs typeface="Poppins" pitchFamily="34" charset="-120"/>
+              </a:rPr>
+              <a:t>no time logged</a:t>
+            </a:r>
+            <a:endParaRPr lang="en-US" sz="600" dirty="0"/>
+          </a:p>
+        </p:txBody>
+      </p:sp>
+      <p:sp>
+        <p:nvSpPr>
+          <p:cNvPr id="71" name="Text 69"/>
+          <p:cNvSpPr txBox="1"/>
+          <p:nvPr/>
+        </p:nvSpPr>
+        <p:spPr>
+          <a:xfrm>
+            <a:off x="640080" y="4480560"/>
+            <a:ext cx="1783080" cy="237744"/>
+          </a:xfrm>
+          <a:prstGeom prst="rect">
+            <a:avLst/>
+          </a:prstGeom>
+          <a:noFill/>
+          <a:ln/>
+        </p:spPr>
+        <p:txBody>
+          <a:bodyPr wrap="square" lIns="0" tIns="0" rIns="0" bIns="0" rtlCol="0" anchor="ctr"/>
+          <a:lstStyle/>
+          <a:p>
+            <a:pPr indent="0" marL="0">
+              <a:buNone/>
+            </a:pPr>
+            <a:r>
+              <a:rPr lang="en-US" sz="800" dirty="0">
+                <a:solidFill>
+                  <a:srgbClr val="5E7280"/>
+                </a:solidFill>
+                <a:latin typeface="Poppins" pitchFamily="34" charset="0"/>
+                <a:ea typeface="Poppins" pitchFamily="34" charset="-122"/>
+                <a:cs typeface="Poppins" pitchFamily="34" charset="-120"/>
+              </a:rPr>
+              <a:t>Ryan Neil Orande</a:t>
             </a:r>
             <a:endParaRPr lang="en-US" sz="800" dirty="0"/>
           </a:p>
@@ -47791,52 +48108,13 @@
       </p:sp>
       <p:sp>
         <p:nvSpPr>
-          <p:cNvPr id="63" name="Text 61"/>
-          <p:cNvSpPr txBox="1"/>
-          <p:nvPr/>
-        </p:nvSpPr>
-        <p:spPr>
-          <a:xfrm>
-            <a:off x="640080" y="3958521"/>
-            <a:ext cx="1783080" cy="226106"/>
-          </a:xfrm>
-          <a:prstGeom prst="rect">
-            <a:avLst/>
-          </a:prstGeom>
-          <a:noFill/>
-          <a:ln/>
-        </p:spPr>
-        <p:txBody>
-          <a:bodyPr wrap="square" lIns="0" tIns="0" rIns="0" bIns="0" rtlCol="0" anchor="ctr"/>
-          <a:lstStyle/>
-          <a:p>
-            <a:pPr indent="0" marL="0">
-              <a:buNone/>
-            </a:pPr>
-            <a:r>
-              <a:rPr lang="en-US" sz="800" b="1" dirty="0">
-                <a:solidFill>
-                  <a:srgbClr val="12293A"/>
-                </a:solidFill>
-                <a:latin typeface="Poppins" pitchFamily="34" charset="0"/>
-                <a:ea typeface="Poppins" pitchFamily="34" charset="-122"/>
-                <a:cs typeface="Poppins" pitchFamily="34" charset="-120"/>
-              </a:rPr>
-              <a:t>Isayah Kuhlmann</a:t>
-            </a:r>
-            <a:endParaRPr lang="en-US" sz="800" dirty="0"/>
-          </a:p>
-        </p:txBody>
-      </p:sp>
-      <p:sp>
-        <p:nvSpPr>
-          <p:cNvPr id="64" name="Shape 62"/>
-          <p:cNvSpPr/>
-          <p:nvPr/>
-        </p:nvSpPr>
-        <p:spPr>
-          <a:xfrm>
-            <a:off x="2468880" y="4041856"/>
+          <p:cNvPr id="72" name="Shape 70"/>
+          <p:cNvSpPr/>
+          <p:nvPr/>
+        </p:nvSpPr>
+        <p:spPr>
+          <a:xfrm>
+            <a:off x="2468880" y="4569714"/>
             <a:ext cx="2377440" cy="59436"/>
           </a:xfrm>
           <a:prstGeom prst="roundRect">
@@ -47852,36 +48130,14 @@
       </p:sp>
       <p:sp>
         <p:nvSpPr>
-          <p:cNvPr id="65" name="Shape 63"/>
-          <p:cNvSpPr/>
-          <p:nvPr/>
-        </p:nvSpPr>
-        <p:spPr>
-          <a:xfrm>
-            <a:off x="2468880" y="4041856"/>
-            <a:ext cx="45720" cy="59436"/>
-          </a:xfrm>
-          <a:prstGeom prst="roundRect">
-            <a:avLst>
-              <a:gd name="adj" fmla="val 64000"/>
-            </a:avLst>
-          </a:prstGeom>
-          <a:solidFill>
-            <a:srgbClr val="2C8394"/>
-          </a:solidFill>
-          <a:ln/>
-        </p:spPr>
-      </p:sp>
-      <p:sp>
-        <p:nvSpPr>
-          <p:cNvPr id="66" name="Text 64"/>
-          <p:cNvSpPr txBox="1"/>
-          <p:nvPr/>
-        </p:nvSpPr>
-        <p:spPr>
-          <a:xfrm>
-            <a:off x="5029200" y="3958521"/>
-            <a:ext cx="822960" cy="226106"/>
+          <p:cNvPr id="73" name="Text 71"/>
+          <p:cNvSpPr txBox="1"/>
+          <p:nvPr/>
+        </p:nvSpPr>
+        <p:spPr>
+          <a:xfrm>
+            <a:off x="5029200" y="4480560"/>
+            <a:ext cx="822960" cy="237744"/>
           </a:xfrm>
           <a:prstGeom prst="rect">
             <a:avLst/>
@@ -47897,15 +48153,15 @@
               <a:buNone/>
             </a:pPr>
             <a:r>
-              <a:rPr lang="en-US" sz="800" b="1" dirty="0">
-                <a:solidFill>
-                  <a:srgbClr val="2C8394"/>
-                </a:solidFill>
-                <a:latin typeface="Poppins" pitchFamily="34" charset="0"/>
-                <a:ea typeface="Poppins" pitchFamily="34" charset="-122"/>
-                <a:cs typeface="Poppins" pitchFamily="34" charset="-120"/>
-              </a:rPr>
-              <a:t>0.50h</a:t>
+              <a:rPr lang="en-US" sz="800" dirty="0">
+                <a:solidFill>
+                  <a:srgbClr val="8FA1AC"/>
+                </a:solidFill>
+                <a:latin typeface="Poppins" pitchFamily="34" charset="0"/>
+                <a:ea typeface="Poppins" pitchFamily="34" charset="-122"/>
+                <a:cs typeface="Poppins" pitchFamily="34" charset="-120"/>
+              </a:rPr>
+              <a:t>—</a:t>
             </a:r>
             <a:endParaRPr lang="en-US" sz="800" dirty="0"/>
           </a:p>
@@ -47913,14 +48169,14 @@
       </p:sp>
       <p:sp>
         <p:nvSpPr>
-          <p:cNvPr id="67" name="Text 65"/>
-          <p:cNvSpPr txBox="1"/>
-          <p:nvPr/>
-        </p:nvSpPr>
-        <p:spPr>
-          <a:xfrm>
-            <a:off x="5943600" y="3958521"/>
-            <a:ext cx="822960" cy="226106"/>
+          <p:cNvPr id="74" name="Text 72"/>
+          <p:cNvSpPr txBox="1"/>
+          <p:nvPr/>
+        </p:nvSpPr>
+        <p:spPr>
+          <a:xfrm>
+            <a:off x="5943600" y="4480560"/>
+            <a:ext cx="822960" cy="237744"/>
           </a:xfrm>
           <a:prstGeom prst="rect">
             <a:avLst/>
@@ -47936,15 +48192,54 @@
               <a:buNone/>
             </a:pPr>
             <a:r>
-              <a:rPr lang="en-US" sz="800" b="1" dirty="0">
-                <a:solidFill>
-                  <a:srgbClr val="12293A"/>
-                </a:solidFill>
-                <a:latin typeface="Poppins" pitchFamily="34" charset="0"/>
-                <a:ea typeface="Poppins" pitchFamily="34" charset="-122"/>
-                <a:cs typeface="Poppins" pitchFamily="34" charset="-120"/>
-              </a:rPr>
-              <a:t>1.3%</a:t>
+              <a:rPr lang="en-US" sz="600" dirty="0">
+                <a:solidFill>
+                  <a:srgbClr val="8FA1AC"/>
+                </a:solidFill>
+                <a:latin typeface="Poppins" pitchFamily="34" charset="0"/>
+                <a:ea typeface="Poppins" pitchFamily="34" charset="-122"/>
+                <a:cs typeface="Poppins" pitchFamily="34" charset="-120"/>
+              </a:rPr>
+              <a:t>no time logged</a:t>
+            </a:r>
+            <a:endParaRPr lang="en-US" sz="600" dirty="0"/>
+          </a:p>
+        </p:txBody>
+      </p:sp>
+      <p:sp>
+        <p:nvSpPr>
+          <p:cNvPr id="75" name="Text 73"/>
+          <p:cNvSpPr txBox="1"/>
+          <p:nvPr/>
+        </p:nvSpPr>
+        <p:spPr>
+          <a:xfrm>
+            <a:off x="640080" y="4718304"/>
+            <a:ext cx="1783080" cy="237744"/>
+          </a:xfrm>
+          <a:prstGeom prst="rect">
+            <a:avLst/>
+          </a:prstGeom>
+          <a:noFill/>
+          <a:ln/>
+        </p:spPr>
+        <p:txBody>
+          <a:bodyPr wrap="square" lIns="0" tIns="0" rIns="0" bIns="0" rtlCol="0" anchor="ctr"/>
+          <a:lstStyle/>
+          <a:p>
+            <a:pPr indent="0" marL="0">
+              <a:buNone/>
+            </a:pPr>
+            <a:r>
+              <a:rPr lang="en-US" sz="800" dirty="0">
+                <a:solidFill>
+                  <a:srgbClr val="5E7280"/>
+                </a:solidFill>
+                <a:latin typeface="Poppins" pitchFamily="34" charset="0"/>
+                <a:ea typeface="Poppins" pitchFamily="34" charset="-122"/>
+                <a:cs typeface="Poppins" pitchFamily="34" charset="-120"/>
+              </a:rPr>
+              <a:t>Argenis Rafael Guevara</a:t>
             </a:r>
             <a:endParaRPr lang="en-US" sz="800" dirty="0"/>
           </a:p>
@@ -47952,52 +48247,13 @@
       </p:sp>
       <p:sp>
         <p:nvSpPr>
-          <p:cNvPr id="68" name="Text 66"/>
-          <p:cNvSpPr txBox="1"/>
-          <p:nvPr/>
-        </p:nvSpPr>
-        <p:spPr>
-          <a:xfrm>
-            <a:off x="640080" y="4184627"/>
-            <a:ext cx="1783080" cy="226106"/>
-          </a:xfrm>
-          <a:prstGeom prst="rect">
-            <a:avLst/>
-          </a:prstGeom>
-          <a:noFill/>
-          <a:ln/>
-        </p:spPr>
-        <p:txBody>
-          <a:bodyPr wrap="square" lIns="0" tIns="0" rIns="0" bIns="0" rtlCol="0" anchor="ctr"/>
-          <a:lstStyle/>
-          <a:p>
-            <a:pPr indent="0" marL="0">
-              <a:buNone/>
-            </a:pPr>
-            <a:r>
-              <a:rPr lang="en-US" sz="800" b="1" dirty="0">
-                <a:solidFill>
-                  <a:srgbClr val="12293A"/>
-                </a:solidFill>
-                <a:latin typeface="Poppins" pitchFamily="34" charset="0"/>
-                <a:ea typeface="Poppins" pitchFamily="34" charset="-122"/>
-                <a:cs typeface="Poppins" pitchFamily="34" charset="-120"/>
-              </a:rPr>
-              <a:t>Joshua Casey</a:t>
-            </a:r>
-            <a:endParaRPr lang="en-US" sz="800" dirty="0"/>
-          </a:p>
-        </p:txBody>
-      </p:sp>
-      <p:sp>
-        <p:nvSpPr>
-          <p:cNvPr id="69" name="Shape 67"/>
-          <p:cNvSpPr/>
-          <p:nvPr/>
-        </p:nvSpPr>
-        <p:spPr>
-          <a:xfrm>
-            <a:off x="2468880" y="4267962"/>
+          <p:cNvPr id="76" name="Shape 74"/>
+          <p:cNvSpPr/>
+          <p:nvPr/>
+        </p:nvSpPr>
+        <p:spPr>
+          <a:xfrm>
+            <a:off x="2468880" y="4807458"/>
             <a:ext cx="2377440" cy="59436"/>
           </a:xfrm>
           <a:prstGeom prst="roundRect">
@@ -48013,36 +48269,14 @@
       </p:sp>
       <p:sp>
         <p:nvSpPr>
-          <p:cNvPr id="70" name="Shape 68"/>
-          <p:cNvSpPr/>
-          <p:nvPr/>
-        </p:nvSpPr>
-        <p:spPr>
-          <a:xfrm>
-            <a:off x="2468880" y="4267962"/>
-            <a:ext cx="45720" cy="59436"/>
-          </a:xfrm>
-          <a:prstGeom prst="roundRect">
-            <a:avLst>
-              <a:gd name="adj" fmla="val 64000"/>
-            </a:avLst>
-          </a:prstGeom>
-          <a:solidFill>
-            <a:srgbClr val="2C8394"/>
-          </a:solidFill>
-          <a:ln/>
-        </p:spPr>
-      </p:sp>
-      <p:sp>
-        <p:nvSpPr>
-          <p:cNvPr id="71" name="Text 69"/>
-          <p:cNvSpPr txBox="1"/>
-          <p:nvPr/>
-        </p:nvSpPr>
-        <p:spPr>
-          <a:xfrm>
-            <a:off x="5029200" y="4184627"/>
-            <a:ext cx="822960" cy="226106"/>
+          <p:cNvPr id="77" name="Text 75"/>
+          <p:cNvSpPr txBox="1"/>
+          <p:nvPr/>
+        </p:nvSpPr>
+        <p:spPr>
+          <a:xfrm>
+            <a:off x="5029200" y="4718304"/>
+            <a:ext cx="822960" cy="237744"/>
           </a:xfrm>
           <a:prstGeom prst="rect">
             <a:avLst/>
@@ -48058,15 +48292,15 @@
               <a:buNone/>
             </a:pPr>
             <a:r>
-              <a:rPr lang="en-US" sz="800" b="1" dirty="0">
-                <a:solidFill>
-                  <a:srgbClr val="2C8394"/>
-                </a:solidFill>
-                <a:latin typeface="Poppins" pitchFamily="34" charset="0"/>
-                <a:ea typeface="Poppins" pitchFamily="34" charset="-122"/>
-                <a:cs typeface="Poppins" pitchFamily="34" charset="-120"/>
-              </a:rPr>
-              <a:t>0.25h</a:t>
+              <a:rPr lang="en-US" sz="800" dirty="0">
+                <a:solidFill>
+                  <a:srgbClr val="8FA1AC"/>
+                </a:solidFill>
+                <a:latin typeface="Poppins" pitchFamily="34" charset="0"/>
+                <a:ea typeface="Poppins" pitchFamily="34" charset="-122"/>
+                <a:cs typeface="Poppins" pitchFamily="34" charset="-120"/>
+              </a:rPr>
+              <a:t>—</a:t>
             </a:r>
             <a:endParaRPr lang="en-US" sz="800" dirty="0"/>
           </a:p>
@@ -48074,14 +48308,14 @@
       </p:sp>
       <p:sp>
         <p:nvSpPr>
-          <p:cNvPr id="72" name="Text 70"/>
-          <p:cNvSpPr txBox="1"/>
-          <p:nvPr/>
-        </p:nvSpPr>
-        <p:spPr>
-          <a:xfrm>
-            <a:off x="5943600" y="4184627"/>
-            <a:ext cx="822960" cy="226106"/>
+          <p:cNvPr id="78" name="Text 76"/>
+          <p:cNvSpPr txBox="1"/>
+          <p:nvPr/>
+        </p:nvSpPr>
+        <p:spPr>
+          <a:xfrm>
+            <a:off x="5943600" y="4718304"/>
+            <a:ext cx="822960" cy="237744"/>
           </a:xfrm>
           <a:prstGeom prst="rect">
             <a:avLst/>
@@ -48097,15 +48331,54 @@
               <a:buNone/>
             </a:pPr>
             <a:r>
-              <a:rPr lang="en-US" sz="800" b="1" dirty="0">
-                <a:solidFill>
-                  <a:srgbClr val="12293A"/>
-                </a:solidFill>
-                <a:latin typeface="Poppins" pitchFamily="34" charset="0"/>
-                <a:ea typeface="Poppins" pitchFamily="34" charset="-122"/>
-                <a:cs typeface="Poppins" pitchFamily="34" charset="-120"/>
-              </a:rPr>
-              <a:t>0.7%</a:t>
+              <a:rPr lang="en-US" sz="600" dirty="0">
+                <a:solidFill>
+                  <a:srgbClr val="8FA1AC"/>
+                </a:solidFill>
+                <a:latin typeface="Poppins" pitchFamily="34" charset="0"/>
+                <a:ea typeface="Poppins" pitchFamily="34" charset="-122"/>
+                <a:cs typeface="Poppins" pitchFamily="34" charset="-120"/>
+              </a:rPr>
+              <a:t>no time logged</a:t>
+            </a:r>
+            <a:endParaRPr lang="en-US" sz="600" dirty="0"/>
+          </a:p>
+        </p:txBody>
+      </p:sp>
+      <p:sp>
+        <p:nvSpPr>
+          <p:cNvPr id="79" name="Text 77"/>
+          <p:cNvSpPr txBox="1"/>
+          <p:nvPr/>
+        </p:nvSpPr>
+        <p:spPr>
+          <a:xfrm>
+            <a:off x="640080" y="4956048"/>
+            <a:ext cx="1783080" cy="237744"/>
+          </a:xfrm>
+          <a:prstGeom prst="rect">
+            <a:avLst/>
+          </a:prstGeom>
+          <a:noFill/>
+          <a:ln/>
+        </p:spPr>
+        <p:txBody>
+          <a:bodyPr wrap="square" lIns="0" tIns="0" rIns="0" bIns="0" rtlCol="0" anchor="ctr"/>
+          <a:lstStyle/>
+          <a:p>
+            <a:pPr indent="0" marL="0">
+              <a:buNone/>
+            </a:pPr>
+            <a:r>
+              <a:rPr lang="en-US" sz="800" dirty="0">
+                <a:solidFill>
+                  <a:srgbClr val="5E7280"/>
+                </a:solidFill>
+                <a:latin typeface="Poppins" pitchFamily="34" charset="0"/>
+                <a:ea typeface="Poppins" pitchFamily="34" charset="-122"/>
+                <a:cs typeface="Poppins" pitchFamily="34" charset="-120"/>
+              </a:rPr>
+              <a:t>Isaac Mercado</a:t>
             </a:r>
             <a:endParaRPr lang="en-US" sz="800" dirty="0"/>
           </a:p>
@@ -48113,52 +48386,13 @@
       </p:sp>
       <p:sp>
         <p:nvSpPr>
-          <p:cNvPr id="73" name="Text 71"/>
-          <p:cNvSpPr txBox="1"/>
-          <p:nvPr/>
-        </p:nvSpPr>
-        <p:spPr>
-          <a:xfrm>
-            <a:off x="640080" y="4410733"/>
-            <a:ext cx="1783080" cy="226106"/>
-          </a:xfrm>
-          <a:prstGeom prst="rect">
-            <a:avLst/>
-          </a:prstGeom>
-          <a:noFill/>
-          <a:ln/>
-        </p:spPr>
-        <p:txBody>
-          <a:bodyPr wrap="square" lIns="0" tIns="0" rIns="0" bIns="0" rtlCol="0" anchor="ctr"/>
-          <a:lstStyle/>
-          <a:p>
-            <a:pPr indent="0" marL="0">
-              <a:buNone/>
-            </a:pPr>
-            <a:r>
-              <a:rPr lang="en-US" sz="800" dirty="0">
-                <a:solidFill>
-                  <a:srgbClr val="5E7280"/>
-                </a:solidFill>
-                <a:latin typeface="Poppins" pitchFamily="34" charset="0"/>
-                <a:ea typeface="Poppins" pitchFamily="34" charset="-122"/>
-                <a:cs typeface="Poppins" pitchFamily="34" charset="-120"/>
-              </a:rPr>
-              <a:t>Rodney Nolan</a:t>
-            </a:r>
-            <a:endParaRPr lang="en-US" sz="800" dirty="0"/>
-          </a:p>
-        </p:txBody>
-      </p:sp>
-      <p:sp>
-        <p:nvSpPr>
-          <p:cNvPr id="74" name="Shape 72"/>
-          <p:cNvSpPr/>
-          <p:nvPr/>
-        </p:nvSpPr>
-        <p:spPr>
-          <a:xfrm>
-            <a:off x="2468880" y="4494068"/>
+          <p:cNvPr id="80" name="Shape 78"/>
+          <p:cNvSpPr/>
+          <p:nvPr/>
+        </p:nvSpPr>
+        <p:spPr>
+          <a:xfrm>
+            <a:off x="2468880" y="5045202"/>
             <a:ext cx="2377440" cy="59436"/>
           </a:xfrm>
           <a:prstGeom prst="roundRect">
@@ -48174,14 +48408,14 @@
       </p:sp>
       <p:sp>
         <p:nvSpPr>
-          <p:cNvPr id="75" name="Text 73"/>
-          <p:cNvSpPr txBox="1"/>
-          <p:nvPr/>
-        </p:nvSpPr>
-        <p:spPr>
-          <a:xfrm>
-            <a:off x="5029200" y="4410733"/>
-            <a:ext cx="822960" cy="226106"/>
+          <p:cNvPr id="81" name="Text 79"/>
+          <p:cNvSpPr txBox="1"/>
+          <p:nvPr/>
+        </p:nvSpPr>
+        <p:spPr>
+          <a:xfrm>
+            <a:off x="5029200" y="4956048"/>
+            <a:ext cx="822960" cy="237744"/>
           </a:xfrm>
           <a:prstGeom prst="rect">
             <a:avLst/>
@@ -48213,14 +48447,14 @@
       </p:sp>
       <p:sp>
         <p:nvSpPr>
-          <p:cNvPr id="76" name="Text 74"/>
-          <p:cNvSpPr txBox="1"/>
-          <p:nvPr/>
-        </p:nvSpPr>
-        <p:spPr>
-          <a:xfrm>
-            <a:off x="5943600" y="4410733"/>
-            <a:ext cx="822960" cy="226106"/>
+          <p:cNvPr id="82" name="Text 80"/>
+          <p:cNvSpPr txBox="1"/>
+          <p:nvPr/>
+        </p:nvSpPr>
+        <p:spPr>
+          <a:xfrm>
+            <a:off x="5943600" y="4956048"/>
+            <a:ext cx="822960" cy="237744"/>
           </a:xfrm>
           <a:prstGeom prst="rect">
             <a:avLst/>
@@ -48252,30 +48486,89 @@
       </p:sp>
       <p:sp>
         <p:nvSpPr>
-          <p:cNvPr id="77" name="Text 75"/>
-          <p:cNvSpPr txBox="1"/>
-          <p:nvPr/>
-        </p:nvSpPr>
-        <p:spPr>
-          <a:xfrm>
-            <a:off x="640080" y="4636839"/>
-            <a:ext cx="1783080" cy="226106"/>
-          </a:xfrm>
-          <a:prstGeom prst="rect">
-            <a:avLst/>
-          </a:prstGeom>
-          <a:noFill/>
-          <a:ln/>
-        </p:spPr>
-        <p:txBody>
-          <a:bodyPr wrap="square" lIns="0" tIns="0" rIns="0" bIns="0" rtlCol="0" anchor="ctr"/>
-          <a:lstStyle/>
-          <a:p>
-            <a:pPr indent="0" marL="0">
-              <a:buNone/>
-            </a:pPr>
-            <a:r>
-              <a:rPr lang="en-US" sz="800" dirty="0">
+          <p:cNvPr id="83" name="Shape 81"/>
+          <p:cNvSpPr/>
+          <p:nvPr/>
+        </p:nvSpPr>
+        <p:spPr>
+          <a:xfrm>
+            <a:off x="640080" y="5230368"/>
+            <a:ext cx="6126480" cy="10973"/>
+          </a:xfrm>
+          <a:prstGeom prst="rect">
+            <a:avLst/>
+          </a:prstGeom>
+          <a:solidFill>
+            <a:srgbClr val="12293A"/>
+          </a:solidFill>
+          <a:ln/>
+        </p:spPr>
+      </p:sp>
+      <p:sp>
+        <p:nvSpPr>
+          <p:cNvPr id="84" name="Text 82"/>
+          <p:cNvSpPr txBox="1"/>
+          <p:nvPr/>
+        </p:nvSpPr>
+        <p:spPr>
+          <a:xfrm>
+            <a:off x="640080" y="5266944"/>
+            <a:ext cx="1783080" cy="237744"/>
+          </a:xfrm>
+          <a:prstGeom prst="rect">
+            <a:avLst/>
+          </a:prstGeom>
+          <a:noFill/>
+          <a:ln/>
+        </p:spPr>
+        <p:txBody>
+          <a:bodyPr wrap="square" lIns="0" tIns="0" rIns="0" bIns="0" rtlCol="0" anchor="ctr"/>
+          <a:lstStyle/>
+          <a:p>
+            <a:pPr indent="0" marL="0">
+              <a:buNone/>
+            </a:pPr>
+            <a:r>
+              <a:rPr lang="en-US" sz="850" b="1" dirty="0">
+                <a:solidFill>
+                  <a:srgbClr val="12293A"/>
+                </a:solidFill>
+                <a:latin typeface="Poppins" pitchFamily="34" charset="0"/>
+                <a:ea typeface="Poppins" pitchFamily="34" charset="-122"/>
+                <a:cs typeface="Poppins" pitchFamily="34" charset="-120"/>
+              </a:rPr>
+              <a:t>TOTAL</a:t>
+            </a:r>
+            <a:endParaRPr lang="en-US" sz="850" dirty="0"/>
+          </a:p>
+        </p:txBody>
+      </p:sp>
+      <p:sp>
+        <p:nvSpPr>
+          <p:cNvPr id="85" name="Text 83"/>
+          <p:cNvSpPr txBox="1"/>
+          <p:nvPr/>
+        </p:nvSpPr>
+        <p:spPr>
+          <a:xfrm>
+            <a:off x="2468880" y="5266944"/>
+            <a:ext cx="2377440" cy="237744"/>
+          </a:xfrm>
+          <a:prstGeom prst="rect">
+            <a:avLst/>
+          </a:prstGeom>
+          <a:noFill/>
+          <a:ln/>
+        </p:spPr>
+        <p:txBody>
+          <a:bodyPr wrap="square" lIns="0" tIns="0" rIns="0" bIns="0" rtlCol="0" anchor="ctr"/>
+          <a:lstStyle/>
+          <a:p>
+            <a:pPr indent="0" marL="0">
+              <a:buNone/>
+            </a:pPr>
+            <a:r>
+              <a:rPr lang="en-US" sz="700" dirty="0">
                 <a:solidFill>
                   <a:srgbClr val="5E7280"/>
                 </a:solidFill>
@@ -48283,44 +48576,22 @@
                 <a:ea typeface="Poppins" pitchFamily="34" charset="-122"/>
                 <a:cs typeface="Poppins" pitchFamily="34" charset="-120"/>
               </a:rPr>
-              <a:t>Karim AlRifaii</a:t>
-            </a:r>
-            <a:endParaRPr lang="en-US" sz="800" dirty="0"/>
-          </a:p>
-        </p:txBody>
-      </p:sp>
-      <p:sp>
-        <p:nvSpPr>
-          <p:cNvPr id="78" name="Shape 76"/>
-          <p:cNvSpPr/>
-          <p:nvPr/>
-        </p:nvSpPr>
-        <p:spPr>
-          <a:xfrm>
-            <a:off x="2468880" y="4720174"/>
-            <a:ext cx="2377440" cy="59436"/>
-          </a:xfrm>
-          <a:prstGeom prst="roundRect">
-            <a:avLst>
-              <a:gd name="adj" fmla="val 49231"/>
-            </a:avLst>
-          </a:prstGeom>
-          <a:solidFill>
-            <a:srgbClr val="E2EAEE"/>
-          </a:solidFill>
-          <a:ln/>
-        </p:spPr>
-      </p:sp>
-      <p:sp>
-        <p:nvSpPr>
-          <p:cNvPr id="79" name="Text 77"/>
-          <p:cNvSpPr txBox="1"/>
-          <p:nvPr/>
-        </p:nvSpPr>
-        <p:spPr>
-          <a:xfrm>
-            <a:off x="5029200" y="4636839"/>
-            <a:ext cx="822960" cy="226106"/>
+              <a:t>9 PS people × 38h = 342h available</a:t>
+            </a:r>
+            <a:endParaRPr lang="en-US" sz="700" dirty="0"/>
+          </a:p>
+        </p:txBody>
+      </p:sp>
+      <p:sp>
+        <p:nvSpPr>
+          <p:cNvPr id="86" name="Text 84"/>
+          <p:cNvSpPr txBox="1"/>
+          <p:nvPr/>
+        </p:nvSpPr>
+        <p:spPr>
+          <a:xfrm>
+            <a:off x="5029200" y="5266944"/>
+            <a:ext cx="822960" cy="237744"/>
           </a:xfrm>
           <a:prstGeom prst="rect">
             <a:avLst/>
@@ -48336,30 +48607,30 @@
               <a:buNone/>
             </a:pPr>
             <a:r>
-              <a:rPr lang="en-US" sz="800" dirty="0">
-                <a:solidFill>
-                  <a:srgbClr val="8FA1AC"/>
-                </a:solidFill>
-                <a:latin typeface="Poppins" pitchFamily="34" charset="0"/>
-                <a:ea typeface="Poppins" pitchFamily="34" charset="-122"/>
-                <a:cs typeface="Poppins" pitchFamily="34" charset="-120"/>
-              </a:rPr>
-              <a:t>—</a:t>
-            </a:r>
-            <a:endParaRPr lang="en-US" sz="800" dirty="0"/>
-          </a:p>
-        </p:txBody>
-      </p:sp>
-      <p:sp>
-        <p:nvSpPr>
-          <p:cNvPr id="80" name="Text 78"/>
-          <p:cNvSpPr txBox="1"/>
-          <p:nvPr/>
-        </p:nvSpPr>
-        <p:spPr>
-          <a:xfrm>
-            <a:off x="5943600" y="4636839"/>
-            <a:ext cx="822960" cy="226106"/>
+              <a:rPr lang="en-US" sz="950" b="1" dirty="0">
+                <a:solidFill>
+                  <a:srgbClr val="2C8394"/>
+                </a:solidFill>
+                <a:latin typeface="Poppins" pitchFamily="34" charset="0"/>
+                <a:ea typeface="Poppins" pitchFamily="34" charset="-122"/>
+                <a:cs typeface="Poppins" pitchFamily="34" charset="-120"/>
+              </a:rPr>
+              <a:t>16.07h</a:t>
+            </a:r>
+            <a:endParaRPr lang="en-US" sz="950" dirty="0"/>
+          </a:p>
+        </p:txBody>
+      </p:sp>
+      <p:sp>
+        <p:nvSpPr>
+          <p:cNvPr id="87" name="Text 85"/>
+          <p:cNvSpPr txBox="1"/>
+          <p:nvPr/>
+        </p:nvSpPr>
+        <p:spPr>
+          <a:xfrm>
+            <a:off x="5943600" y="5266944"/>
+            <a:ext cx="822960" cy="237744"/>
           </a:xfrm>
           <a:prstGeom prst="rect">
             <a:avLst/>
@@ -48375,440 +48646,23 @@
               <a:buNone/>
             </a:pPr>
             <a:r>
-              <a:rPr lang="en-US" sz="600" dirty="0">
-                <a:solidFill>
-                  <a:srgbClr val="8FA1AC"/>
-                </a:solidFill>
-                <a:latin typeface="Poppins" pitchFamily="34" charset="0"/>
-                <a:ea typeface="Poppins" pitchFamily="34" charset="-122"/>
-                <a:cs typeface="Poppins" pitchFamily="34" charset="-120"/>
-              </a:rPr>
-              <a:t>no time logged</a:t>
-            </a:r>
-            <a:endParaRPr lang="en-US" sz="600" dirty="0"/>
-          </a:p>
-        </p:txBody>
-      </p:sp>
-      <p:sp>
-        <p:nvSpPr>
-          <p:cNvPr id="81" name="Text 79"/>
-          <p:cNvSpPr txBox="1"/>
-          <p:nvPr/>
-        </p:nvSpPr>
-        <p:spPr>
-          <a:xfrm>
-            <a:off x="640080" y="4862945"/>
-            <a:ext cx="1783080" cy="226106"/>
-          </a:xfrm>
-          <a:prstGeom prst="rect">
-            <a:avLst/>
-          </a:prstGeom>
-          <a:noFill/>
-          <a:ln/>
-        </p:spPr>
-        <p:txBody>
-          <a:bodyPr wrap="square" lIns="0" tIns="0" rIns="0" bIns="0" rtlCol="0" anchor="ctr"/>
-          <a:lstStyle/>
-          <a:p>
-            <a:pPr indent="0" marL="0">
-              <a:buNone/>
-            </a:pPr>
-            <a:r>
-              <a:rPr lang="en-US" sz="800" dirty="0">
-                <a:solidFill>
-                  <a:srgbClr val="5E7280"/>
-                </a:solidFill>
-                <a:latin typeface="Poppins" pitchFamily="34" charset="0"/>
-                <a:ea typeface="Poppins" pitchFamily="34" charset="-122"/>
-                <a:cs typeface="Poppins" pitchFamily="34" charset="-120"/>
-              </a:rPr>
-              <a:t>Ryan Neil Orande</a:t>
-            </a:r>
-            <a:endParaRPr lang="en-US" sz="800" dirty="0"/>
-          </a:p>
-        </p:txBody>
-      </p:sp>
-      <p:sp>
-        <p:nvSpPr>
-          <p:cNvPr id="82" name="Shape 80"/>
-          <p:cNvSpPr/>
-          <p:nvPr/>
-        </p:nvSpPr>
-        <p:spPr>
-          <a:xfrm>
-            <a:off x="2468880" y="4946281"/>
-            <a:ext cx="2377440" cy="59436"/>
-          </a:xfrm>
-          <a:prstGeom prst="roundRect">
-            <a:avLst>
-              <a:gd name="adj" fmla="val 49231"/>
-            </a:avLst>
-          </a:prstGeom>
-          <a:solidFill>
-            <a:srgbClr val="E2EAEE"/>
-          </a:solidFill>
-          <a:ln/>
-        </p:spPr>
-      </p:sp>
-      <p:sp>
-        <p:nvSpPr>
-          <p:cNvPr id="83" name="Text 81"/>
-          <p:cNvSpPr txBox="1"/>
-          <p:nvPr/>
-        </p:nvSpPr>
-        <p:spPr>
-          <a:xfrm>
-            <a:off x="5029200" y="4862945"/>
-            <a:ext cx="822960" cy="226106"/>
-          </a:xfrm>
-          <a:prstGeom prst="rect">
-            <a:avLst/>
-          </a:prstGeom>
-          <a:noFill/>
-          <a:ln/>
-        </p:spPr>
-        <p:txBody>
-          <a:bodyPr wrap="square" lIns="0" tIns="0" rIns="0" bIns="0" rtlCol="0" anchor="ctr"/>
-          <a:lstStyle/>
-          <a:p>
-            <a:pPr algn="r" indent="0" marL="0">
-              <a:buNone/>
-            </a:pPr>
-            <a:r>
-              <a:rPr lang="en-US" sz="800" dirty="0">
-                <a:solidFill>
-                  <a:srgbClr val="8FA1AC"/>
-                </a:solidFill>
-                <a:latin typeface="Poppins" pitchFamily="34" charset="0"/>
-                <a:ea typeface="Poppins" pitchFamily="34" charset="-122"/>
-                <a:cs typeface="Poppins" pitchFamily="34" charset="-120"/>
-              </a:rPr>
-              <a:t>—</a:t>
-            </a:r>
-            <a:endParaRPr lang="en-US" sz="800" dirty="0"/>
-          </a:p>
-        </p:txBody>
-      </p:sp>
-      <p:sp>
-        <p:nvSpPr>
-          <p:cNvPr id="84" name="Text 82"/>
-          <p:cNvSpPr txBox="1"/>
-          <p:nvPr/>
-        </p:nvSpPr>
-        <p:spPr>
-          <a:xfrm>
-            <a:off x="5943600" y="4862945"/>
-            <a:ext cx="822960" cy="226106"/>
-          </a:xfrm>
-          <a:prstGeom prst="rect">
-            <a:avLst/>
-          </a:prstGeom>
-          <a:noFill/>
-          <a:ln/>
-        </p:spPr>
-        <p:txBody>
-          <a:bodyPr wrap="square" lIns="0" tIns="0" rIns="0" bIns="0" rtlCol="0" anchor="ctr"/>
-          <a:lstStyle/>
-          <a:p>
-            <a:pPr algn="r" indent="0" marL="0">
-              <a:buNone/>
-            </a:pPr>
-            <a:r>
-              <a:rPr lang="en-US" sz="600" dirty="0">
-                <a:solidFill>
-                  <a:srgbClr val="8FA1AC"/>
-                </a:solidFill>
-                <a:latin typeface="Poppins" pitchFamily="34" charset="0"/>
-                <a:ea typeface="Poppins" pitchFamily="34" charset="-122"/>
-                <a:cs typeface="Poppins" pitchFamily="34" charset="-120"/>
-              </a:rPr>
-              <a:t>no time logged</a:t>
-            </a:r>
-            <a:endParaRPr lang="en-US" sz="600" dirty="0"/>
-          </a:p>
-        </p:txBody>
-      </p:sp>
-      <p:sp>
-        <p:nvSpPr>
-          <p:cNvPr id="85" name="Text 83"/>
-          <p:cNvSpPr txBox="1"/>
-          <p:nvPr/>
-        </p:nvSpPr>
-        <p:spPr>
-          <a:xfrm>
-            <a:off x="640080" y="5089052"/>
-            <a:ext cx="1783080" cy="226106"/>
-          </a:xfrm>
-          <a:prstGeom prst="rect">
-            <a:avLst/>
-          </a:prstGeom>
-          <a:noFill/>
-          <a:ln/>
-        </p:spPr>
-        <p:txBody>
-          <a:bodyPr wrap="square" lIns="0" tIns="0" rIns="0" bIns="0" rtlCol="0" anchor="ctr"/>
-          <a:lstStyle/>
-          <a:p>
-            <a:pPr indent="0" marL="0">
-              <a:buNone/>
-            </a:pPr>
-            <a:r>
-              <a:rPr lang="en-US" sz="800" dirty="0">
-                <a:solidFill>
-                  <a:srgbClr val="5E7280"/>
-                </a:solidFill>
-                <a:latin typeface="Poppins" pitchFamily="34" charset="0"/>
-                <a:ea typeface="Poppins" pitchFamily="34" charset="-122"/>
-                <a:cs typeface="Poppins" pitchFamily="34" charset="-120"/>
-              </a:rPr>
-              <a:t>Argenis Rafael Guevara</a:t>
-            </a:r>
-            <a:endParaRPr lang="en-US" sz="800" dirty="0"/>
-          </a:p>
-        </p:txBody>
-      </p:sp>
-      <p:sp>
-        <p:nvSpPr>
-          <p:cNvPr id="86" name="Shape 84"/>
-          <p:cNvSpPr/>
-          <p:nvPr/>
-        </p:nvSpPr>
-        <p:spPr>
-          <a:xfrm>
-            <a:off x="2468880" y="5172387"/>
-            <a:ext cx="2377440" cy="59436"/>
-          </a:xfrm>
-          <a:prstGeom prst="roundRect">
-            <a:avLst>
-              <a:gd name="adj" fmla="val 49231"/>
-            </a:avLst>
-          </a:prstGeom>
-          <a:solidFill>
-            <a:srgbClr val="E2EAEE"/>
-          </a:solidFill>
-          <a:ln/>
-        </p:spPr>
-      </p:sp>
-      <p:sp>
-        <p:nvSpPr>
-          <p:cNvPr id="87" name="Text 85"/>
-          <p:cNvSpPr txBox="1"/>
-          <p:nvPr/>
-        </p:nvSpPr>
-        <p:spPr>
-          <a:xfrm>
-            <a:off x="5029200" y="5089052"/>
-            <a:ext cx="822960" cy="226106"/>
-          </a:xfrm>
-          <a:prstGeom prst="rect">
-            <a:avLst/>
-          </a:prstGeom>
-          <a:noFill/>
-          <a:ln/>
-        </p:spPr>
-        <p:txBody>
-          <a:bodyPr wrap="square" lIns="0" tIns="0" rIns="0" bIns="0" rtlCol="0" anchor="ctr"/>
-          <a:lstStyle/>
-          <a:p>
-            <a:pPr algn="r" indent="0" marL="0">
-              <a:buNone/>
-            </a:pPr>
-            <a:r>
-              <a:rPr lang="en-US" sz="800" dirty="0">
-                <a:solidFill>
-                  <a:srgbClr val="8FA1AC"/>
-                </a:solidFill>
-                <a:latin typeface="Poppins" pitchFamily="34" charset="0"/>
-                <a:ea typeface="Poppins" pitchFamily="34" charset="-122"/>
-                <a:cs typeface="Poppins" pitchFamily="34" charset="-120"/>
-              </a:rPr>
-              <a:t>—</a:t>
-            </a:r>
-            <a:endParaRPr lang="en-US" sz="800" dirty="0"/>
+              <a:rPr lang="en-US" sz="950" b="1" dirty="0">
+                <a:solidFill>
+                  <a:srgbClr val="C88A2E"/>
+                </a:solidFill>
+                <a:latin typeface="Poppins" pitchFamily="34" charset="0"/>
+                <a:ea typeface="Poppins" pitchFamily="34" charset="-122"/>
+                <a:cs typeface="Poppins" pitchFamily="34" charset="-120"/>
+              </a:rPr>
+              <a:t>4.7%</a:t>
+            </a:r>
+            <a:endParaRPr lang="en-US" sz="950" dirty="0"/>
           </a:p>
         </p:txBody>
       </p:sp>
       <p:sp>
         <p:nvSpPr>
           <p:cNvPr id="88" name="Text 86"/>
-          <p:cNvSpPr txBox="1"/>
-          <p:nvPr/>
-        </p:nvSpPr>
-        <p:spPr>
-          <a:xfrm>
-            <a:off x="5943600" y="5089052"/>
-            <a:ext cx="822960" cy="226106"/>
-          </a:xfrm>
-          <a:prstGeom prst="rect">
-            <a:avLst/>
-          </a:prstGeom>
-          <a:noFill/>
-          <a:ln/>
-        </p:spPr>
-        <p:txBody>
-          <a:bodyPr wrap="square" lIns="0" tIns="0" rIns="0" bIns="0" rtlCol="0" anchor="ctr"/>
-          <a:lstStyle/>
-          <a:p>
-            <a:pPr algn="r" indent="0" marL="0">
-              <a:buNone/>
-            </a:pPr>
-            <a:r>
-              <a:rPr lang="en-US" sz="600" dirty="0">
-                <a:solidFill>
-                  <a:srgbClr val="8FA1AC"/>
-                </a:solidFill>
-                <a:latin typeface="Poppins" pitchFamily="34" charset="0"/>
-                <a:ea typeface="Poppins" pitchFamily="34" charset="-122"/>
-                <a:cs typeface="Poppins" pitchFamily="34" charset="-120"/>
-              </a:rPr>
-              <a:t>no time logged</a:t>
-            </a:r>
-            <a:endParaRPr lang="en-US" sz="600" dirty="0"/>
-          </a:p>
-        </p:txBody>
-      </p:sp>
-      <p:sp>
-        <p:nvSpPr>
-          <p:cNvPr id="89" name="Text 87"/>
-          <p:cNvSpPr txBox="1"/>
-          <p:nvPr/>
-        </p:nvSpPr>
-        <p:spPr>
-          <a:xfrm>
-            <a:off x="640080" y="5315158"/>
-            <a:ext cx="1783080" cy="226106"/>
-          </a:xfrm>
-          <a:prstGeom prst="rect">
-            <a:avLst/>
-          </a:prstGeom>
-          <a:noFill/>
-          <a:ln/>
-        </p:spPr>
-        <p:txBody>
-          <a:bodyPr wrap="square" lIns="0" tIns="0" rIns="0" bIns="0" rtlCol="0" anchor="ctr"/>
-          <a:lstStyle/>
-          <a:p>
-            <a:pPr indent="0" marL="0">
-              <a:buNone/>
-            </a:pPr>
-            <a:r>
-              <a:rPr lang="en-US" sz="800" dirty="0">
-                <a:solidFill>
-                  <a:srgbClr val="5E7280"/>
-                </a:solidFill>
-                <a:latin typeface="Poppins" pitchFamily="34" charset="0"/>
-                <a:ea typeface="Poppins" pitchFamily="34" charset="-122"/>
-                <a:cs typeface="Poppins" pitchFamily="34" charset="-120"/>
-              </a:rPr>
-              <a:t>Isaac Mercado</a:t>
-            </a:r>
-            <a:endParaRPr lang="en-US" sz="800" dirty="0"/>
-          </a:p>
-        </p:txBody>
-      </p:sp>
-      <p:sp>
-        <p:nvSpPr>
-          <p:cNvPr id="90" name="Shape 88"/>
-          <p:cNvSpPr/>
-          <p:nvPr/>
-        </p:nvSpPr>
-        <p:spPr>
-          <a:xfrm>
-            <a:off x="2468880" y="5398493"/>
-            <a:ext cx="2377440" cy="59436"/>
-          </a:xfrm>
-          <a:prstGeom prst="roundRect">
-            <a:avLst>
-              <a:gd name="adj" fmla="val 49231"/>
-            </a:avLst>
-          </a:prstGeom>
-          <a:solidFill>
-            <a:srgbClr val="E2EAEE"/>
-          </a:solidFill>
-          <a:ln/>
-        </p:spPr>
-      </p:sp>
-      <p:sp>
-        <p:nvSpPr>
-          <p:cNvPr id="91" name="Text 89"/>
-          <p:cNvSpPr txBox="1"/>
-          <p:nvPr/>
-        </p:nvSpPr>
-        <p:spPr>
-          <a:xfrm>
-            <a:off x="5029200" y="5315158"/>
-            <a:ext cx="822960" cy="226106"/>
-          </a:xfrm>
-          <a:prstGeom prst="rect">
-            <a:avLst/>
-          </a:prstGeom>
-          <a:noFill/>
-          <a:ln/>
-        </p:spPr>
-        <p:txBody>
-          <a:bodyPr wrap="square" lIns="0" tIns="0" rIns="0" bIns="0" rtlCol="0" anchor="ctr"/>
-          <a:lstStyle/>
-          <a:p>
-            <a:pPr algn="r" indent="0" marL="0">
-              <a:buNone/>
-            </a:pPr>
-            <a:r>
-              <a:rPr lang="en-US" sz="800" dirty="0">
-                <a:solidFill>
-                  <a:srgbClr val="8FA1AC"/>
-                </a:solidFill>
-                <a:latin typeface="Poppins" pitchFamily="34" charset="0"/>
-                <a:ea typeface="Poppins" pitchFamily="34" charset="-122"/>
-                <a:cs typeface="Poppins" pitchFamily="34" charset="-120"/>
-              </a:rPr>
-              <a:t>—</a:t>
-            </a:r>
-            <a:endParaRPr lang="en-US" sz="800" dirty="0"/>
-          </a:p>
-        </p:txBody>
-      </p:sp>
-      <p:sp>
-        <p:nvSpPr>
-          <p:cNvPr id="92" name="Text 90"/>
-          <p:cNvSpPr txBox="1"/>
-          <p:nvPr/>
-        </p:nvSpPr>
-        <p:spPr>
-          <a:xfrm>
-            <a:off x="5943600" y="5315158"/>
-            <a:ext cx="822960" cy="226106"/>
-          </a:xfrm>
-          <a:prstGeom prst="rect">
-            <a:avLst/>
-          </a:prstGeom>
-          <a:noFill/>
-          <a:ln/>
-        </p:spPr>
-        <p:txBody>
-          <a:bodyPr wrap="square" lIns="0" tIns="0" rIns="0" bIns="0" rtlCol="0" anchor="ctr"/>
-          <a:lstStyle/>
-          <a:p>
-            <a:pPr algn="r" indent="0" marL="0">
-              <a:buNone/>
-            </a:pPr>
-            <a:r>
-              <a:rPr lang="en-US" sz="600" dirty="0">
-                <a:solidFill>
-                  <a:srgbClr val="8FA1AC"/>
-                </a:solidFill>
-                <a:latin typeface="Poppins" pitchFamily="34" charset="0"/>
-                <a:ea typeface="Poppins" pitchFamily="34" charset="-122"/>
-                <a:cs typeface="Poppins" pitchFamily="34" charset="-120"/>
-              </a:rPr>
-              <a:t>no time logged</a:t>
-            </a:r>
-            <a:endParaRPr lang="en-US" sz="600" dirty="0"/>
-          </a:p>
-        </p:txBody>
-      </p:sp>
-      <p:sp>
-        <p:nvSpPr>
-          <p:cNvPr id="93" name="Text 91"/>
           <p:cNvSpPr txBox="1"/>
           <p:nvPr/>
         </p:nvSpPr>
@@ -48839,7 +48693,7 @@
                 <a:ea typeface="Poppins" pitchFamily="34" charset="-122"/>
                 <a:cs typeface="Poppins" pitchFamily="34" charset="-120"/>
               </a:rPr>
-              <a:t>Available staff = the 11 Professional Services people assigned to PS-pipeline tickets open now or closed this week, at a 38h standard week. Anton Lopez, Jasmine Hikuroa, Bjorn Magabo and Phuong Ho carry PS-pipeline tickets but are not Professional Services staff — excluded from the capacity base.</a:t>
+              <a:t>Available staff = the 9 Professional Services people assigned to PS-pipeline tickets open now or closed this week, at a 38h standard week. Anton Lopez, Jasmine Hikuroa, Bjorn Magabo, Phuong Ho, Katherine Fenwick and Yeran Hettiarachchy carry PS-pipeline tickets but are not Professional Services staff — they and their hours are excluded.</a:t>
             </a:r>
             <a:endParaRPr lang="en-US" sz="580" dirty="0"/>
           </a:p>
@@ -48847,7 +48701,7 @@
       </p:sp>
       <p:sp>
         <p:nvSpPr>
-          <p:cNvPr id="94" name="Shape 92"/>
+          <p:cNvPr id="89" name="Shape 87"/>
           <p:cNvSpPr/>
           <p:nvPr/>
         </p:nvSpPr>
@@ -48876,7 +48730,7 @@
       </p:sp>
       <p:sp>
         <p:nvSpPr>
-          <p:cNvPr id="95" name="Text 93"/>
+          <p:cNvPr id="90" name="Text 88"/>
           <p:cNvSpPr txBox="1"/>
           <p:nvPr/>
         </p:nvSpPr>
@@ -48929,7 +48783,7 @@
       </p:sp>
       <p:sp>
         <p:nvSpPr>
-          <p:cNvPr id="96" name="Text 94"/>
+          <p:cNvPr id="91" name="Text 89"/>
           <p:cNvSpPr txBox="1"/>
           <p:nvPr/>
         </p:nvSpPr>
@@ -48968,7 +48822,7 @@
       </p:sp>
       <p:sp>
         <p:nvSpPr>
-          <p:cNvPr id="97" name="Text 95"/>
+          <p:cNvPr id="92" name="Text 90"/>
           <p:cNvSpPr txBox="1"/>
           <p:nvPr/>
         </p:nvSpPr>
@@ -49007,7 +48861,7 @@
       </p:sp>
       <p:sp>
         <p:nvSpPr>
-          <p:cNvPr id="98" name="Text 96"/>
+          <p:cNvPr id="93" name="Text 91"/>
           <p:cNvSpPr txBox="1"/>
           <p:nvPr/>
         </p:nvSpPr>
@@ -49046,14 +48900,14 @@
       </p:sp>
       <p:sp>
         <p:nvSpPr>
-          <p:cNvPr id="99" name="Text 97"/>
-          <p:cNvSpPr txBox="1"/>
-          <p:nvPr/>
-        </p:nvSpPr>
-        <p:spPr>
-          <a:xfrm>
-            <a:off x="7379208" y="2944368"/>
-            <a:ext cx="1371600" cy="196596"/>
+          <p:cNvPr id="94" name="Text 92"/>
+          <p:cNvSpPr txBox="1"/>
+          <p:nvPr/>
+        </p:nvSpPr>
+        <p:spPr>
+          <a:xfrm>
+            <a:off x="7379208" y="2926080"/>
+            <a:ext cx="1371600" cy="173736"/>
           </a:xfrm>
           <a:prstGeom prst="rect">
             <a:avLst/>
@@ -49085,13 +48939,13 @@
       </p:sp>
       <p:sp>
         <p:nvSpPr>
-          <p:cNvPr id="100" name="Shape 98"/>
-          <p:cNvSpPr/>
-          <p:nvPr/>
-        </p:nvSpPr>
-        <p:spPr>
-          <a:xfrm>
-            <a:off x="8823960" y="3012948"/>
+          <p:cNvPr id="95" name="Shape 93"/>
+          <p:cNvSpPr/>
+          <p:nvPr/>
+        </p:nvSpPr>
+        <p:spPr>
+          <a:xfrm>
+            <a:off x="8823960" y="2983687"/>
             <a:ext cx="1371600" cy="59436"/>
           </a:xfrm>
           <a:prstGeom prst="roundRect">
@@ -49107,13 +48961,13 @@
       </p:sp>
       <p:sp>
         <p:nvSpPr>
-          <p:cNvPr id="101" name="Shape 99"/>
-          <p:cNvSpPr/>
-          <p:nvPr/>
-        </p:nvSpPr>
-        <p:spPr>
-          <a:xfrm>
-            <a:off x="8823960" y="3012948"/>
+          <p:cNvPr id="96" name="Shape 94"/>
+          <p:cNvSpPr/>
+          <p:nvPr/>
+        </p:nvSpPr>
+        <p:spPr>
+          <a:xfrm>
+            <a:off x="8823960" y="2983687"/>
             <a:ext cx="1371600" cy="59436"/>
           </a:xfrm>
           <a:prstGeom prst="roundRect">
@@ -49129,14 +48983,14 @@
       </p:sp>
       <p:sp>
         <p:nvSpPr>
-          <p:cNvPr id="102" name="Text 100"/>
-          <p:cNvSpPr txBox="1"/>
-          <p:nvPr/>
-        </p:nvSpPr>
-        <p:spPr>
-          <a:xfrm>
-            <a:off x="10287000" y="2944368"/>
-            <a:ext cx="640080" cy="196596"/>
+          <p:cNvPr id="97" name="Text 95"/>
+          <p:cNvSpPr txBox="1"/>
+          <p:nvPr/>
+        </p:nvSpPr>
+        <p:spPr>
+          <a:xfrm>
+            <a:off x="10287000" y="2926080"/>
+            <a:ext cx="640080" cy="173736"/>
           </a:xfrm>
           <a:prstGeom prst="rect">
             <a:avLst/>
@@ -49160,7 +49014,7 @@
                 <a:ea typeface="Poppins" pitchFamily="34" charset="-122"/>
                 <a:cs typeface="Poppins" pitchFamily="34" charset="-120"/>
               </a:rPr>
-              <a:t>31.44h</a:t>
+              <a:t>16.00h</a:t>
             </a:r>
             <a:endParaRPr lang="en-US" sz="800" dirty="0"/>
           </a:p>
@@ -49168,14 +49022,14 @@
       </p:sp>
       <p:sp>
         <p:nvSpPr>
-          <p:cNvPr id="103" name="Text 101"/>
-          <p:cNvSpPr txBox="1"/>
-          <p:nvPr/>
-        </p:nvSpPr>
-        <p:spPr>
-          <a:xfrm>
-            <a:off x="10972800" y="2944368"/>
-            <a:ext cx="603504" cy="196596"/>
+          <p:cNvPr id="98" name="Text 96"/>
+          <p:cNvSpPr txBox="1"/>
+          <p:nvPr/>
+        </p:nvSpPr>
+        <p:spPr>
+          <a:xfrm>
+            <a:off x="10972800" y="2926080"/>
+            <a:ext cx="603504" cy="173736"/>
           </a:xfrm>
           <a:prstGeom prst="rect">
             <a:avLst/>
@@ -49199,7 +49053,7 @@
                 <a:ea typeface="Poppins" pitchFamily="34" charset="-122"/>
                 <a:cs typeface="Poppins" pitchFamily="34" charset="-120"/>
               </a:rPr>
-              <a:t>95.2%</a:t>
+              <a:t>99.6%</a:t>
             </a:r>
             <a:endParaRPr lang="en-US" sz="800" dirty="0"/>
           </a:p>
@@ -49207,14 +49061,14 @@
       </p:sp>
       <p:sp>
         <p:nvSpPr>
-          <p:cNvPr id="104" name="Text 102"/>
-          <p:cNvSpPr txBox="1"/>
-          <p:nvPr/>
-        </p:nvSpPr>
-        <p:spPr>
-          <a:xfrm>
-            <a:off x="7379208" y="3140964"/>
-            <a:ext cx="1371600" cy="196596"/>
+          <p:cNvPr id="99" name="Text 97"/>
+          <p:cNvSpPr txBox="1"/>
+          <p:nvPr/>
+        </p:nvSpPr>
+        <p:spPr>
+          <a:xfrm>
+            <a:off x="7379208" y="3099816"/>
+            <a:ext cx="1371600" cy="173736"/>
           </a:xfrm>
           <a:prstGeom prst="rect">
             <a:avLst/>
@@ -49246,13 +49100,13 @@
       </p:sp>
       <p:sp>
         <p:nvSpPr>
-          <p:cNvPr id="105" name="Shape 103"/>
-          <p:cNvSpPr/>
-          <p:nvPr/>
-        </p:nvSpPr>
-        <p:spPr>
-          <a:xfrm>
-            <a:off x="8823960" y="3209544"/>
+          <p:cNvPr id="100" name="Shape 98"/>
+          <p:cNvSpPr/>
+          <p:nvPr/>
+        </p:nvSpPr>
+        <p:spPr>
+          <a:xfrm>
+            <a:off x="8823960" y="3157423"/>
             <a:ext cx="1371600" cy="59436"/>
           </a:xfrm>
           <a:prstGeom prst="roundRect">
@@ -49268,14 +49122,153 @@
       </p:sp>
       <p:sp>
         <p:nvSpPr>
-          <p:cNvPr id="106" name="Shape 104"/>
-          <p:cNvSpPr/>
-          <p:nvPr/>
-        </p:nvSpPr>
-        <p:spPr>
-          <a:xfrm>
-            <a:off x="8823960" y="3209544"/>
-            <a:ext cx="68493" cy="59436"/>
+          <p:cNvPr id="101" name="Shape 99"/>
+          <p:cNvSpPr/>
+          <p:nvPr/>
+        </p:nvSpPr>
+        <p:spPr>
+          <a:xfrm>
+            <a:off x="8823960" y="3157423"/>
+            <a:ext cx="45720" cy="59436"/>
+          </a:xfrm>
+          <a:prstGeom prst="roundRect">
+            <a:avLst>
+              <a:gd name="adj" fmla="val 64000"/>
+            </a:avLst>
+          </a:prstGeom>
+          <a:solidFill>
+            <a:srgbClr val="2C8394"/>
+          </a:solidFill>
+          <a:ln/>
+        </p:spPr>
+      </p:sp>
+      <p:sp>
+        <p:nvSpPr>
+          <p:cNvPr id="102" name="Text 100"/>
+          <p:cNvSpPr txBox="1"/>
+          <p:nvPr/>
+        </p:nvSpPr>
+        <p:spPr>
+          <a:xfrm>
+            <a:off x="10287000" y="3099816"/>
+            <a:ext cx="640080" cy="173736"/>
+          </a:xfrm>
+          <a:prstGeom prst="rect">
+            <a:avLst/>
+          </a:prstGeom>
+          <a:noFill/>
+          <a:ln/>
+        </p:spPr>
+        <p:txBody>
+          <a:bodyPr wrap="square" lIns="0" tIns="0" rIns="0" bIns="0" rtlCol="0" anchor="ctr"/>
+          <a:lstStyle/>
+          <a:p>
+            <a:pPr algn="r" indent="0" marL="0">
+              <a:buNone/>
+            </a:pPr>
+            <a:r>
+              <a:rPr lang="en-US" sz="800" b="1" dirty="0">
+                <a:solidFill>
+                  <a:srgbClr val="2C8394"/>
+                </a:solidFill>
+                <a:latin typeface="Poppins" pitchFamily="34" charset="0"/>
+                <a:ea typeface="Poppins" pitchFamily="34" charset="-122"/>
+                <a:cs typeface="Poppins" pitchFamily="34" charset="-120"/>
+              </a:rPr>
+              <a:t>0.07h</a:t>
+            </a:r>
+            <a:endParaRPr lang="en-US" sz="800" dirty="0"/>
+          </a:p>
+        </p:txBody>
+      </p:sp>
+      <p:sp>
+        <p:nvSpPr>
+          <p:cNvPr id="103" name="Text 101"/>
+          <p:cNvSpPr txBox="1"/>
+          <p:nvPr/>
+        </p:nvSpPr>
+        <p:spPr>
+          <a:xfrm>
+            <a:off x="10972800" y="3099816"/>
+            <a:ext cx="603504" cy="173736"/>
+          </a:xfrm>
+          <a:prstGeom prst="rect">
+            <a:avLst/>
+          </a:prstGeom>
+          <a:noFill/>
+          <a:ln/>
+        </p:spPr>
+        <p:txBody>
+          <a:bodyPr wrap="square" lIns="0" tIns="0" rIns="0" bIns="0" rtlCol="0" anchor="ctr"/>
+          <a:lstStyle/>
+          <a:p>
+            <a:pPr algn="r" indent="0" marL="0">
+              <a:buNone/>
+            </a:pPr>
+            <a:r>
+              <a:rPr lang="en-US" sz="800" dirty="0">
+                <a:solidFill>
+                  <a:srgbClr val="5E7280"/>
+                </a:solidFill>
+                <a:latin typeface="Poppins" pitchFamily="34" charset="0"/>
+                <a:ea typeface="Poppins" pitchFamily="34" charset="-122"/>
+                <a:cs typeface="Poppins" pitchFamily="34" charset="-120"/>
+              </a:rPr>
+              <a:t>0.4%</a:t>
+            </a:r>
+            <a:endParaRPr lang="en-US" sz="800" dirty="0"/>
+          </a:p>
+        </p:txBody>
+      </p:sp>
+      <p:sp>
+        <p:nvSpPr>
+          <p:cNvPr id="104" name="Text 102"/>
+          <p:cNvSpPr txBox="1"/>
+          <p:nvPr/>
+        </p:nvSpPr>
+        <p:spPr>
+          <a:xfrm>
+            <a:off x="7379208" y="3273552"/>
+            <a:ext cx="1371600" cy="173736"/>
+          </a:xfrm>
+          <a:prstGeom prst="rect">
+            <a:avLst/>
+          </a:prstGeom>
+          <a:noFill/>
+          <a:ln/>
+        </p:spPr>
+        <p:txBody>
+          <a:bodyPr wrap="square" lIns="0" tIns="0" rIns="0" bIns="0" rtlCol="0" anchor="ctr"/>
+          <a:lstStyle/>
+          <a:p>
+            <a:pPr indent="0" marL="0">
+              <a:buNone/>
+            </a:pPr>
+            <a:r>
+              <a:rPr lang="en-US" sz="800" dirty="0">
+                <a:solidFill>
+                  <a:srgbClr val="5E7280"/>
+                </a:solidFill>
+                <a:latin typeface="Poppins" pitchFamily="34" charset="0"/>
+                <a:ea typeface="Poppins" pitchFamily="34" charset="-122"/>
+                <a:cs typeface="Poppins" pitchFamily="34" charset="-120"/>
+              </a:rPr>
+              <a:t>Onboarding</a:t>
+            </a:r>
+            <a:endParaRPr lang="en-US" sz="800" dirty="0"/>
+          </a:p>
+        </p:txBody>
+      </p:sp>
+      <p:sp>
+        <p:nvSpPr>
+          <p:cNvPr id="105" name="Shape 103"/>
+          <p:cNvSpPr/>
+          <p:nvPr/>
+        </p:nvSpPr>
+        <p:spPr>
+          <a:xfrm>
+            <a:off x="8823960" y="3331159"/>
+            <a:ext cx="1371600" cy="59436"/>
           </a:xfrm>
           <a:prstGeom prst="roundRect">
             <a:avLst>
@@ -49283,10 +49276,49 @@
             </a:avLst>
           </a:prstGeom>
           <a:solidFill>
-            <a:srgbClr val="2C8394"/>
-          </a:solidFill>
-          <a:ln/>
-        </p:spPr>
+            <a:srgbClr val="E2EAEE"/>
+          </a:solidFill>
+          <a:ln/>
+        </p:spPr>
+      </p:sp>
+      <p:sp>
+        <p:nvSpPr>
+          <p:cNvPr id="106" name="Text 104"/>
+          <p:cNvSpPr txBox="1"/>
+          <p:nvPr/>
+        </p:nvSpPr>
+        <p:spPr>
+          <a:xfrm>
+            <a:off x="10287000" y="3273552"/>
+            <a:ext cx="640080" cy="173736"/>
+          </a:xfrm>
+          <a:prstGeom prst="rect">
+            <a:avLst/>
+          </a:prstGeom>
+          <a:noFill/>
+          <a:ln/>
+        </p:spPr>
+        <p:txBody>
+          <a:bodyPr wrap="square" lIns="0" tIns="0" rIns="0" bIns="0" rtlCol="0" anchor="ctr"/>
+          <a:lstStyle/>
+          <a:p>
+            <a:pPr algn="r" indent="0" marL="0">
+              <a:buNone/>
+            </a:pPr>
+            <a:r>
+              <a:rPr lang="en-US" sz="800" dirty="0">
+                <a:solidFill>
+                  <a:srgbClr val="8FA1AC"/>
+                </a:solidFill>
+                <a:latin typeface="Poppins" pitchFamily="34" charset="0"/>
+                <a:ea typeface="Poppins" pitchFamily="34" charset="-122"/>
+                <a:cs typeface="Poppins" pitchFamily="34" charset="-120"/>
+              </a:rPr>
+              <a:t>—</a:t>
+            </a:r>
+            <a:endParaRPr lang="en-US" sz="800" dirty="0"/>
+          </a:p>
+        </p:txBody>
       </p:sp>
       <p:sp>
         <p:nvSpPr>
@@ -49296,8 +49328,8 @@
         </p:nvSpPr>
         <p:spPr>
           <a:xfrm>
-            <a:off x="10287000" y="3140964"/>
-            <a:ext cx="640080" cy="196596"/>
+            <a:off x="10972800" y="3273552"/>
+            <a:ext cx="603504" cy="173736"/>
           </a:xfrm>
           <a:prstGeom prst="rect">
             <a:avLst/>
@@ -49313,15 +49345,54 @@
               <a:buNone/>
             </a:pPr>
             <a:r>
-              <a:rPr lang="en-US" sz="800" b="1" dirty="0">
-                <a:solidFill>
-                  <a:srgbClr val="2C8394"/>
-                </a:solidFill>
-                <a:latin typeface="Poppins" pitchFamily="34" charset="0"/>
-                <a:ea typeface="Poppins" pitchFamily="34" charset="-122"/>
-                <a:cs typeface="Poppins" pitchFamily="34" charset="-120"/>
-              </a:rPr>
-              <a:t>1.57h</a:t>
+              <a:rPr lang="en-US" sz="650" dirty="0">
+                <a:solidFill>
+                  <a:srgbClr val="8FA1AC"/>
+                </a:solidFill>
+                <a:latin typeface="Poppins" pitchFamily="34" charset="0"/>
+                <a:ea typeface="Poppins" pitchFamily="34" charset="-122"/>
+                <a:cs typeface="Poppins" pitchFamily="34" charset="-120"/>
+              </a:rPr>
+              <a:t>none</a:t>
+            </a:r>
+            <a:endParaRPr lang="en-US" sz="650" dirty="0"/>
+          </a:p>
+        </p:txBody>
+      </p:sp>
+      <p:sp>
+        <p:nvSpPr>
+          <p:cNvPr id="108" name="Text 106"/>
+          <p:cNvSpPr txBox="1"/>
+          <p:nvPr/>
+        </p:nvSpPr>
+        <p:spPr>
+          <a:xfrm>
+            <a:off x="7379208" y="3447288"/>
+            <a:ext cx="1371600" cy="173736"/>
+          </a:xfrm>
+          <a:prstGeom prst="rect">
+            <a:avLst/>
+          </a:prstGeom>
+          <a:noFill/>
+          <a:ln/>
+        </p:spPr>
+        <p:txBody>
+          <a:bodyPr wrap="square" lIns="0" tIns="0" rIns="0" bIns="0" rtlCol="0" anchor="ctr"/>
+          <a:lstStyle/>
+          <a:p>
+            <a:pPr indent="0" marL="0">
+              <a:buNone/>
+            </a:pPr>
+            <a:r>
+              <a:rPr lang="en-US" sz="800" dirty="0">
+                <a:solidFill>
+                  <a:srgbClr val="5E7280"/>
+                </a:solidFill>
+                <a:latin typeface="Poppins" pitchFamily="34" charset="0"/>
+                <a:ea typeface="Poppins" pitchFamily="34" charset="-122"/>
+                <a:cs typeface="Poppins" pitchFamily="34" charset="-120"/>
+              </a:rPr>
+              <a:t>Training</a:t>
             </a:r>
             <a:endParaRPr lang="en-US" sz="800" dirty="0"/>
           </a:p>
@@ -49329,91 +49400,13 @@
       </p:sp>
       <p:sp>
         <p:nvSpPr>
-          <p:cNvPr id="108" name="Text 106"/>
-          <p:cNvSpPr txBox="1"/>
-          <p:nvPr/>
-        </p:nvSpPr>
-        <p:spPr>
-          <a:xfrm>
-            <a:off x="10972800" y="3140964"/>
-            <a:ext cx="603504" cy="196596"/>
-          </a:xfrm>
-          <a:prstGeom prst="rect">
-            <a:avLst/>
-          </a:prstGeom>
-          <a:noFill/>
-          <a:ln/>
-        </p:spPr>
-        <p:txBody>
-          <a:bodyPr wrap="square" lIns="0" tIns="0" rIns="0" bIns="0" rtlCol="0" anchor="ctr"/>
-          <a:lstStyle/>
-          <a:p>
-            <a:pPr algn="r" indent="0" marL="0">
-              <a:buNone/>
-            </a:pPr>
-            <a:r>
-              <a:rPr lang="en-US" sz="800" dirty="0">
-                <a:solidFill>
-                  <a:srgbClr val="5E7280"/>
-                </a:solidFill>
-                <a:latin typeface="Poppins" pitchFamily="34" charset="0"/>
-                <a:ea typeface="Poppins" pitchFamily="34" charset="-122"/>
-                <a:cs typeface="Poppins" pitchFamily="34" charset="-120"/>
-              </a:rPr>
-              <a:t>4.8%</a:t>
-            </a:r>
-            <a:endParaRPr lang="en-US" sz="800" dirty="0"/>
-          </a:p>
-        </p:txBody>
-      </p:sp>
-      <p:sp>
-        <p:nvSpPr>
-          <p:cNvPr id="109" name="Text 107"/>
-          <p:cNvSpPr txBox="1"/>
-          <p:nvPr/>
-        </p:nvSpPr>
-        <p:spPr>
-          <a:xfrm>
-            <a:off x="7379208" y="3337560"/>
-            <a:ext cx="1371600" cy="196596"/>
-          </a:xfrm>
-          <a:prstGeom prst="rect">
-            <a:avLst/>
-          </a:prstGeom>
-          <a:noFill/>
-          <a:ln/>
-        </p:spPr>
-        <p:txBody>
-          <a:bodyPr wrap="square" lIns="0" tIns="0" rIns="0" bIns="0" rtlCol="0" anchor="ctr"/>
-          <a:lstStyle/>
-          <a:p>
-            <a:pPr indent="0" marL="0">
-              <a:buNone/>
-            </a:pPr>
-            <a:r>
-              <a:rPr lang="en-US" sz="800" dirty="0">
-                <a:solidFill>
-                  <a:srgbClr val="5E7280"/>
-                </a:solidFill>
-                <a:latin typeface="Poppins" pitchFamily="34" charset="0"/>
-                <a:ea typeface="Poppins" pitchFamily="34" charset="-122"/>
-                <a:cs typeface="Poppins" pitchFamily="34" charset="-120"/>
-              </a:rPr>
-              <a:t>Onboarding</a:t>
-            </a:r>
-            <a:endParaRPr lang="en-US" sz="800" dirty="0"/>
-          </a:p>
-        </p:txBody>
-      </p:sp>
-      <p:sp>
-        <p:nvSpPr>
-          <p:cNvPr id="110" name="Shape 108"/>
-          <p:cNvSpPr/>
-          <p:nvPr/>
-        </p:nvSpPr>
-        <p:spPr>
-          <a:xfrm>
-            <a:off x="8823960" y="3406140"/>
+          <p:cNvPr id="109" name="Shape 107"/>
+          <p:cNvSpPr/>
+          <p:nvPr/>
+        </p:nvSpPr>
+        <p:spPr>
+          <a:xfrm>
+            <a:off x="8823960" y="3504895"/>
             <a:ext cx="1371600" cy="59436"/>
           </a:xfrm>
           <a:prstGeom prst="roundRect">
@@ -49429,14 +49422,53 @@
       </p:sp>
       <p:sp>
         <p:nvSpPr>
+          <p:cNvPr id="110" name="Text 108"/>
+          <p:cNvSpPr txBox="1"/>
+          <p:nvPr/>
+        </p:nvSpPr>
+        <p:spPr>
+          <a:xfrm>
+            <a:off x="10287000" y="3447288"/>
+            <a:ext cx="640080" cy="173736"/>
+          </a:xfrm>
+          <a:prstGeom prst="rect">
+            <a:avLst/>
+          </a:prstGeom>
+          <a:noFill/>
+          <a:ln/>
+        </p:spPr>
+        <p:txBody>
+          <a:bodyPr wrap="square" lIns="0" tIns="0" rIns="0" bIns="0" rtlCol="0" anchor="ctr"/>
+          <a:lstStyle/>
+          <a:p>
+            <a:pPr algn="r" indent="0" marL="0">
+              <a:buNone/>
+            </a:pPr>
+            <a:r>
+              <a:rPr lang="en-US" sz="800" dirty="0">
+                <a:solidFill>
+                  <a:srgbClr val="8FA1AC"/>
+                </a:solidFill>
+                <a:latin typeface="Poppins" pitchFamily="34" charset="0"/>
+                <a:ea typeface="Poppins" pitchFamily="34" charset="-122"/>
+                <a:cs typeface="Poppins" pitchFamily="34" charset="-120"/>
+              </a:rPr>
+              <a:t>—</a:t>
+            </a:r>
+            <a:endParaRPr lang="en-US" sz="800" dirty="0"/>
+          </a:p>
+        </p:txBody>
+      </p:sp>
+      <p:sp>
+        <p:nvSpPr>
           <p:cNvPr id="111" name="Text 109"/>
           <p:cNvSpPr txBox="1"/>
           <p:nvPr/>
         </p:nvSpPr>
         <p:spPr>
           <a:xfrm>
-            <a:off x="10287000" y="3337560"/>
-            <a:ext cx="640080" cy="196596"/>
+            <a:off x="10972800" y="3447288"/>
+            <a:ext cx="603504" cy="173736"/>
           </a:xfrm>
           <a:prstGeom prst="rect">
             <a:avLst/>
@@ -49452,15 +49484,54 @@
               <a:buNone/>
             </a:pPr>
             <a:r>
+              <a:rPr lang="en-US" sz="650" dirty="0">
+                <a:solidFill>
+                  <a:srgbClr val="8FA1AC"/>
+                </a:solidFill>
+                <a:latin typeface="Poppins" pitchFamily="34" charset="0"/>
+                <a:ea typeface="Poppins" pitchFamily="34" charset="-122"/>
+                <a:cs typeface="Poppins" pitchFamily="34" charset="-120"/>
+              </a:rPr>
+              <a:t>none</a:t>
+            </a:r>
+            <a:endParaRPr lang="en-US" sz="650" dirty="0"/>
+          </a:p>
+        </p:txBody>
+      </p:sp>
+      <p:sp>
+        <p:nvSpPr>
+          <p:cNvPr id="112" name="Text 110"/>
+          <p:cNvSpPr txBox="1"/>
+          <p:nvPr/>
+        </p:nvSpPr>
+        <p:spPr>
+          <a:xfrm>
+            <a:off x="7379208" y="3621024"/>
+            <a:ext cx="1371600" cy="173736"/>
+          </a:xfrm>
+          <a:prstGeom prst="rect">
+            <a:avLst/>
+          </a:prstGeom>
+          <a:noFill/>
+          <a:ln/>
+        </p:spPr>
+        <p:txBody>
+          <a:bodyPr wrap="square" lIns="0" tIns="0" rIns="0" bIns="0" rtlCol="0" anchor="ctr"/>
+          <a:lstStyle/>
+          <a:p>
+            <a:pPr indent="0" marL="0">
+              <a:buNone/>
+            </a:pPr>
+            <a:r>
               <a:rPr lang="en-US" sz="800" dirty="0">
                 <a:solidFill>
-                  <a:srgbClr val="8FA1AC"/>
-                </a:solidFill>
-                <a:latin typeface="Poppins" pitchFamily="34" charset="0"/>
-                <a:ea typeface="Poppins" pitchFamily="34" charset="-122"/>
-                <a:cs typeface="Poppins" pitchFamily="34" charset="-120"/>
-              </a:rPr>
-              <a:t>—</a:t>
+                  <a:srgbClr val="5E7280"/>
+                </a:solidFill>
+                <a:latin typeface="Poppins" pitchFamily="34" charset="0"/>
+                <a:ea typeface="Poppins" pitchFamily="34" charset="-122"/>
+                <a:cs typeface="Poppins" pitchFamily="34" charset="-120"/>
+              </a:rPr>
+              <a:t>Warranty</a:t>
             </a:r>
             <a:endParaRPr lang="en-US" sz="800" dirty="0"/>
           </a:p>
@@ -49468,91 +49539,13 @@
       </p:sp>
       <p:sp>
         <p:nvSpPr>
-          <p:cNvPr id="112" name="Text 110"/>
-          <p:cNvSpPr txBox="1"/>
-          <p:nvPr/>
-        </p:nvSpPr>
-        <p:spPr>
-          <a:xfrm>
-            <a:off x="10972800" y="3337560"/>
-            <a:ext cx="603504" cy="196596"/>
-          </a:xfrm>
-          <a:prstGeom prst="rect">
-            <a:avLst/>
-          </a:prstGeom>
-          <a:noFill/>
-          <a:ln/>
-        </p:spPr>
-        <p:txBody>
-          <a:bodyPr wrap="square" lIns="0" tIns="0" rIns="0" bIns="0" rtlCol="0" anchor="ctr"/>
-          <a:lstStyle/>
-          <a:p>
-            <a:pPr algn="r" indent="0" marL="0">
-              <a:buNone/>
-            </a:pPr>
-            <a:r>
-              <a:rPr lang="en-US" sz="650" dirty="0">
-                <a:solidFill>
-                  <a:srgbClr val="8FA1AC"/>
-                </a:solidFill>
-                <a:latin typeface="Poppins" pitchFamily="34" charset="0"/>
-                <a:ea typeface="Poppins" pitchFamily="34" charset="-122"/>
-                <a:cs typeface="Poppins" pitchFamily="34" charset="-120"/>
-              </a:rPr>
-              <a:t>none</a:t>
-            </a:r>
-            <a:endParaRPr lang="en-US" sz="650" dirty="0"/>
-          </a:p>
-        </p:txBody>
-      </p:sp>
-      <p:sp>
-        <p:nvSpPr>
-          <p:cNvPr id="113" name="Text 111"/>
-          <p:cNvSpPr txBox="1"/>
-          <p:nvPr/>
-        </p:nvSpPr>
-        <p:spPr>
-          <a:xfrm>
-            <a:off x="7379208" y="3534156"/>
-            <a:ext cx="1371600" cy="196596"/>
-          </a:xfrm>
-          <a:prstGeom prst="rect">
-            <a:avLst/>
-          </a:prstGeom>
-          <a:noFill/>
-          <a:ln/>
-        </p:spPr>
-        <p:txBody>
-          <a:bodyPr wrap="square" lIns="0" tIns="0" rIns="0" bIns="0" rtlCol="0" anchor="ctr"/>
-          <a:lstStyle/>
-          <a:p>
-            <a:pPr indent="0" marL="0">
-              <a:buNone/>
-            </a:pPr>
-            <a:r>
-              <a:rPr lang="en-US" sz="800" dirty="0">
-                <a:solidFill>
-                  <a:srgbClr val="5E7280"/>
-                </a:solidFill>
-                <a:latin typeface="Poppins" pitchFamily="34" charset="0"/>
-                <a:ea typeface="Poppins" pitchFamily="34" charset="-122"/>
-                <a:cs typeface="Poppins" pitchFamily="34" charset="-120"/>
-              </a:rPr>
-              <a:t>Training</a:t>
-            </a:r>
-            <a:endParaRPr lang="en-US" sz="800" dirty="0"/>
-          </a:p>
-        </p:txBody>
-      </p:sp>
-      <p:sp>
-        <p:nvSpPr>
-          <p:cNvPr id="114" name="Shape 112"/>
-          <p:cNvSpPr/>
-          <p:nvPr/>
-        </p:nvSpPr>
-        <p:spPr>
-          <a:xfrm>
-            <a:off x="8823960" y="3602736"/>
+          <p:cNvPr id="113" name="Shape 111"/>
+          <p:cNvSpPr/>
+          <p:nvPr/>
+        </p:nvSpPr>
+        <p:spPr>
+          <a:xfrm>
+            <a:off x="8823960" y="3678631"/>
             <a:ext cx="1371600" cy="59436"/>
           </a:xfrm>
           <a:prstGeom prst="roundRect">
@@ -49568,14 +49561,53 @@
       </p:sp>
       <p:sp>
         <p:nvSpPr>
+          <p:cNvPr id="114" name="Text 112"/>
+          <p:cNvSpPr txBox="1"/>
+          <p:nvPr/>
+        </p:nvSpPr>
+        <p:spPr>
+          <a:xfrm>
+            <a:off x="10287000" y="3621024"/>
+            <a:ext cx="640080" cy="173736"/>
+          </a:xfrm>
+          <a:prstGeom prst="rect">
+            <a:avLst/>
+          </a:prstGeom>
+          <a:noFill/>
+          <a:ln/>
+        </p:spPr>
+        <p:txBody>
+          <a:bodyPr wrap="square" lIns="0" tIns="0" rIns="0" bIns="0" rtlCol="0" anchor="ctr"/>
+          <a:lstStyle/>
+          <a:p>
+            <a:pPr algn="r" indent="0" marL="0">
+              <a:buNone/>
+            </a:pPr>
+            <a:r>
+              <a:rPr lang="en-US" sz="800" dirty="0">
+                <a:solidFill>
+                  <a:srgbClr val="8FA1AC"/>
+                </a:solidFill>
+                <a:latin typeface="Poppins" pitchFamily="34" charset="0"/>
+                <a:ea typeface="Poppins" pitchFamily="34" charset="-122"/>
+                <a:cs typeface="Poppins" pitchFamily="34" charset="-120"/>
+              </a:rPr>
+              <a:t>—</a:t>
+            </a:r>
+            <a:endParaRPr lang="en-US" sz="800" dirty="0"/>
+          </a:p>
+        </p:txBody>
+      </p:sp>
+      <p:sp>
+        <p:nvSpPr>
           <p:cNvPr id="115" name="Text 113"/>
           <p:cNvSpPr txBox="1"/>
           <p:nvPr/>
         </p:nvSpPr>
         <p:spPr>
           <a:xfrm>
-            <a:off x="10287000" y="3534156"/>
-            <a:ext cx="640080" cy="196596"/>
+            <a:off x="10972800" y="3621024"/>
+            <a:ext cx="603504" cy="173736"/>
           </a:xfrm>
           <a:prstGeom prst="rect">
             <a:avLst/>
@@ -49591,7 +49623,7 @@
               <a:buNone/>
             </a:pPr>
             <a:r>
-              <a:rPr lang="en-US" sz="800" dirty="0">
+              <a:rPr lang="en-US" sz="650" dirty="0">
                 <a:solidFill>
                   <a:srgbClr val="8FA1AC"/>
                 </a:solidFill>
@@ -49599,187 +49631,185 @@
                 <a:ea typeface="Poppins" pitchFamily="34" charset="-122"/>
                 <a:cs typeface="Poppins" pitchFamily="34" charset="-120"/>
               </a:rPr>
-              <a:t>—</a:t>
+              <a:t>none</a:t>
+            </a:r>
+            <a:endParaRPr lang="en-US" sz="650" dirty="0"/>
+          </a:p>
+        </p:txBody>
+      </p:sp>
+      <p:sp>
+        <p:nvSpPr>
+          <p:cNvPr id="116" name="Shape 114"/>
+          <p:cNvSpPr/>
+          <p:nvPr/>
+        </p:nvSpPr>
+        <p:spPr>
+          <a:xfrm>
+            <a:off x="7379208" y="3822192"/>
+            <a:ext cx="4197096" cy="10973"/>
+          </a:xfrm>
+          <a:prstGeom prst="rect">
+            <a:avLst/>
+          </a:prstGeom>
+          <a:solidFill>
+            <a:srgbClr val="12293A"/>
+          </a:solidFill>
+          <a:ln/>
+        </p:spPr>
+      </p:sp>
+      <p:sp>
+        <p:nvSpPr>
+          <p:cNvPr id="117" name="Text 115"/>
+          <p:cNvSpPr txBox="1"/>
+          <p:nvPr/>
+        </p:nvSpPr>
+        <p:spPr>
+          <a:xfrm>
+            <a:off x="7379208" y="3849624"/>
+            <a:ext cx="1371600" cy="182880"/>
+          </a:xfrm>
+          <a:prstGeom prst="rect">
+            <a:avLst/>
+          </a:prstGeom>
+          <a:noFill/>
+          <a:ln/>
+        </p:spPr>
+        <p:txBody>
+          <a:bodyPr wrap="square" lIns="0" tIns="0" rIns="0" bIns="0" rtlCol="0" anchor="ctr"/>
+          <a:lstStyle/>
+          <a:p>
+            <a:pPr indent="0" marL="0">
+              <a:buNone/>
+            </a:pPr>
+            <a:r>
+              <a:rPr lang="en-US" sz="850" b="1" dirty="0">
+                <a:solidFill>
+                  <a:srgbClr val="12293A"/>
+                </a:solidFill>
+                <a:latin typeface="Poppins" pitchFamily="34" charset="0"/>
+                <a:ea typeface="Poppins" pitchFamily="34" charset="-122"/>
+                <a:cs typeface="Poppins" pitchFamily="34" charset="-120"/>
+              </a:rPr>
+              <a:t>TOTAL</a:t>
+            </a:r>
+            <a:endParaRPr lang="en-US" sz="850" dirty="0"/>
+          </a:p>
+        </p:txBody>
+      </p:sp>
+      <p:sp>
+        <p:nvSpPr>
+          <p:cNvPr id="118" name="Text 116"/>
+          <p:cNvSpPr txBox="1"/>
+          <p:nvPr/>
+        </p:nvSpPr>
+        <p:spPr>
+          <a:xfrm>
+            <a:off x="8823960" y="3849624"/>
+            <a:ext cx="1371600" cy="182880"/>
+          </a:xfrm>
+          <a:prstGeom prst="rect">
+            <a:avLst/>
+          </a:prstGeom>
+          <a:noFill/>
+          <a:ln/>
+        </p:spPr>
+        <p:txBody>
+          <a:bodyPr wrap="square" lIns="0" tIns="0" rIns="0" bIns="0" rtlCol="0" anchor="ctr"/>
+          <a:lstStyle/>
+          <a:p>
+            <a:pPr indent="0" marL="0">
+              <a:buNone/>
+            </a:pPr>
+            <a:r>
+              <a:rPr lang="en-US" sz="650" dirty="0">
+                <a:solidFill>
+                  <a:srgbClr val="5E7280"/>
+                </a:solidFill>
+                <a:latin typeface="Poppins" pitchFamily="34" charset="0"/>
+                <a:ea typeface="Poppins" pitchFamily="34" charset="-122"/>
+                <a:cs typeface="Poppins" pitchFamily="34" charset="-120"/>
+              </a:rPr>
+              <a:t>13 PS items carry time</a:t>
+            </a:r>
+            <a:endParaRPr lang="en-US" sz="650" dirty="0"/>
+          </a:p>
+        </p:txBody>
+      </p:sp>
+      <p:sp>
+        <p:nvSpPr>
+          <p:cNvPr id="119" name="Text 117"/>
+          <p:cNvSpPr txBox="1"/>
+          <p:nvPr/>
+        </p:nvSpPr>
+        <p:spPr>
+          <a:xfrm>
+            <a:off x="10287000" y="3849624"/>
+            <a:ext cx="640080" cy="182880"/>
+          </a:xfrm>
+          <a:prstGeom prst="rect">
+            <a:avLst/>
+          </a:prstGeom>
+          <a:noFill/>
+          <a:ln/>
+        </p:spPr>
+        <p:txBody>
+          <a:bodyPr wrap="square" lIns="0" tIns="0" rIns="0" bIns="0" rtlCol="0" anchor="ctr"/>
+          <a:lstStyle/>
+          <a:p>
+            <a:pPr algn="r" indent="0" marL="0">
+              <a:buNone/>
+            </a:pPr>
+            <a:r>
+              <a:rPr lang="en-US" sz="900" b="1" dirty="0">
+                <a:solidFill>
+                  <a:srgbClr val="2C8394"/>
+                </a:solidFill>
+                <a:latin typeface="Poppins" pitchFamily="34" charset="0"/>
+                <a:ea typeface="Poppins" pitchFamily="34" charset="-122"/>
+                <a:cs typeface="Poppins" pitchFamily="34" charset="-120"/>
+              </a:rPr>
+              <a:t>16.07h</a:t>
+            </a:r>
+            <a:endParaRPr lang="en-US" sz="900" dirty="0"/>
+          </a:p>
+        </p:txBody>
+      </p:sp>
+      <p:sp>
+        <p:nvSpPr>
+          <p:cNvPr id="120" name="Text 118"/>
+          <p:cNvSpPr txBox="1"/>
+          <p:nvPr/>
+        </p:nvSpPr>
+        <p:spPr>
+          <a:xfrm>
+            <a:off x="10972800" y="3849624"/>
+            <a:ext cx="603504" cy="182880"/>
+          </a:xfrm>
+          <a:prstGeom prst="rect">
+            <a:avLst/>
+          </a:prstGeom>
+          <a:noFill/>
+          <a:ln/>
+        </p:spPr>
+        <p:txBody>
+          <a:bodyPr wrap="square" lIns="0" tIns="0" rIns="0" bIns="0" rtlCol="0" anchor="ctr"/>
+          <a:lstStyle/>
+          <a:p>
+            <a:pPr algn="r" indent="0" marL="0">
+              <a:buNone/>
+            </a:pPr>
+            <a:r>
+              <a:rPr lang="en-US" sz="800" b="1" dirty="0">
+                <a:solidFill>
+                  <a:srgbClr val="5E7280"/>
+                </a:solidFill>
+                <a:latin typeface="Poppins" pitchFamily="34" charset="0"/>
+                <a:ea typeface="Poppins" pitchFamily="34" charset="-122"/>
+                <a:cs typeface="Poppins" pitchFamily="34" charset="-120"/>
+              </a:rPr>
+              <a:t>100%</a:t>
             </a:r>
             <a:endParaRPr lang="en-US" sz="800" dirty="0"/>
-          </a:p>
-        </p:txBody>
-      </p:sp>
-      <p:sp>
-        <p:nvSpPr>
-          <p:cNvPr id="116" name="Text 114"/>
-          <p:cNvSpPr txBox="1"/>
-          <p:nvPr/>
-        </p:nvSpPr>
-        <p:spPr>
-          <a:xfrm>
-            <a:off x="10972800" y="3534156"/>
-            <a:ext cx="603504" cy="196596"/>
-          </a:xfrm>
-          <a:prstGeom prst="rect">
-            <a:avLst/>
-          </a:prstGeom>
-          <a:noFill/>
-          <a:ln/>
-        </p:spPr>
-        <p:txBody>
-          <a:bodyPr wrap="square" lIns="0" tIns="0" rIns="0" bIns="0" rtlCol="0" anchor="ctr"/>
-          <a:lstStyle/>
-          <a:p>
-            <a:pPr algn="r" indent="0" marL="0">
-              <a:buNone/>
-            </a:pPr>
-            <a:r>
-              <a:rPr lang="en-US" sz="650" dirty="0">
-                <a:solidFill>
-                  <a:srgbClr val="8FA1AC"/>
-                </a:solidFill>
-                <a:latin typeface="Poppins" pitchFamily="34" charset="0"/>
-                <a:ea typeface="Poppins" pitchFamily="34" charset="-122"/>
-                <a:cs typeface="Poppins" pitchFamily="34" charset="-120"/>
-              </a:rPr>
-              <a:t>none</a:t>
-            </a:r>
-            <a:endParaRPr lang="en-US" sz="650" dirty="0"/>
-          </a:p>
-        </p:txBody>
-      </p:sp>
-      <p:sp>
-        <p:nvSpPr>
-          <p:cNvPr id="117" name="Text 115"/>
-          <p:cNvSpPr txBox="1"/>
-          <p:nvPr/>
-        </p:nvSpPr>
-        <p:spPr>
-          <a:xfrm>
-            <a:off x="7379208" y="3730752"/>
-            <a:ext cx="1371600" cy="196596"/>
-          </a:xfrm>
-          <a:prstGeom prst="rect">
-            <a:avLst/>
-          </a:prstGeom>
-          <a:noFill/>
-          <a:ln/>
-        </p:spPr>
-        <p:txBody>
-          <a:bodyPr wrap="square" lIns="0" tIns="0" rIns="0" bIns="0" rtlCol="0" anchor="ctr"/>
-          <a:lstStyle/>
-          <a:p>
-            <a:pPr indent="0" marL="0">
-              <a:buNone/>
-            </a:pPr>
-            <a:r>
-              <a:rPr lang="en-US" sz="800" dirty="0">
-                <a:solidFill>
-                  <a:srgbClr val="5E7280"/>
-                </a:solidFill>
-                <a:latin typeface="Poppins" pitchFamily="34" charset="0"/>
-                <a:ea typeface="Poppins" pitchFamily="34" charset="-122"/>
-                <a:cs typeface="Poppins" pitchFamily="34" charset="-120"/>
-              </a:rPr>
-              <a:t>Warranty</a:t>
-            </a:r>
-            <a:endParaRPr lang="en-US" sz="800" dirty="0"/>
-          </a:p>
-        </p:txBody>
-      </p:sp>
-      <p:sp>
-        <p:nvSpPr>
-          <p:cNvPr id="118" name="Shape 116"/>
-          <p:cNvSpPr/>
-          <p:nvPr/>
-        </p:nvSpPr>
-        <p:spPr>
-          <a:xfrm>
-            <a:off x="8823960" y="3799332"/>
-            <a:ext cx="1371600" cy="59436"/>
-          </a:xfrm>
-          <a:prstGeom prst="roundRect">
-            <a:avLst>
-              <a:gd name="adj" fmla="val 49231"/>
-            </a:avLst>
-          </a:prstGeom>
-          <a:solidFill>
-            <a:srgbClr val="E2EAEE"/>
-          </a:solidFill>
-          <a:ln/>
-        </p:spPr>
-      </p:sp>
-      <p:sp>
-        <p:nvSpPr>
-          <p:cNvPr id="119" name="Text 117"/>
-          <p:cNvSpPr txBox="1"/>
-          <p:nvPr/>
-        </p:nvSpPr>
-        <p:spPr>
-          <a:xfrm>
-            <a:off x="10287000" y="3730752"/>
-            <a:ext cx="640080" cy="196596"/>
-          </a:xfrm>
-          <a:prstGeom prst="rect">
-            <a:avLst/>
-          </a:prstGeom>
-          <a:noFill/>
-          <a:ln/>
-        </p:spPr>
-        <p:txBody>
-          <a:bodyPr wrap="square" lIns="0" tIns="0" rIns="0" bIns="0" rtlCol="0" anchor="ctr"/>
-          <a:lstStyle/>
-          <a:p>
-            <a:pPr algn="r" indent="0" marL="0">
-              <a:buNone/>
-            </a:pPr>
-            <a:r>
-              <a:rPr lang="en-US" sz="800" dirty="0">
-                <a:solidFill>
-                  <a:srgbClr val="8FA1AC"/>
-                </a:solidFill>
-                <a:latin typeface="Poppins" pitchFamily="34" charset="0"/>
-                <a:ea typeface="Poppins" pitchFamily="34" charset="-122"/>
-                <a:cs typeface="Poppins" pitchFamily="34" charset="-120"/>
-              </a:rPr>
-              <a:t>—</a:t>
-            </a:r>
-            <a:endParaRPr lang="en-US" sz="800" dirty="0"/>
-          </a:p>
-        </p:txBody>
-      </p:sp>
-      <p:sp>
-        <p:nvSpPr>
-          <p:cNvPr id="120" name="Text 118"/>
-          <p:cNvSpPr txBox="1"/>
-          <p:nvPr/>
-        </p:nvSpPr>
-        <p:spPr>
-          <a:xfrm>
-            <a:off x="10972800" y="3730752"/>
-            <a:ext cx="603504" cy="196596"/>
-          </a:xfrm>
-          <a:prstGeom prst="rect">
-            <a:avLst/>
-          </a:prstGeom>
-          <a:noFill/>
-          <a:ln/>
-        </p:spPr>
-        <p:txBody>
-          <a:bodyPr wrap="square" lIns="0" tIns="0" rIns="0" bIns="0" rtlCol="0" anchor="ctr"/>
-          <a:lstStyle/>
-          <a:p>
-            <a:pPr algn="r" indent="0" marL="0">
-              <a:buNone/>
-            </a:pPr>
-            <a:r>
-              <a:rPr lang="en-US" sz="650" dirty="0">
-                <a:solidFill>
-                  <a:srgbClr val="8FA1AC"/>
-                </a:solidFill>
-                <a:latin typeface="Poppins" pitchFamily="34" charset="0"/>
-                <a:ea typeface="Poppins" pitchFamily="34" charset="-122"/>
-                <a:cs typeface="Poppins" pitchFamily="34" charset="-120"/>
-              </a:rPr>
-              <a:t>none</a:t>
-            </a:r>
-            <a:endParaRPr lang="en-US" sz="650" dirty="0"/>
           </a:p>
         </p:txBody>
       </p:sp>
@@ -49898,7 +49928,7 @@
                 <a:ea typeface="Poppins" pitchFamily="34" charset="-122"/>
                 <a:cs typeface="Poppins" pitchFamily="34" charset="-120"/>
               </a:rPr>
-              <a:t>7.9% billable utilisation is a logging number, not a delivery number. </a:t>
+              <a:t>4.7% billable utilisation is a logging number, not a delivery number. </a:t>
             </a:r>
             <a:pPr indent="0" marL="0">
               <a:spcAft>
@@ -49915,7 +49945,7 @@
                 <a:ea typeface="Poppins" pitchFamily="34" charset="-122"/>
                 <a:cs typeface="Poppins" pitchFamily="34" charset="-120"/>
               </a:rPr>
-              <a:t>33.01h landed against 418h of capacity, but only 13% of the week's 132 PS items carry hours.</a:t>
+              <a:t>16.07h landed against 342h of capacity, but only 10% of the week's 132 PS items carry hours.</a:t>
             </a:r>
             <a:endParaRPr lang="en-US" sz="900" dirty="0"/>
           </a:p>
@@ -49946,7 +49976,7 @@
                 <a:ea typeface="Poppins" pitchFamily="34" charset="-122"/>
                 <a:cs typeface="Poppins" pitchFamily="34" charset="-120"/>
               </a:rPr>
-              <a:t>Two people carry the entire logged total. </a:t>
+              <a:t>One person carries almost the entire logged total. </a:t>
             </a:r>
             <a:pPr indent="0" marL="0">
               <a:spcAft>
@@ -49963,7 +49993,7 @@
                 <a:ea typeface="Poppins" pitchFamily="34" charset="-122"/>
                 <a:cs typeface="Poppins" pitchFamily="34" charset="-120"/>
               </a:rPr>
-              <a:t>Katherine Fenwick 38.2% and Rhys Woolcock 36.4%; the other 5 PS members logged nothing at all.</a:t>
+              <a:t>Rhys Woolcock 13.82h (36.4%) is 86% of the hours; Gregory, Isayah and Joshua logged under 2h each and 5 PS members logged nothing at all.</a:t>
             </a:r>
             <a:endParaRPr lang="en-US" sz="900" dirty="0"/>
           </a:p>
@@ -50011,7 +50041,7 @@
                 <a:ea typeface="Poppins" pitchFamily="34" charset="-122"/>
                 <a:cs typeface="Poppins" pitchFamily="34" charset="-120"/>
               </a:rPr>
-              <a:t>64 PS cases opened this week; Tech carries 95% of logged time. Median time to close since 8 Sep: Tech 0.6 d.</a:t>
+              <a:t>64 PS cases opened this week; Tech carries 99.6% of logged time. Median time to close since 8 Sep: Tech 0.6 d.</a:t>
             </a:r>
             <a:endParaRPr lang="en-US" sz="900" dirty="0"/>
           </a:p>
@@ -50050,7 +50080,7 @@
                 <a:ea typeface="Poppins" pitchFamily="34" charset="-122"/>
                 <a:cs typeface="Poppins" pitchFamily="34" charset="-120"/>
               </a:rPr>
-              <a:t>All logged hours are treated as billable — creatio_non_billable is populated on only 3 of 30 records, so billable/non-billable is not yet separable. 2.44h of the Tech total sits on a record named 'Warranty Test' — worth clearing out.</a:t>
+              <a:t>All logged hours are treated as billable — creatio_non_billable is populated on only 3 of the 30 PS records carrying time, so billable/non-billable is not yet separable.</a:t>
             </a:r>
             <a:endParaRPr lang="en-US" sz="750" dirty="0"/>
           </a:p>

</xml_diff>